<commit_message>
docs: replace deck captures with live website
</commit_message>
<xml_diff>
--- a/docs/submission/credo-deck-professional.pptx
+++ b/docs/submission/credo-deck-professional.pptx
@@ -2,24 +2,24 @@
 <file path=ppt/presentation.xml><?xml version="1.0" encoding="utf-8"?>
 <p:presentation xmlns:p="http://schemas.openxmlformats.org/presentationml/2006/main">
   <p:sldMasterIdLst>
-    <p:sldMasterId xmlns:r="http://schemas.openxmlformats.org/officeDocument/2006/relationships" id="2147483648" r:id="R160e9d2c792b4608"/>
+    <p:sldMasterId xmlns:r="http://schemas.openxmlformats.org/officeDocument/2006/relationships" id="2147483648" r:id="Rff3677b2b78e4b23"/>
   </p:sldMasterIdLst>
   <p:notesMasterIdLst>
-    <p:notesMasterId xmlns:r="http://schemas.openxmlformats.org/officeDocument/2006/relationships" r:id="R0c38560bcdda45b8"/>
+    <p:notesMasterId xmlns:r="http://schemas.openxmlformats.org/officeDocument/2006/relationships" r:id="Rd4cecc322d334690"/>
   </p:notesMasterIdLst>
   <p:sldIdLst>
-    <p:sldId xmlns:r="http://schemas.openxmlformats.org/officeDocument/2006/relationships" id="256" r:id="R52b6f8e031564d01"/>
-    <p:sldId xmlns:r="http://schemas.openxmlformats.org/officeDocument/2006/relationships" id="257" r:id="Rb5781f462e6f4eac"/>
-    <p:sldId xmlns:r="http://schemas.openxmlformats.org/officeDocument/2006/relationships" id="258" r:id="Rc90a19988df74402"/>
-    <p:sldId xmlns:r="http://schemas.openxmlformats.org/officeDocument/2006/relationships" id="259" r:id="R43bc1e3689e544a6"/>
-    <p:sldId xmlns:r="http://schemas.openxmlformats.org/officeDocument/2006/relationships" id="260" r:id="Rd91154c4d19b4359"/>
-    <p:sldId xmlns:r="http://schemas.openxmlformats.org/officeDocument/2006/relationships" id="261" r:id="Radefb1826c4745da"/>
-    <p:sldId xmlns:r="http://schemas.openxmlformats.org/officeDocument/2006/relationships" id="262" r:id="R5872e81efa9a4f2c"/>
-    <p:sldId xmlns:r="http://schemas.openxmlformats.org/officeDocument/2006/relationships" id="263" r:id="R0780f471bf034bca"/>
-    <p:sldId xmlns:r="http://schemas.openxmlformats.org/officeDocument/2006/relationships" id="264" r:id="Rac09a94b261945ad"/>
-    <p:sldId xmlns:r="http://schemas.openxmlformats.org/officeDocument/2006/relationships" id="265" r:id="Rb492e90490624866"/>
-    <p:sldId xmlns:r="http://schemas.openxmlformats.org/officeDocument/2006/relationships" id="266" r:id="R18514185b60148ec"/>
-    <p:sldId xmlns:r="http://schemas.openxmlformats.org/officeDocument/2006/relationships" id="267" r:id="R70d2d034a64c4927"/>
+    <p:sldId xmlns:r="http://schemas.openxmlformats.org/officeDocument/2006/relationships" id="256" r:id="Re6e53064cbcb4c81"/>
+    <p:sldId xmlns:r="http://schemas.openxmlformats.org/officeDocument/2006/relationships" id="257" r:id="Rd3fbf833eeff4324"/>
+    <p:sldId xmlns:r="http://schemas.openxmlformats.org/officeDocument/2006/relationships" id="258" r:id="R295338eee1e64550"/>
+    <p:sldId xmlns:r="http://schemas.openxmlformats.org/officeDocument/2006/relationships" id="259" r:id="R8b1fc1fea5324d3b"/>
+    <p:sldId xmlns:r="http://schemas.openxmlformats.org/officeDocument/2006/relationships" id="260" r:id="R51bca57d7b4148f4"/>
+    <p:sldId xmlns:r="http://schemas.openxmlformats.org/officeDocument/2006/relationships" id="261" r:id="Rb3ff09dc6d174c82"/>
+    <p:sldId xmlns:r="http://schemas.openxmlformats.org/officeDocument/2006/relationships" id="262" r:id="R7ce4d21ec9f0406d"/>
+    <p:sldId xmlns:r="http://schemas.openxmlformats.org/officeDocument/2006/relationships" id="263" r:id="R64792cbcba894f1d"/>
+    <p:sldId xmlns:r="http://schemas.openxmlformats.org/officeDocument/2006/relationships" id="264" r:id="R54f98ffee595461d"/>
+    <p:sldId xmlns:r="http://schemas.openxmlformats.org/officeDocument/2006/relationships" id="265" r:id="Rd82d6a558b604dab"/>
+    <p:sldId xmlns:r="http://schemas.openxmlformats.org/officeDocument/2006/relationships" id="266" r:id="Rccc4cdb0292042e7"/>
+    <p:sldId xmlns:r="http://schemas.openxmlformats.org/officeDocument/2006/relationships" id="267" r:id="R5ff8271231b043c2"/>
   </p:sldIdLst>
   <p:sldSz cx="12192000" cy="6858000"/>
   <p:notesSz cx="6858000" cy="9144000"/>
@@ -463,7 +463,7 @@
           </a:p>
           <a:p xmlns:a="http://schemas.openxmlformats.org/drawingml/2006/main">
             <a:r>
-              <a:t>- Product screenshot: dogfood-output/screenshots/landing-3d-final.png.</a:t>
+              <a:t>- Live product screenshot captured from https://credo.becoder.xyz/ on 26 August 2026.</a:t>
             </a:r>
           </a:p>
         </p:txBody>
@@ -1273,7 +1273,7 @@
           </a:p>
           <a:p xmlns:a="http://schemas.openxmlformats.org/drawingml/2006/main">
             <a:r>
-              <a:t>- dogfood-output/screenshots/playground-desktop.png.</a:t>
+              <a:t>- Live playground screenshot captured from https://credo.becoder.xyz/playground on 26 August 2026.</a:t>
             </a:r>
           </a:p>
           <a:p xmlns:a="http://schemas.openxmlformats.org/drawingml/2006/main">
@@ -1431,7 +1431,7 @@
   </p:cSld>
   <p:clrMap bg1="lt1" tx1="dk1" bg2="lt2" tx2="dk2" accent1="accent1" accent2="accent2" accent3="accent3" accent4="accent4" accent5="accent5" accent6="accent6" hlink="hlink" folHlink="folHlink"/>
   <p:sldLayoutIdLst>
-    <p:sldLayoutId xmlns:r="http://schemas.openxmlformats.org/officeDocument/2006/relationships" id="2147483649" r:id="Rd6d7278e5b7c4604"/>
+    <p:sldLayoutId xmlns:r="http://schemas.openxmlformats.org/officeDocument/2006/relationships" id="2147483649" r:id="Rdb758ec31ad24c56"/>
   </p:sldLayoutIdLst>
   <p:txStyles>
     <p:titleStyle>
@@ -1986,7 +1986,7 @@
           <p:nvPr/>
         </p:nvPicPr>
         <p:blipFill>
-          <a:blip xmlns:r="http://schemas.openxmlformats.org/officeDocument/2006/relationships" xmlns:a="http://schemas.openxmlformats.org/drawingml/2006/main" r:embed="R8f096fb890e547f6"/>
+          <a:blip xmlns:r="http://schemas.openxmlformats.org/officeDocument/2006/relationships" xmlns:a="http://schemas.openxmlformats.org/drawingml/2006/main" r:embed="Rcec0b3d888fb41fe"/>
           <a:stretch xmlns:a="http://schemas.openxmlformats.org/drawingml/2006/main"/>
         </p:blipFill>
         <p:spPr>
@@ -2006,7 +2006,7 @@
           <p:cNvPr id="2" name="">
             <a:extLst xmlns:a="http://schemas.openxmlformats.org/drawingml/2006/main">
               <a:ext uri="{FF2B5EF4-FFF2-40B4-BE49-F238E27FC236}">
-                <a16:creationId xmlns:a16="http://schemas.microsoft.com/office/drawing/2014/main" id="{ED8E4EF8-03B7-4D95-82BF-85336BAB8A5D}"/>
+                <a16:creationId xmlns:a16="http://schemas.microsoft.com/office/drawing/2014/main" id="{71176BF1-61F6-4CF3-8DBD-503D286E41FA}"/>
               </a:ext>
             </a:extLst>
           </p:cNvPr>
@@ -2056,7 +2056,7 @@
           <p:cNvPr id="3" name="">
             <a:extLst xmlns:a="http://schemas.openxmlformats.org/drawingml/2006/main">
               <a:ext uri="{FF2B5EF4-FFF2-40B4-BE49-F238E27FC236}">
-                <a16:creationId xmlns:a16="http://schemas.microsoft.com/office/drawing/2014/main" id="{6C72AD6E-D801-4268-A5AB-3C67F5FA58DC}"/>
+                <a16:creationId xmlns:a16="http://schemas.microsoft.com/office/drawing/2014/main" id="{71965B19-2D9F-4475-9788-73E3A575F616}"/>
               </a:ext>
             </a:extLst>
           </p:cNvPr>
@@ -2123,7 +2123,7 @@
           <p:cNvPr id="4" name="">
             <a:extLst xmlns:a="http://schemas.openxmlformats.org/drawingml/2006/main">
               <a:ext uri="{FF2B5EF4-FFF2-40B4-BE49-F238E27FC236}">
-                <a16:creationId xmlns:a16="http://schemas.microsoft.com/office/drawing/2014/main" id="{5BE75668-B771-432D-83D2-10BDE31DC389}"/>
+                <a16:creationId xmlns:a16="http://schemas.microsoft.com/office/drawing/2014/main" id="{5B901B9D-14B4-45F8-939A-3D6555774282}"/>
               </a:ext>
             </a:extLst>
           </p:cNvPr>
@@ -2173,7 +2173,7 @@
           <p:cNvPr id="5" name="">
             <a:extLst xmlns:a="http://schemas.openxmlformats.org/drawingml/2006/main">
               <a:ext uri="{FF2B5EF4-FFF2-40B4-BE49-F238E27FC236}">
-                <a16:creationId xmlns:a16="http://schemas.microsoft.com/office/drawing/2014/main" id="{1DF68782-BB65-4A0F-AA6B-0D1E2D44FD2B}"/>
+                <a16:creationId xmlns:a16="http://schemas.microsoft.com/office/drawing/2014/main" id="{016997B2-AE73-48B5-B0A2-7B9C508C6134}"/>
               </a:ext>
             </a:extLst>
           </p:cNvPr>
@@ -2206,7 +2206,7 @@
           <p:cNvPr id="6" name="">
             <a:extLst xmlns:a="http://schemas.openxmlformats.org/drawingml/2006/main">
               <a:ext uri="{FF2B5EF4-FFF2-40B4-BE49-F238E27FC236}">
-                <a16:creationId xmlns:a16="http://schemas.microsoft.com/office/drawing/2014/main" id="{B0C18183-C660-4D33-83F9-075E64D51CCB}"/>
+                <a16:creationId xmlns:a16="http://schemas.microsoft.com/office/drawing/2014/main" id="{0F8AA029-8800-4378-87E1-2D72A1F31548}"/>
               </a:ext>
             </a:extLst>
           </p:cNvPr>
@@ -2260,17 +2260,17 @@
           <p:nvPr/>
         </p:nvPicPr>
         <p:blipFill>
-          <a:blip xmlns:r="http://schemas.openxmlformats.org/officeDocument/2006/relationships" xmlns:a="http://schemas.openxmlformats.org/drawingml/2006/main" r:embed="Rb35f75ab2753428c"/>
+          <a:blip xmlns:r="http://schemas.openxmlformats.org/officeDocument/2006/relationships" xmlns:a="http://schemas.openxmlformats.org/drawingml/2006/main" r:embed="R1ea6e8a36e684cf5"/>
           <a:stretch xmlns:a="http://schemas.openxmlformats.org/drawingml/2006/main"/>
         </p:blipFill>
         <p:spPr>
           <a:xfrm xmlns:a="http://schemas.openxmlformats.org/drawingml/2006/main">
-            <a:off x="7410450" y="1759744"/>
-            <a:ext cx="4286250" cy="2976563"/>
+            <a:off x="7029450" y="2033777"/>
+            <a:ext cx="4762500" cy="2142746"/>
           </a:xfrm>
           <a:prstGeom xmlns:a="http://schemas.openxmlformats.org/drawingml/2006/main" prst="roundRect">
             <a:avLst>
-              <a:gd name="adj" fmla="val 2667"/>
+              <a:gd name="adj" fmla="val 4000"/>
             </a:avLst>
           </a:prstGeom>
         </p:spPr>
@@ -2280,7 +2280,7 @@
           <p:cNvPr id="8" name="">
             <a:extLst xmlns:a="http://schemas.openxmlformats.org/drawingml/2006/main">
               <a:ext uri="{FF2B5EF4-FFF2-40B4-BE49-F238E27FC236}">
-                <a16:creationId xmlns:a16="http://schemas.microsoft.com/office/drawing/2014/main" id="{376937FF-E077-4A28-97B9-16A6F1C1E58F}"/>
+                <a16:creationId xmlns:a16="http://schemas.microsoft.com/office/drawing/2014/main" id="{982BCCAE-0F6C-4F67-9E92-0E8662E1623C}"/>
               </a:ext>
             </a:extLst>
           </p:cNvPr>
@@ -2330,7 +2330,7 @@
           <p:cNvPr id="9" name="">
             <a:extLst xmlns:a="http://schemas.openxmlformats.org/drawingml/2006/main">
               <a:ext uri="{FF2B5EF4-FFF2-40B4-BE49-F238E27FC236}">
-                <a16:creationId xmlns:a16="http://schemas.microsoft.com/office/drawing/2014/main" id="{18F2A79F-D842-4714-9066-6D3486C87795}"/>
+                <a16:creationId xmlns:a16="http://schemas.microsoft.com/office/drawing/2014/main" id="{90A470BD-FA8F-4D0E-BF8F-621ACD32B243}"/>
               </a:ext>
             </a:extLst>
           </p:cNvPr>
@@ -2378,7 +2378,7 @@
     </p:spTree>
     <p:extLst>
       <p:ext uri="{BB962C8B-B14F-4D97-AF65-F5344CB8AC3E}">
-        <p14:creationId xmlns:p14="http://schemas.microsoft.com/office/powerpoint/2010/main" val="1020190541"/>
+        <p14:creationId xmlns:p14="http://schemas.microsoft.com/office/powerpoint/2010/main" val="1401059571"/>
       </p:ext>
     </p:extLst>
   </p:cSld>
@@ -2409,7 +2409,7 @@
           <p:cNvPr id="22" name="">
             <a:extLst xmlns:a="http://schemas.openxmlformats.org/drawingml/2006/main">
               <a:ext uri="{FF2B5EF4-FFF2-40B4-BE49-F238E27FC236}">
-                <a16:creationId xmlns:a16="http://schemas.microsoft.com/office/drawing/2014/main" id="{4CB0D0D3-8126-4AEB-AB7D-7CB5CD20F0C9}"/>
+                <a16:creationId xmlns:a16="http://schemas.microsoft.com/office/drawing/2014/main" id="{56F37E4E-FE22-4E29-9943-DA8BE46742B6}"/>
               </a:ext>
             </a:extLst>
           </p:cNvPr>
@@ -2459,7 +2459,7 @@
           <p:cNvPr id="2" name="">
             <a:extLst xmlns:a="http://schemas.openxmlformats.org/drawingml/2006/main">
               <a:ext uri="{FF2B5EF4-FFF2-40B4-BE49-F238E27FC236}">
-                <a16:creationId xmlns:a16="http://schemas.microsoft.com/office/drawing/2014/main" id="{15789B8C-A40A-4DE2-9801-DF08A10FA533}"/>
+                <a16:creationId xmlns:a16="http://schemas.microsoft.com/office/drawing/2014/main" id="{B7143F49-B015-4F07-B881-8746DCAA6981}"/>
               </a:ext>
             </a:extLst>
           </p:cNvPr>
@@ -2509,7 +2509,7 @@
           <p:cNvPr id="3" name="">
             <a:extLst xmlns:a="http://schemas.openxmlformats.org/drawingml/2006/main">
               <a:ext uri="{FF2B5EF4-FFF2-40B4-BE49-F238E27FC236}">
-                <a16:creationId xmlns:a16="http://schemas.microsoft.com/office/drawing/2014/main" id="{23CE3713-79DF-47C7-B746-DABB9D147F77}"/>
+                <a16:creationId xmlns:a16="http://schemas.microsoft.com/office/drawing/2014/main" id="{AD7C3DBC-0CDA-4767-AC26-A06F5D142ED6}"/>
               </a:ext>
             </a:extLst>
           </p:cNvPr>
@@ -2542,7 +2542,7 @@
           <p:cNvPr id="4" name="">
             <a:extLst xmlns:a="http://schemas.openxmlformats.org/drawingml/2006/main">
               <a:ext uri="{FF2B5EF4-FFF2-40B4-BE49-F238E27FC236}">
-                <a16:creationId xmlns:a16="http://schemas.microsoft.com/office/drawing/2014/main" id="{5E05391C-C521-4F4D-8743-E7F96C24245B}"/>
+                <a16:creationId xmlns:a16="http://schemas.microsoft.com/office/drawing/2014/main" id="{28D0EF1F-62E4-4B37-907D-21AF3F180661}"/>
               </a:ext>
             </a:extLst>
           </p:cNvPr>
@@ -2592,7 +2592,7 @@
           <p:cNvPr id="5" name="">
             <a:extLst xmlns:a="http://schemas.openxmlformats.org/drawingml/2006/main">
               <a:ext uri="{FF2B5EF4-FFF2-40B4-BE49-F238E27FC236}">
-                <a16:creationId xmlns:a16="http://schemas.microsoft.com/office/drawing/2014/main" id="{20147B1D-35CB-4EAE-ACF9-8D66E0A28964}"/>
+                <a16:creationId xmlns:a16="http://schemas.microsoft.com/office/drawing/2014/main" id="{38E6A302-B050-45E3-A47A-DA2D48167194}"/>
               </a:ext>
             </a:extLst>
           </p:cNvPr>
@@ -2642,7 +2642,7 @@
           <p:cNvPr id="6" name="">
             <a:extLst xmlns:a="http://schemas.openxmlformats.org/drawingml/2006/main">
               <a:ext uri="{FF2B5EF4-FFF2-40B4-BE49-F238E27FC236}">
-                <a16:creationId xmlns:a16="http://schemas.microsoft.com/office/drawing/2014/main" id="{8735122A-C368-432A-8BEF-4299E4FD492D}"/>
+                <a16:creationId xmlns:a16="http://schemas.microsoft.com/office/drawing/2014/main" id="{0F6EB00A-607D-4E8D-8321-7D1AF380AAB6}"/>
               </a:ext>
             </a:extLst>
           </p:cNvPr>
@@ -2692,7 +2692,7 @@
           <p:cNvPr id="7" name="">
             <a:extLst xmlns:a="http://schemas.openxmlformats.org/drawingml/2006/main">
               <a:ext uri="{FF2B5EF4-FFF2-40B4-BE49-F238E27FC236}">
-                <a16:creationId xmlns:a16="http://schemas.microsoft.com/office/drawing/2014/main" id="{626D94DE-158E-4E60-BC6F-44D49840EFED}"/>
+                <a16:creationId xmlns:a16="http://schemas.microsoft.com/office/drawing/2014/main" id="{E65551F1-0EE3-4D78-AF18-B1B5EB301C14}"/>
               </a:ext>
             </a:extLst>
           </p:cNvPr>
@@ -2742,7 +2742,7 @@
           <p:cNvPr id="8" name="">
             <a:extLst xmlns:a="http://schemas.openxmlformats.org/drawingml/2006/main">
               <a:ext uri="{FF2B5EF4-FFF2-40B4-BE49-F238E27FC236}">
-                <a16:creationId xmlns:a16="http://schemas.microsoft.com/office/drawing/2014/main" id="{80B4BACA-085B-469D-A1F0-94F70D449A2F}"/>
+                <a16:creationId xmlns:a16="http://schemas.microsoft.com/office/drawing/2014/main" id="{EC8277A8-B398-4DAC-9588-2AF1EEA91DD5}"/>
               </a:ext>
             </a:extLst>
           </p:cNvPr>
@@ -2792,7 +2792,7 @@
           <p:cNvPr id="9" name="">
             <a:extLst xmlns:a="http://schemas.openxmlformats.org/drawingml/2006/main">
               <a:ext uri="{FF2B5EF4-FFF2-40B4-BE49-F238E27FC236}">
-                <a16:creationId xmlns:a16="http://schemas.microsoft.com/office/drawing/2014/main" id="{2B5AE3CD-0B55-42A2-999A-C51E0FAD2CED}"/>
+                <a16:creationId xmlns:a16="http://schemas.microsoft.com/office/drawing/2014/main" id="{B70E7474-A419-4E2C-8E9A-154DA636D27F}"/>
               </a:ext>
             </a:extLst>
           </p:cNvPr>
@@ -2842,7 +2842,7 @@
           <p:cNvPr id="10" name="">
             <a:extLst xmlns:a="http://schemas.openxmlformats.org/drawingml/2006/main">
               <a:ext uri="{FF2B5EF4-FFF2-40B4-BE49-F238E27FC236}">
-                <a16:creationId xmlns:a16="http://schemas.microsoft.com/office/drawing/2014/main" id="{CA8BC6AC-B0B0-4487-8838-09D9FAF46952}"/>
+                <a16:creationId xmlns:a16="http://schemas.microsoft.com/office/drawing/2014/main" id="{D0F76DBF-51F3-4565-B926-C224E3582B10}"/>
               </a:ext>
             </a:extLst>
           </p:cNvPr>
@@ -2892,7 +2892,7 @@
           <p:cNvPr id="11" name="">
             <a:extLst xmlns:a="http://schemas.openxmlformats.org/drawingml/2006/main">
               <a:ext uri="{FF2B5EF4-FFF2-40B4-BE49-F238E27FC236}">
-                <a16:creationId xmlns:a16="http://schemas.microsoft.com/office/drawing/2014/main" id="{33FFF5B3-C83C-4FB7-A4AB-4808E44CBBB9}"/>
+                <a16:creationId xmlns:a16="http://schemas.microsoft.com/office/drawing/2014/main" id="{1650C35B-58C5-44EF-B7BD-FA8233327C23}"/>
               </a:ext>
             </a:extLst>
           </p:cNvPr>
@@ -2942,7 +2942,7 @@
           <p:cNvPr id="12" name="">
             <a:extLst xmlns:a="http://schemas.openxmlformats.org/drawingml/2006/main">
               <a:ext uri="{FF2B5EF4-FFF2-40B4-BE49-F238E27FC236}">
-                <a16:creationId xmlns:a16="http://schemas.microsoft.com/office/drawing/2014/main" id="{CDDB63DD-5F7C-4879-9B5A-539BADBF7809}"/>
+                <a16:creationId xmlns:a16="http://schemas.microsoft.com/office/drawing/2014/main" id="{2561B0B9-0700-4C08-A600-EE7852DC63DC}"/>
               </a:ext>
             </a:extLst>
           </p:cNvPr>
@@ -2992,7 +2992,7 @@
           <p:cNvPr id="13" name="">
             <a:extLst xmlns:a="http://schemas.openxmlformats.org/drawingml/2006/main">
               <a:ext uri="{FF2B5EF4-FFF2-40B4-BE49-F238E27FC236}">
-                <a16:creationId xmlns:a16="http://schemas.microsoft.com/office/drawing/2014/main" id="{EE8DE567-37F3-4ED5-9BB7-7587FF1AE25B}"/>
+                <a16:creationId xmlns:a16="http://schemas.microsoft.com/office/drawing/2014/main" id="{B1D8C773-3E65-4753-97D3-ADA755FDA5FC}"/>
               </a:ext>
             </a:extLst>
           </p:cNvPr>
@@ -3042,7 +3042,7 @@
           <p:cNvPr id="14" name="">
             <a:extLst xmlns:a="http://schemas.openxmlformats.org/drawingml/2006/main">
               <a:ext uri="{FF2B5EF4-FFF2-40B4-BE49-F238E27FC236}">
-                <a16:creationId xmlns:a16="http://schemas.microsoft.com/office/drawing/2014/main" id="{3AEAECF7-682E-4512-A722-6EA2E31EBEFD}"/>
+                <a16:creationId xmlns:a16="http://schemas.microsoft.com/office/drawing/2014/main" id="{6ED27F3B-53AC-4759-AA3A-1D01B2EB56F7}"/>
               </a:ext>
             </a:extLst>
           </p:cNvPr>
@@ -3092,7 +3092,7 @@
           <p:cNvPr id="15" name="">
             <a:extLst xmlns:a="http://schemas.openxmlformats.org/drawingml/2006/main">
               <a:ext uri="{FF2B5EF4-FFF2-40B4-BE49-F238E27FC236}">
-                <a16:creationId xmlns:a16="http://schemas.microsoft.com/office/drawing/2014/main" id="{90C70295-9648-44F8-B766-464CC315A443}"/>
+                <a16:creationId xmlns:a16="http://schemas.microsoft.com/office/drawing/2014/main" id="{9A415EE8-57BB-463C-8A37-2FE78A65CDAD}"/>
               </a:ext>
             </a:extLst>
           </p:cNvPr>
@@ -3142,7 +3142,7 @@
           <p:cNvPr id="16" name="">
             <a:extLst xmlns:a="http://schemas.openxmlformats.org/drawingml/2006/main">
               <a:ext uri="{FF2B5EF4-FFF2-40B4-BE49-F238E27FC236}">
-                <a16:creationId xmlns:a16="http://schemas.microsoft.com/office/drawing/2014/main" id="{89C95024-44BB-4AC1-9AEC-8A71C877D8D3}"/>
+                <a16:creationId xmlns:a16="http://schemas.microsoft.com/office/drawing/2014/main" id="{061AAED9-E351-4060-B8E5-4B96A6A0F67A}"/>
               </a:ext>
             </a:extLst>
           </p:cNvPr>
@@ -3192,7 +3192,7 @@
           <p:cNvPr id="17" name="">
             <a:extLst xmlns:a="http://schemas.openxmlformats.org/drawingml/2006/main">
               <a:ext uri="{FF2B5EF4-FFF2-40B4-BE49-F238E27FC236}">
-                <a16:creationId xmlns:a16="http://schemas.microsoft.com/office/drawing/2014/main" id="{543ED232-2A99-4F8B-8738-31CD432766E1}"/>
+                <a16:creationId xmlns:a16="http://schemas.microsoft.com/office/drawing/2014/main" id="{04424473-12F1-44B7-94EB-BEED81FBFEDA}"/>
               </a:ext>
             </a:extLst>
           </p:cNvPr>
@@ -3242,7 +3242,7 @@
           <p:cNvPr id="18" name="">
             <a:extLst xmlns:a="http://schemas.openxmlformats.org/drawingml/2006/main">
               <a:ext uri="{FF2B5EF4-FFF2-40B4-BE49-F238E27FC236}">
-                <a16:creationId xmlns:a16="http://schemas.microsoft.com/office/drawing/2014/main" id="{29344FBE-0EBF-48D4-B4D7-DEADC7B75667}"/>
+                <a16:creationId xmlns:a16="http://schemas.microsoft.com/office/drawing/2014/main" id="{57E38C77-4544-4C16-9B08-1862FB5FDEC6}"/>
               </a:ext>
             </a:extLst>
           </p:cNvPr>
@@ -3292,7 +3292,7 @@
           <p:cNvPr id="19" name="">
             <a:extLst xmlns:a="http://schemas.openxmlformats.org/drawingml/2006/main">
               <a:ext uri="{FF2B5EF4-FFF2-40B4-BE49-F238E27FC236}">
-                <a16:creationId xmlns:a16="http://schemas.microsoft.com/office/drawing/2014/main" id="{25D72B18-9748-4B1F-85C6-86388BF75939}"/>
+                <a16:creationId xmlns:a16="http://schemas.microsoft.com/office/drawing/2014/main" id="{59EACA24-0A3F-409C-B453-20EDA92E7AFC}"/>
               </a:ext>
             </a:extLst>
           </p:cNvPr>
@@ -3325,7 +3325,7 @@
           <p:cNvPr id="20" name="">
             <a:extLst xmlns:a="http://schemas.openxmlformats.org/drawingml/2006/main">
               <a:ext uri="{FF2B5EF4-FFF2-40B4-BE49-F238E27FC236}">
-                <a16:creationId xmlns:a16="http://schemas.microsoft.com/office/drawing/2014/main" id="{6477A562-74BD-40B6-8959-5D5EDB5E5823}"/>
+                <a16:creationId xmlns:a16="http://schemas.microsoft.com/office/drawing/2014/main" id="{9B084514-2F63-466F-8AB5-58CCF7F5FC89}"/>
               </a:ext>
             </a:extLst>
           </p:cNvPr>
@@ -3375,7 +3375,7 @@
           <p:cNvPr id="21" name="">
             <a:extLst xmlns:a="http://schemas.openxmlformats.org/drawingml/2006/main">
               <a:ext uri="{FF2B5EF4-FFF2-40B4-BE49-F238E27FC236}">
-                <a16:creationId xmlns:a16="http://schemas.microsoft.com/office/drawing/2014/main" id="{C487F3A3-5DDC-46D9-AFAB-4A0AA748ED85}"/>
+                <a16:creationId xmlns:a16="http://schemas.microsoft.com/office/drawing/2014/main" id="{B09C2A38-A225-4BB5-8D11-88CFAAD7B811}"/>
               </a:ext>
             </a:extLst>
           </p:cNvPr>
@@ -3423,7 +3423,7 @@
     </p:spTree>
     <p:extLst>
       <p:ext uri="{BB962C8B-B14F-4D97-AF65-F5344CB8AC3E}">
-        <p14:creationId xmlns:p14="http://schemas.microsoft.com/office/powerpoint/2010/main" val="1463646913"/>
+        <p14:creationId xmlns:p14="http://schemas.microsoft.com/office/powerpoint/2010/main" val="638903592"/>
       </p:ext>
     </p:extLst>
   </p:cSld>
@@ -3454,7 +3454,7 @@
           <p:cNvPr id="27" name="">
             <a:extLst xmlns:a="http://schemas.openxmlformats.org/drawingml/2006/main">
               <a:ext uri="{FF2B5EF4-FFF2-40B4-BE49-F238E27FC236}">
-                <a16:creationId xmlns:a16="http://schemas.microsoft.com/office/drawing/2014/main" id="{94BC9758-4830-45BC-8795-5C22419919E8}"/>
+                <a16:creationId xmlns:a16="http://schemas.microsoft.com/office/drawing/2014/main" id="{169C6BA9-9320-45AB-800C-470B0703D95E}"/>
               </a:ext>
             </a:extLst>
           </p:cNvPr>
@@ -3504,7 +3504,7 @@
           <p:cNvPr id="2" name="">
             <a:extLst xmlns:a="http://schemas.openxmlformats.org/drawingml/2006/main">
               <a:ext uri="{FF2B5EF4-FFF2-40B4-BE49-F238E27FC236}">
-                <a16:creationId xmlns:a16="http://schemas.microsoft.com/office/drawing/2014/main" id="{081CB84A-C077-46D7-A99E-1362CF72D5F1}"/>
+                <a16:creationId xmlns:a16="http://schemas.microsoft.com/office/drawing/2014/main" id="{52E505DD-B84A-4198-B372-D87D75101BD8}"/>
               </a:ext>
             </a:extLst>
           </p:cNvPr>
@@ -3554,7 +3554,7 @@
           <p:cNvPr id="3" name="">
             <a:extLst xmlns:a="http://schemas.openxmlformats.org/drawingml/2006/main">
               <a:ext uri="{FF2B5EF4-FFF2-40B4-BE49-F238E27FC236}">
-                <a16:creationId xmlns:a16="http://schemas.microsoft.com/office/drawing/2014/main" id="{D25A4DFB-7CB9-46C0-BAC4-41A6BBFD5B67}"/>
+                <a16:creationId xmlns:a16="http://schemas.microsoft.com/office/drawing/2014/main" id="{570227C2-88F0-4ACD-9D97-A91C3D11AA5C}"/>
               </a:ext>
             </a:extLst>
           </p:cNvPr>
@@ -3587,7 +3587,7 @@
           <p:cNvPr id="4" name="">
             <a:extLst xmlns:a="http://schemas.openxmlformats.org/drawingml/2006/main">
               <a:ext uri="{FF2B5EF4-FFF2-40B4-BE49-F238E27FC236}">
-                <a16:creationId xmlns:a16="http://schemas.microsoft.com/office/drawing/2014/main" id="{ACB2AD4D-7531-4886-B0CB-B8A1EE6687E0}"/>
+                <a16:creationId xmlns:a16="http://schemas.microsoft.com/office/drawing/2014/main" id="{BFD94748-3521-4D49-928A-37B84C39ACFF}"/>
               </a:ext>
             </a:extLst>
           </p:cNvPr>
@@ -3637,7 +3637,7 @@
           <p:cNvPr id="5" name="">
             <a:extLst xmlns:a="http://schemas.openxmlformats.org/drawingml/2006/main">
               <a:ext uri="{FF2B5EF4-FFF2-40B4-BE49-F238E27FC236}">
-                <a16:creationId xmlns:a16="http://schemas.microsoft.com/office/drawing/2014/main" id="{2E9F5D79-7018-4AE7-A3A5-85E7EF4CC88D}"/>
+                <a16:creationId xmlns:a16="http://schemas.microsoft.com/office/drawing/2014/main" id="{38D4CACC-61D3-4309-B9DB-1635FA21959B}"/>
               </a:ext>
             </a:extLst>
           </p:cNvPr>
@@ -3687,7 +3687,7 @@
           <p:cNvPr id="6" name="">
             <a:extLst xmlns:a="http://schemas.openxmlformats.org/drawingml/2006/main">
               <a:ext uri="{FF2B5EF4-FFF2-40B4-BE49-F238E27FC236}">
-                <a16:creationId xmlns:a16="http://schemas.microsoft.com/office/drawing/2014/main" id="{F3C298E7-8080-4C36-AA02-E040776814A0}"/>
+                <a16:creationId xmlns:a16="http://schemas.microsoft.com/office/drawing/2014/main" id="{CD688704-02F6-403C-890A-CC671403132B}"/>
               </a:ext>
             </a:extLst>
           </p:cNvPr>
@@ -3737,7 +3737,7 @@
           <p:cNvPr id="7" name="">
             <a:extLst xmlns:a="http://schemas.openxmlformats.org/drawingml/2006/main">
               <a:ext uri="{FF2B5EF4-FFF2-40B4-BE49-F238E27FC236}">
-                <a16:creationId xmlns:a16="http://schemas.microsoft.com/office/drawing/2014/main" id="{6EE5ABFE-40AE-45BB-A778-46F3AE14EE9C}"/>
+                <a16:creationId xmlns:a16="http://schemas.microsoft.com/office/drawing/2014/main" id="{A7B1D6EA-C457-466C-AC00-26A270658D8E}"/>
               </a:ext>
             </a:extLst>
           </p:cNvPr>
@@ -3770,7 +3770,7 @@
           <p:cNvPr id="8" name="">
             <a:extLst xmlns:a="http://schemas.openxmlformats.org/drawingml/2006/main">
               <a:ext uri="{FF2B5EF4-FFF2-40B4-BE49-F238E27FC236}">
-                <a16:creationId xmlns:a16="http://schemas.microsoft.com/office/drawing/2014/main" id="{13A3001B-AEE9-4EC5-8759-2005FFBEF5B6}"/>
+                <a16:creationId xmlns:a16="http://schemas.microsoft.com/office/drawing/2014/main" id="{DEBF4BB1-92C4-47CD-8BD3-B49EEEAB5BE2}"/>
               </a:ext>
             </a:extLst>
           </p:cNvPr>
@@ -3820,7 +3820,7 @@
           <p:cNvPr id="9" name="">
             <a:extLst xmlns:a="http://schemas.openxmlformats.org/drawingml/2006/main">
               <a:ext uri="{FF2B5EF4-FFF2-40B4-BE49-F238E27FC236}">
-                <a16:creationId xmlns:a16="http://schemas.microsoft.com/office/drawing/2014/main" id="{F993A7EF-925B-46C0-BA0A-495F28B08E9D}"/>
+                <a16:creationId xmlns:a16="http://schemas.microsoft.com/office/drawing/2014/main" id="{38CFA710-DEB6-4719-B165-01793A7AD39D}"/>
               </a:ext>
             </a:extLst>
           </p:cNvPr>
@@ -3870,7 +3870,7 @@
           <p:cNvPr id="10" name="">
             <a:extLst xmlns:a="http://schemas.openxmlformats.org/drawingml/2006/main">
               <a:ext uri="{FF2B5EF4-FFF2-40B4-BE49-F238E27FC236}">
-                <a16:creationId xmlns:a16="http://schemas.microsoft.com/office/drawing/2014/main" id="{31E0ED19-588B-4E6C-B1CE-7EF5C341FF3C}"/>
+                <a16:creationId xmlns:a16="http://schemas.microsoft.com/office/drawing/2014/main" id="{7DE36DC1-7B90-42EC-8850-8EDD3F30F761}"/>
               </a:ext>
             </a:extLst>
           </p:cNvPr>
@@ -3920,7 +3920,7 @@
           <p:cNvPr id="11" name="">
             <a:extLst xmlns:a="http://schemas.openxmlformats.org/drawingml/2006/main">
               <a:ext uri="{FF2B5EF4-FFF2-40B4-BE49-F238E27FC236}">
-                <a16:creationId xmlns:a16="http://schemas.microsoft.com/office/drawing/2014/main" id="{0C11C96C-1D02-4068-AAA5-72943FAD2B40}"/>
+                <a16:creationId xmlns:a16="http://schemas.microsoft.com/office/drawing/2014/main" id="{D0258B2F-CD59-427C-983B-4FC23ED630AE}"/>
               </a:ext>
             </a:extLst>
           </p:cNvPr>
@@ -3953,7 +3953,7 @@
           <p:cNvPr id="12" name="">
             <a:extLst xmlns:a="http://schemas.openxmlformats.org/drawingml/2006/main">
               <a:ext uri="{FF2B5EF4-FFF2-40B4-BE49-F238E27FC236}">
-                <a16:creationId xmlns:a16="http://schemas.microsoft.com/office/drawing/2014/main" id="{34EABC12-8CEC-4D00-9D0D-D5791B353501}"/>
+                <a16:creationId xmlns:a16="http://schemas.microsoft.com/office/drawing/2014/main" id="{F114588A-E8E2-4943-B1B6-B0C54F1304AA}"/>
               </a:ext>
             </a:extLst>
           </p:cNvPr>
@@ -4003,7 +4003,7 @@
           <p:cNvPr id="13" name="">
             <a:extLst xmlns:a="http://schemas.openxmlformats.org/drawingml/2006/main">
               <a:ext uri="{FF2B5EF4-FFF2-40B4-BE49-F238E27FC236}">
-                <a16:creationId xmlns:a16="http://schemas.microsoft.com/office/drawing/2014/main" id="{37F06425-3013-4095-A1B2-0C8E25CB3BFA}"/>
+                <a16:creationId xmlns:a16="http://schemas.microsoft.com/office/drawing/2014/main" id="{D7ACDA84-7CDA-481D-8B47-2ADC5BA56A38}"/>
               </a:ext>
             </a:extLst>
           </p:cNvPr>
@@ -4053,7 +4053,7 @@
           <p:cNvPr id="14" name="">
             <a:extLst xmlns:a="http://schemas.openxmlformats.org/drawingml/2006/main">
               <a:ext uri="{FF2B5EF4-FFF2-40B4-BE49-F238E27FC236}">
-                <a16:creationId xmlns:a16="http://schemas.microsoft.com/office/drawing/2014/main" id="{CA6F9C67-B88E-408C-9483-13F68175AC6A}"/>
+                <a16:creationId xmlns:a16="http://schemas.microsoft.com/office/drawing/2014/main" id="{249A3AAF-812F-4B0C-BDC1-BF9CA4D7354F}"/>
               </a:ext>
             </a:extLst>
           </p:cNvPr>
@@ -4103,7 +4103,7 @@
           <p:cNvPr id="15" name="">
             <a:extLst xmlns:a="http://schemas.openxmlformats.org/drawingml/2006/main">
               <a:ext uri="{FF2B5EF4-FFF2-40B4-BE49-F238E27FC236}">
-                <a16:creationId xmlns:a16="http://schemas.microsoft.com/office/drawing/2014/main" id="{C2BB1AD6-FAE5-4F7C-9DFF-C8B5135FB9E8}"/>
+                <a16:creationId xmlns:a16="http://schemas.microsoft.com/office/drawing/2014/main" id="{5134D77E-82B6-44BA-AA0E-1280BE2313B8}"/>
               </a:ext>
             </a:extLst>
           </p:cNvPr>
@@ -4136,7 +4136,7 @@
           <p:cNvPr id="16" name="">
             <a:extLst xmlns:a="http://schemas.openxmlformats.org/drawingml/2006/main">
               <a:ext uri="{FF2B5EF4-FFF2-40B4-BE49-F238E27FC236}">
-                <a16:creationId xmlns:a16="http://schemas.microsoft.com/office/drawing/2014/main" id="{F42E53AD-43C5-48B2-8FE6-A9C97A02CEC5}"/>
+                <a16:creationId xmlns:a16="http://schemas.microsoft.com/office/drawing/2014/main" id="{D36D474F-2681-466F-A56B-DB5A42F449E7}"/>
               </a:ext>
             </a:extLst>
           </p:cNvPr>
@@ -4186,7 +4186,7 @@
           <p:cNvPr id="17" name="">
             <a:extLst xmlns:a="http://schemas.openxmlformats.org/drawingml/2006/main">
               <a:ext uri="{FF2B5EF4-FFF2-40B4-BE49-F238E27FC236}">
-                <a16:creationId xmlns:a16="http://schemas.microsoft.com/office/drawing/2014/main" id="{DE964B78-D7FB-4AD9-8717-DAFF44DB10F2}"/>
+                <a16:creationId xmlns:a16="http://schemas.microsoft.com/office/drawing/2014/main" id="{2098933F-7939-43CD-8686-B4C2A5041D60}"/>
               </a:ext>
             </a:extLst>
           </p:cNvPr>
@@ -4236,7 +4236,7 @@
           <p:cNvPr id="18" name="">
             <a:extLst xmlns:a="http://schemas.openxmlformats.org/drawingml/2006/main">
               <a:ext uri="{FF2B5EF4-FFF2-40B4-BE49-F238E27FC236}">
-                <a16:creationId xmlns:a16="http://schemas.microsoft.com/office/drawing/2014/main" id="{688CE1C7-41CF-4AEC-B3A1-AAED4EAB8E0D}"/>
+                <a16:creationId xmlns:a16="http://schemas.microsoft.com/office/drawing/2014/main" id="{C9E1F057-697F-4C4A-A29B-3E8A7C1F1229}"/>
               </a:ext>
             </a:extLst>
           </p:cNvPr>
@@ -4286,7 +4286,7 @@
           <p:cNvPr id="19" name="">
             <a:extLst xmlns:a="http://schemas.openxmlformats.org/drawingml/2006/main">
               <a:ext uri="{FF2B5EF4-FFF2-40B4-BE49-F238E27FC236}">
-                <a16:creationId xmlns:a16="http://schemas.microsoft.com/office/drawing/2014/main" id="{8567BBEE-75EF-42F0-BA6C-03763C2CEBD3}"/>
+                <a16:creationId xmlns:a16="http://schemas.microsoft.com/office/drawing/2014/main" id="{E3A14725-5DD5-4093-90BC-79ACC6389BB1}"/>
               </a:ext>
             </a:extLst>
           </p:cNvPr>
@@ -4319,7 +4319,7 @@
           <p:cNvPr id="20" name="">
             <a:extLst xmlns:a="http://schemas.openxmlformats.org/drawingml/2006/main">
               <a:ext uri="{FF2B5EF4-FFF2-40B4-BE49-F238E27FC236}">
-                <a16:creationId xmlns:a16="http://schemas.microsoft.com/office/drawing/2014/main" id="{E3EDF0E5-1C3E-493F-93D1-CEACF53978E0}"/>
+                <a16:creationId xmlns:a16="http://schemas.microsoft.com/office/drawing/2014/main" id="{0C2474EF-5635-45F7-8B37-C2C7D5DBD272}"/>
               </a:ext>
             </a:extLst>
           </p:cNvPr>
@@ -4369,7 +4369,7 @@
           <p:cNvPr id="21" name="">
             <a:extLst xmlns:a="http://schemas.openxmlformats.org/drawingml/2006/main">
               <a:ext uri="{FF2B5EF4-FFF2-40B4-BE49-F238E27FC236}">
-                <a16:creationId xmlns:a16="http://schemas.microsoft.com/office/drawing/2014/main" id="{3DDB8479-1144-4472-A113-729758F06D7D}"/>
+                <a16:creationId xmlns:a16="http://schemas.microsoft.com/office/drawing/2014/main" id="{991100BD-F0CF-49A1-81F4-6FE6ED438242}"/>
               </a:ext>
             </a:extLst>
           </p:cNvPr>
@@ -4419,7 +4419,7 @@
           <p:cNvPr id="22" name="">
             <a:extLst xmlns:a="http://schemas.openxmlformats.org/drawingml/2006/main">
               <a:ext uri="{FF2B5EF4-FFF2-40B4-BE49-F238E27FC236}">
-                <a16:creationId xmlns:a16="http://schemas.microsoft.com/office/drawing/2014/main" id="{792A104F-1962-4706-953D-30E26983D8D2}"/>
+                <a16:creationId xmlns:a16="http://schemas.microsoft.com/office/drawing/2014/main" id="{E92075B0-E2BE-4399-BEF1-59A9E4C00426}"/>
               </a:ext>
             </a:extLst>
           </p:cNvPr>
@@ -4469,7 +4469,7 @@
           <p:cNvPr id="23" name="">
             <a:extLst xmlns:a="http://schemas.openxmlformats.org/drawingml/2006/main">
               <a:ext uri="{FF2B5EF4-FFF2-40B4-BE49-F238E27FC236}">
-                <a16:creationId xmlns:a16="http://schemas.microsoft.com/office/drawing/2014/main" id="{57A99CA6-1D66-483E-A948-E5912367BC0E}"/>
+                <a16:creationId xmlns:a16="http://schemas.microsoft.com/office/drawing/2014/main" id="{9BC4E2E9-E80B-47E3-807E-105024F4D7BC}"/>
               </a:ext>
             </a:extLst>
           </p:cNvPr>
@@ -4504,7 +4504,7 @@
           <p:cNvPr id="24" name="">
             <a:extLst xmlns:a="http://schemas.openxmlformats.org/drawingml/2006/main">
               <a:ext uri="{FF2B5EF4-FFF2-40B4-BE49-F238E27FC236}">
-                <a16:creationId xmlns:a16="http://schemas.microsoft.com/office/drawing/2014/main" id="{CBAF04A0-CF7F-457C-8872-FBE351C08AD7}"/>
+                <a16:creationId xmlns:a16="http://schemas.microsoft.com/office/drawing/2014/main" id="{7B8BACAF-1F5C-4759-8644-7C5FEEB9FBB4}"/>
               </a:ext>
             </a:extLst>
           </p:cNvPr>
@@ -4554,7 +4554,7 @@
           <p:cNvPr id="25" name="">
             <a:extLst xmlns:a="http://schemas.openxmlformats.org/drawingml/2006/main">
               <a:ext uri="{FF2B5EF4-FFF2-40B4-BE49-F238E27FC236}">
-                <a16:creationId xmlns:a16="http://schemas.microsoft.com/office/drawing/2014/main" id="{189F205B-9FDA-496D-954D-13A97ACCD3A7}"/>
+                <a16:creationId xmlns:a16="http://schemas.microsoft.com/office/drawing/2014/main" id="{5B49C3FC-C539-4DD6-8669-191074C9F796}"/>
               </a:ext>
             </a:extLst>
           </p:cNvPr>
@@ -4604,7 +4604,7 @@
           <p:cNvPr id="26" name="">
             <a:extLst xmlns:a="http://schemas.openxmlformats.org/drawingml/2006/main">
               <a:ext uri="{FF2B5EF4-FFF2-40B4-BE49-F238E27FC236}">
-                <a16:creationId xmlns:a16="http://schemas.microsoft.com/office/drawing/2014/main" id="{0C7109B4-6064-4961-B01E-E6E9199F887D}"/>
+                <a16:creationId xmlns:a16="http://schemas.microsoft.com/office/drawing/2014/main" id="{69535D06-D8CA-48C8-A678-62A5EA62AE2B}"/>
               </a:ext>
             </a:extLst>
           </p:cNvPr>
@@ -4652,7 +4652,7 @@
     </p:spTree>
     <p:extLst>
       <p:ext uri="{BB962C8B-B14F-4D97-AF65-F5344CB8AC3E}">
-        <p14:creationId xmlns:p14="http://schemas.microsoft.com/office/powerpoint/2010/main" val="1800016624"/>
+        <p14:creationId xmlns:p14="http://schemas.microsoft.com/office/powerpoint/2010/main" val="767783328"/>
       </p:ext>
     </p:extLst>
   </p:cSld>
@@ -4687,7 +4687,7 @@
           <p:nvPr/>
         </p:nvPicPr>
         <p:blipFill>
-          <a:blip xmlns:r="http://schemas.openxmlformats.org/officeDocument/2006/relationships" xmlns:a="http://schemas.openxmlformats.org/drawingml/2006/main" r:embed="R61cd562ef2164f2b"/>
+          <a:blip xmlns:r="http://schemas.openxmlformats.org/officeDocument/2006/relationships" xmlns:a="http://schemas.openxmlformats.org/drawingml/2006/main" r:embed="Ra44f47826c024dd8"/>
           <a:stretch xmlns:a="http://schemas.openxmlformats.org/drawingml/2006/main"/>
         </p:blipFill>
         <p:spPr>
@@ -4707,7 +4707,7 @@
           <p:cNvPr id="2" name="">
             <a:extLst xmlns:a="http://schemas.openxmlformats.org/drawingml/2006/main">
               <a:ext uri="{FF2B5EF4-FFF2-40B4-BE49-F238E27FC236}">
-                <a16:creationId xmlns:a16="http://schemas.microsoft.com/office/drawing/2014/main" id="{F6AD9EE1-BB4D-43DA-8AFE-20637B2F5AEE}"/>
+                <a16:creationId xmlns:a16="http://schemas.microsoft.com/office/drawing/2014/main" id="{DA0C7853-7940-41AD-A858-F274496872EE}"/>
               </a:ext>
             </a:extLst>
           </p:cNvPr>
@@ -4757,7 +4757,7 @@
           <p:cNvPr id="3" name="">
             <a:extLst xmlns:a="http://schemas.openxmlformats.org/drawingml/2006/main">
               <a:ext uri="{FF2B5EF4-FFF2-40B4-BE49-F238E27FC236}">
-                <a16:creationId xmlns:a16="http://schemas.microsoft.com/office/drawing/2014/main" id="{70E9B649-7CBA-4DB6-BB00-0896F418D033}"/>
+                <a16:creationId xmlns:a16="http://schemas.microsoft.com/office/drawing/2014/main" id="{4EE5A9CA-123A-4F03-9E4D-792D01D3A445}"/>
               </a:ext>
             </a:extLst>
           </p:cNvPr>
@@ -4824,7 +4824,7 @@
           <p:cNvPr id="4" name="">
             <a:extLst xmlns:a="http://schemas.openxmlformats.org/drawingml/2006/main">
               <a:ext uri="{FF2B5EF4-FFF2-40B4-BE49-F238E27FC236}">
-                <a16:creationId xmlns:a16="http://schemas.microsoft.com/office/drawing/2014/main" id="{E6BD893C-6753-49BD-8A4F-D50E0D1AF2EF}"/>
+                <a16:creationId xmlns:a16="http://schemas.microsoft.com/office/drawing/2014/main" id="{28EF1771-BDB4-47A2-A7E0-3098C16C79F0}"/>
               </a:ext>
             </a:extLst>
           </p:cNvPr>
@@ -4874,7 +4874,7 @@
           <p:cNvPr id="5" name="">
             <a:extLst xmlns:a="http://schemas.openxmlformats.org/drawingml/2006/main">
               <a:ext uri="{FF2B5EF4-FFF2-40B4-BE49-F238E27FC236}">
-                <a16:creationId xmlns:a16="http://schemas.microsoft.com/office/drawing/2014/main" id="{F5B01E2B-0748-4471-A5B3-DDB6E1CA3356}"/>
+                <a16:creationId xmlns:a16="http://schemas.microsoft.com/office/drawing/2014/main" id="{FC66E5F5-F31F-47D6-98F3-241300AFE5DF}"/>
               </a:ext>
             </a:extLst>
           </p:cNvPr>
@@ -4907,7 +4907,7 @@
           <p:cNvPr id="6" name="">
             <a:extLst xmlns:a="http://schemas.openxmlformats.org/drawingml/2006/main">
               <a:ext uri="{FF2B5EF4-FFF2-40B4-BE49-F238E27FC236}">
-                <a16:creationId xmlns:a16="http://schemas.microsoft.com/office/drawing/2014/main" id="{1B75F1F2-2E73-474C-8845-E8379913D81A}"/>
+                <a16:creationId xmlns:a16="http://schemas.microsoft.com/office/drawing/2014/main" id="{BC7DC45C-5C60-4794-809C-9D21A3C5B71C}"/>
               </a:ext>
             </a:extLst>
           </p:cNvPr>
@@ -4957,7 +4957,7 @@
           <p:cNvPr id="7" name="">
             <a:extLst xmlns:a="http://schemas.openxmlformats.org/drawingml/2006/main">
               <a:ext uri="{FF2B5EF4-FFF2-40B4-BE49-F238E27FC236}">
-                <a16:creationId xmlns:a16="http://schemas.microsoft.com/office/drawing/2014/main" id="{9A2F8014-08B6-4627-953A-7C581C4583F8}"/>
+                <a16:creationId xmlns:a16="http://schemas.microsoft.com/office/drawing/2014/main" id="{04BBD249-09DF-4CB2-A993-0148580FD0C2}"/>
               </a:ext>
             </a:extLst>
           </p:cNvPr>
@@ -5007,7 +5007,7 @@
           <p:cNvPr id="8" name="">
             <a:extLst xmlns:a="http://schemas.openxmlformats.org/drawingml/2006/main">
               <a:ext uri="{FF2B5EF4-FFF2-40B4-BE49-F238E27FC236}">
-                <a16:creationId xmlns:a16="http://schemas.microsoft.com/office/drawing/2014/main" id="{19E82FF5-3477-48F8-9730-DA4893ED2EE5}"/>
+                <a16:creationId xmlns:a16="http://schemas.microsoft.com/office/drawing/2014/main" id="{B5109D2C-D4BF-4389-BE08-2DCA73BA19B6}"/>
               </a:ext>
             </a:extLst>
           </p:cNvPr>
@@ -5057,7 +5057,7 @@
           <p:cNvPr id="9" name="">
             <a:extLst xmlns:a="http://schemas.openxmlformats.org/drawingml/2006/main">
               <a:ext uri="{FF2B5EF4-FFF2-40B4-BE49-F238E27FC236}">
-                <a16:creationId xmlns:a16="http://schemas.microsoft.com/office/drawing/2014/main" id="{FDDC1266-8AF9-45F5-B32F-CE24E5D2FEB8}"/>
+                <a16:creationId xmlns:a16="http://schemas.microsoft.com/office/drawing/2014/main" id="{0693F6E3-434F-4F3C-BF07-71AF9C592327}"/>
               </a:ext>
             </a:extLst>
           </p:cNvPr>
@@ -5105,7 +5105,7 @@
     </p:spTree>
     <p:extLst>
       <p:ext uri="{BB962C8B-B14F-4D97-AF65-F5344CB8AC3E}">
-        <p14:creationId xmlns:p14="http://schemas.microsoft.com/office/powerpoint/2010/main" val="2109800066"/>
+        <p14:creationId xmlns:p14="http://schemas.microsoft.com/office/powerpoint/2010/main" val="16486678"/>
       </p:ext>
     </p:extLst>
   </p:cSld>
@@ -5136,7 +5136,7 @@
           <p:cNvPr id="25" name="">
             <a:extLst xmlns:a="http://schemas.openxmlformats.org/drawingml/2006/main">
               <a:ext uri="{FF2B5EF4-FFF2-40B4-BE49-F238E27FC236}">
-                <a16:creationId xmlns:a16="http://schemas.microsoft.com/office/drawing/2014/main" id="{0812D72F-6521-449C-B018-636E3E986DDF}"/>
+                <a16:creationId xmlns:a16="http://schemas.microsoft.com/office/drawing/2014/main" id="{93B72835-F5A9-47FE-AF22-E335C7914BF7}"/>
               </a:ext>
             </a:extLst>
           </p:cNvPr>
@@ -5186,7 +5186,7 @@
           <p:cNvPr id="2" name="">
             <a:extLst xmlns:a="http://schemas.openxmlformats.org/drawingml/2006/main">
               <a:ext uri="{FF2B5EF4-FFF2-40B4-BE49-F238E27FC236}">
-                <a16:creationId xmlns:a16="http://schemas.microsoft.com/office/drawing/2014/main" id="{ACA8B0B3-42C5-4F08-A6E0-0539B296E6CE}"/>
+                <a16:creationId xmlns:a16="http://schemas.microsoft.com/office/drawing/2014/main" id="{D8205D7E-392C-48BE-9AC2-100D002765AC}"/>
               </a:ext>
             </a:extLst>
           </p:cNvPr>
@@ -5236,7 +5236,7 @@
           <p:cNvPr id="3" name="">
             <a:extLst xmlns:a="http://schemas.openxmlformats.org/drawingml/2006/main">
               <a:ext uri="{FF2B5EF4-FFF2-40B4-BE49-F238E27FC236}">
-                <a16:creationId xmlns:a16="http://schemas.microsoft.com/office/drawing/2014/main" id="{48864D44-33A6-42FA-A3DA-EC233CD3AA16}"/>
+                <a16:creationId xmlns:a16="http://schemas.microsoft.com/office/drawing/2014/main" id="{BA62DF8D-0449-4F2A-87AE-7F3877ADD180}"/>
               </a:ext>
             </a:extLst>
           </p:cNvPr>
@@ -5269,7 +5269,7 @@
           <p:cNvPr id="4" name="">
             <a:extLst xmlns:a="http://schemas.openxmlformats.org/drawingml/2006/main">
               <a:ext uri="{FF2B5EF4-FFF2-40B4-BE49-F238E27FC236}">
-                <a16:creationId xmlns:a16="http://schemas.microsoft.com/office/drawing/2014/main" id="{ABE3F078-C522-46FB-A244-66EAC629BCEE}"/>
+                <a16:creationId xmlns:a16="http://schemas.microsoft.com/office/drawing/2014/main" id="{DFA457E5-FBC5-41FC-A95F-111DA7B34212}"/>
               </a:ext>
             </a:extLst>
           </p:cNvPr>
@@ -5319,7 +5319,7 @@
           <p:cNvPr id="5" name="">
             <a:extLst xmlns:a="http://schemas.openxmlformats.org/drawingml/2006/main">
               <a:ext uri="{FF2B5EF4-FFF2-40B4-BE49-F238E27FC236}">
-                <a16:creationId xmlns:a16="http://schemas.microsoft.com/office/drawing/2014/main" id="{4DD5D9A4-6921-4F16-B88E-38F5B5AEDC8B}"/>
+                <a16:creationId xmlns:a16="http://schemas.microsoft.com/office/drawing/2014/main" id="{D798FE16-B0B4-4502-A197-02EA56B0B405}"/>
               </a:ext>
             </a:extLst>
           </p:cNvPr>
@@ -5369,7 +5369,7 @@
           <p:cNvPr id="6" name="">
             <a:extLst xmlns:a="http://schemas.openxmlformats.org/drawingml/2006/main">
               <a:ext uri="{FF2B5EF4-FFF2-40B4-BE49-F238E27FC236}">
-                <a16:creationId xmlns:a16="http://schemas.microsoft.com/office/drawing/2014/main" id="{61D02C27-71D5-4AFD-BFD9-74FC082F31BE}"/>
+                <a16:creationId xmlns:a16="http://schemas.microsoft.com/office/drawing/2014/main" id="{7619E0CB-DC76-47A9-ABEE-B202058896D1}"/>
               </a:ext>
             </a:extLst>
           </p:cNvPr>
@@ -5419,7 +5419,7 @@
           <p:cNvPr id="7" name="">
             <a:extLst xmlns:a="http://schemas.openxmlformats.org/drawingml/2006/main">
               <a:ext uri="{FF2B5EF4-FFF2-40B4-BE49-F238E27FC236}">
-                <a16:creationId xmlns:a16="http://schemas.microsoft.com/office/drawing/2014/main" id="{A02F0980-C03C-4864-92F1-B8F0A35642E7}"/>
+                <a16:creationId xmlns:a16="http://schemas.microsoft.com/office/drawing/2014/main" id="{BEC74834-F542-444C-BBF1-36363B5BED7B}"/>
               </a:ext>
             </a:extLst>
           </p:cNvPr>
@@ -5469,7 +5469,7 @@
           <p:cNvPr id="8" name="">
             <a:extLst xmlns:a="http://schemas.openxmlformats.org/drawingml/2006/main">
               <a:ext uri="{FF2B5EF4-FFF2-40B4-BE49-F238E27FC236}">
-                <a16:creationId xmlns:a16="http://schemas.microsoft.com/office/drawing/2014/main" id="{94D358E8-9F68-44EA-94D3-1F4D4F0D836E}"/>
+                <a16:creationId xmlns:a16="http://schemas.microsoft.com/office/drawing/2014/main" id="{86ECC6EB-F8E9-45B0-9586-B0FEDD00A394}"/>
               </a:ext>
             </a:extLst>
           </p:cNvPr>
@@ -5519,7 +5519,7 @@
           <p:cNvPr id="9" name="">
             <a:extLst xmlns:a="http://schemas.openxmlformats.org/drawingml/2006/main">
               <a:ext uri="{FF2B5EF4-FFF2-40B4-BE49-F238E27FC236}">
-                <a16:creationId xmlns:a16="http://schemas.microsoft.com/office/drawing/2014/main" id="{EFBED262-D170-4720-A403-AF9839EC10DC}"/>
+                <a16:creationId xmlns:a16="http://schemas.microsoft.com/office/drawing/2014/main" id="{4542EA4E-461C-4613-AFA1-40508717F2DA}"/>
               </a:ext>
             </a:extLst>
           </p:cNvPr>
@@ -5569,7 +5569,7 @@
           <p:cNvPr id="10" name="">
             <a:extLst xmlns:a="http://schemas.openxmlformats.org/drawingml/2006/main">
               <a:ext uri="{FF2B5EF4-FFF2-40B4-BE49-F238E27FC236}">
-                <a16:creationId xmlns:a16="http://schemas.microsoft.com/office/drawing/2014/main" id="{F25F7C5D-8380-4DCC-949F-9336602E0B07}"/>
+                <a16:creationId xmlns:a16="http://schemas.microsoft.com/office/drawing/2014/main" id="{1AFB4226-E14B-4F3B-8308-27492D3E9BFD}"/>
               </a:ext>
             </a:extLst>
           </p:cNvPr>
@@ -5602,7 +5602,7 @@
           <p:cNvPr id="11" name="">
             <a:extLst xmlns:a="http://schemas.openxmlformats.org/drawingml/2006/main">
               <a:ext uri="{FF2B5EF4-FFF2-40B4-BE49-F238E27FC236}">
-                <a16:creationId xmlns:a16="http://schemas.microsoft.com/office/drawing/2014/main" id="{48045AE3-A76A-4DAD-A431-4BFBC314C26E}"/>
+                <a16:creationId xmlns:a16="http://schemas.microsoft.com/office/drawing/2014/main" id="{BF15BA47-F3E4-4744-B1CD-506A55886678}"/>
               </a:ext>
             </a:extLst>
           </p:cNvPr>
@@ -5652,7 +5652,7 @@
           <p:cNvPr id="12" name="">
             <a:extLst xmlns:a="http://schemas.openxmlformats.org/drawingml/2006/main">
               <a:ext uri="{FF2B5EF4-FFF2-40B4-BE49-F238E27FC236}">
-                <a16:creationId xmlns:a16="http://schemas.microsoft.com/office/drawing/2014/main" id="{47AA5CFA-6E24-4485-B2E3-59227B112C3E}"/>
+                <a16:creationId xmlns:a16="http://schemas.microsoft.com/office/drawing/2014/main" id="{6B154B3C-04DC-4D40-9A96-22EF8915EB47}"/>
               </a:ext>
             </a:extLst>
           </p:cNvPr>
@@ -5702,7 +5702,7 @@
           <p:cNvPr id="13" name="">
             <a:extLst xmlns:a="http://schemas.openxmlformats.org/drawingml/2006/main">
               <a:ext uri="{FF2B5EF4-FFF2-40B4-BE49-F238E27FC236}">
-                <a16:creationId xmlns:a16="http://schemas.microsoft.com/office/drawing/2014/main" id="{9CC30A57-C1FD-46CB-BB94-AF635387CDCE}"/>
+                <a16:creationId xmlns:a16="http://schemas.microsoft.com/office/drawing/2014/main" id="{4858A6CB-8D2C-4C0A-AC09-D6DE787DB324}"/>
               </a:ext>
             </a:extLst>
           </p:cNvPr>
@@ -5752,7 +5752,7 @@
           <p:cNvPr id="14" name="">
             <a:extLst xmlns:a="http://schemas.openxmlformats.org/drawingml/2006/main">
               <a:ext uri="{FF2B5EF4-FFF2-40B4-BE49-F238E27FC236}">
-                <a16:creationId xmlns:a16="http://schemas.microsoft.com/office/drawing/2014/main" id="{C844F31A-1917-49B3-903D-9C765E7B165A}"/>
+                <a16:creationId xmlns:a16="http://schemas.microsoft.com/office/drawing/2014/main" id="{65EB8BA5-7880-41DB-A14A-A3725E6BA8EF}"/>
               </a:ext>
             </a:extLst>
           </p:cNvPr>
@@ -5785,7 +5785,7 @@
           <p:cNvPr id="15" name="">
             <a:extLst xmlns:a="http://schemas.openxmlformats.org/drawingml/2006/main">
               <a:ext uri="{FF2B5EF4-FFF2-40B4-BE49-F238E27FC236}">
-                <a16:creationId xmlns:a16="http://schemas.microsoft.com/office/drawing/2014/main" id="{E5AA0194-5E6E-435E-90FF-A43C6C4F42DD}"/>
+                <a16:creationId xmlns:a16="http://schemas.microsoft.com/office/drawing/2014/main" id="{9F1EF751-CFC9-48EE-BCF9-865E049708CC}"/>
               </a:ext>
             </a:extLst>
           </p:cNvPr>
@@ -5835,7 +5835,7 @@
           <p:cNvPr id="16" name="">
             <a:extLst xmlns:a="http://schemas.openxmlformats.org/drawingml/2006/main">
               <a:ext uri="{FF2B5EF4-FFF2-40B4-BE49-F238E27FC236}">
-                <a16:creationId xmlns:a16="http://schemas.microsoft.com/office/drawing/2014/main" id="{A0FDF66D-1F6E-4C50-A706-4B3D4AEAD38B}"/>
+                <a16:creationId xmlns:a16="http://schemas.microsoft.com/office/drawing/2014/main" id="{CF5C7491-61B9-4207-ADBF-2A8FEDC01659}"/>
               </a:ext>
             </a:extLst>
           </p:cNvPr>
@@ -5885,7 +5885,7 @@
           <p:cNvPr id="17" name="">
             <a:extLst xmlns:a="http://schemas.openxmlformats.org/drawingml/2006/main">
               <a:ext uri="{FF2B5EF4-FFF2-40B4-BE49-F238E27FC236}">
-                <a16:creationId xmlns:a16="http://schemas.microsoft.com/office/drawing/2014/main" id="{87ED3F4E-1E3C-42A8-99ED-C8B83C4FBC95}"/>
+                <a16:creationId xmlns:a16="http://schemas.microsoft.com/office/drawing/2014/main" id="{EE874D21-3D43-43CC-AE9D-B2EFF4B0E1C3}"/>
               </a:ext>
             </a:extLst>
           </p:cNvPr>
@@ -5935,7 +5935,7 @@
           <p:cNvPr id="18" name="">
             <a:extLst xmlns:a="http://schemas.openxmlformats.org/drawingml/2006/main">
               <a:ext uri="{FF2B5EF4-FFF2-40B4-BE49-F238E27FC236}">
-                <a16:creationId xmlns:a16="http://schemas.microsoft.com/office/drawing/2014/main" id="{208DC9BE-34A8-496C-8C30-70F0FA27CD77}"/>
+                <a16:creationId xmlns:a16="http://schemas.microsoft.com/office/drawing/2014/main" id="{420A36A8-63A3-4E04-894B-A52D2BCCF824}"/>
               </a:ext>
             </a:extLst>
           </p:cNvPr>
@@ -5968,7 +5968,7 @@
           <p:cNvPr id="19" name="">
             <a:extLst xmlns:a="http://schemas.openxmlformats.org/drawingml/2006/main">
               <a:ext uri="{FF2B5EF4-FFF2-40B4-BE49-F238E27FC236}">
-                <a16:creationId xmlns:a16="http://schemas.microsoft.com/office/drawing/2014/main" id="{F4DBD1AF-3744-4B0F-8542-58D256860A74}"/>
+                <a16:creationId xmlns:a16="http://schemas.microsoft.com/office/drawing/2014/main" id="{66E53E6C-934A-4876-9B24-22C287812607}"/>
               </a:ext>
             </a:extLst>
           </p:cNvPr>
@@ -6018,7 +6018,7 @@
           <p:cNvPr id="20" name="">
             <a:extLst xmlns:a="http://schemas.openxmlformats.org/drawingml/2006/main">
               <a:ext uri="{FF2B5EF4-FFF2-40B4-BE49-F238E27FC236}">
-                <a16:creationId xmlns:a16="http://schemas.microsoft.com/office/drawing/2014/main" id="{83699D61-F959-4641-B8C3-986FFAEE4219}"/>
+                <a16:creationId xmlns:a16="http://schemas.microsoft.com/office/drawing/2014/main" id="{04F32DBC-68F9-416E-8599-C2E0C6988D0F}"/>
               </a:ext>
             </a:extLst>
           </p:cNvPr>
@@ -6068,7 +6068,7 @@
           <p:cNvPr id="21" name="">
             <a:extLst xmlns:a="http://schemas.openxmlformats.org/drawingml/2006/main">
               <a:ext uri="{FF2B5EF4-FFF2-40B4-BE49-F238E27FC236}">
-                <a16:creationId xmlns:a16="http://schemas.microsoft.com/office/drawing/2014/main" id="{AF7A68D1-1026-45E6-83DB-FE54861C21C6}"/>
+                <a16:creationId xmlns:a16="http://schemas.microsoft.com/office/drawing/2014/main" id="{68216559-AA0F-49E4-981F-19A63A712505}"/>
               </a:ext>
             </a:extLst>
           </p:cNvPr>
@@ -6118,7 +6118,7 @@
           <p:cNvPr id="22" name="">
             <a:extLst xmlns:a="http://schemas.openxmlformats.org/drawingml/2006/main">
               <a:ext uri="{FF2B5EF4-FFF2-40B4-BE49-F238E27FC236}">
-                <a16:creationId xmlns:a16="http://schemas.microsoft.com/office/drawing/2014/main" id="{8BB017CB-CAC3-4C0A-AA76-4354342C97BC}"/>
+                <a16:creationId xmlns:a16="http://schemas.microsoft.com/office/drawing/2014/main" id="{1670028B-3824-4449-A180-0D86CE0F5748}"/>
               </a:ext>
             </a:extLst>
           </p:cNvPr>
@@ -6151,7 +6151,7 @@
           <p:cNvPr id="23" name="">
             <a:extLst xmlns:a="http://schemas.openxmlformats.org/drawingml/2006/main">
               <a:ext uri="{FF2B5EF4-FFF2-40B4-BE49-F238E27FC236}">
-                <a16:creationId xmlns:a16="http://schemas.microsoft.com/office/drawing/2014/main" id="{F9A06E5C-0A3D-441E-94B2-F64A14F6AD01}"/>
+                <a16:creationId xmlns:a16="http://schemas.microsoft.com/office/drawing/2014/main" id="{1D2BDCA5-9A03-4992-91FE-9274CA55A541}"/>
               </a:ext>
             </a:extLst>
           </p:cNvPr>
@@ -6201,7 +6201,7 @@
           <p:cNvPr id="24" name="">
             <a:extLst xmlns:a="http://schemas.openxmlformats.org/drawingml/2006/main">
               <a:ext uri="{FF2B5EF4-FFF2-40B4-BE49-F238E27FC236}">
-                <a16:creationId xmlns:a16="http://schemas.microsoft.com/office/drawing/2014/main" id="{408C24A0-EE1A-4609-A356-6C12B9DC929F}"/>
+                <a16:creationId xmlns:a16="http://schemas.microsoft.com/office/drawing/2014/main" id="{C23C14B9-DFC6-4C3C-9192-7E7B6FAB6325}"/>
               </a:ext>
             </a:extLst>
           </p:cNvPr>
@@ -6249,7 +6249,7 @@
     </p:spTree>
     <p:extLst>
       <p:ext uri="{BB962C8B-B14F-4D97-AF65-F5344CB8AC3E}">
-        <p14:creationId xmlns:p14="http://schemas.microsoft.com/office/powerpoint/2010/main" val="784910560"/>
+        <p14:creationId xmlns:p14="http://schemas.microsoft.com/office/powerpoint/2010/main" val="1558227204"/>
       </p:ext>
     </p:extLst>
   </p:cSld>
@@ -6280,7 +6280,7 @@
           <p:cNvPr id="27" name="">
             <a:extLst xmlns:a="http://schemas.openxmlformats.org/drawingml/2006/main">
               <a:ext uri="{FF2B5EF4-FFF2-40B4-BE49-F238E27FC236}">
-                <a16:creationId xmlns:a16="http://schemas.microsoft.com/office/drawing/2014/main" id="{23810A1F-983E-45A2-8DC1-97804DCFDCEB}"/>
+                <a16:creationId xmlns:a16="http://schemas.microsoft.com/office/drawing/2014/main" id="{E98CCA23-FA5D-49BD-8D69-7110CC8BDB30}"/>
               </a:ext>
             </a:extLst>
           </p:cNvPr>
@@ -6330,7 +6330,7 @@
           <p:cNvPr id="2" name="">
             <a:extLst xmlns:a="http://schemas.openxmlformats.org/drawingml/2006/main">
               <a:ext uri="{FF2B5EF4-FFF2-40B4-BE49-F238E27FC236}">
-                <a16:creationId xmlns:a16="http://schemas.microsoft.com/office/drawing/2014/main" id="{D7706088-3520-48E3-8A46-63DDD657CCAD}"/>
+                <a16:creationId xmlns:a16="http://schemas.microsoft.com/office/drawing/2014/main" id="{BB8F6E37-4AF4-40A7-ADDE-7B5E925F6943}"/>
               </a:ext>
             </a:extLst>
           </p:cNvPr>
@@ -6380,7 +6380,7 @@
           <p:cNvPr id="3" name="">
             <a:extLst xmlns:a="http://schemas.openxmlformats.org/drawingml/2006/main">
               <a:ext uri="{FF2B5EF4-FFF2-40B4-BE49-F238E27FC236}">
-                <a16:creationId xmlns:a16="http://schemas.microsoft.com/office/drawing/2014/main" id="{2A4E8613-9CF0-4096-9C6E-6F4CE9018CBE}"/>
+                <a16:creationId xmlns:a16="http://schemas.microsoft.com/office/drawing/2014/main" id="{E0A32F89-9FD4-400D-8CDA-B4DFC6EF8ADC}"/>
               </a:ext>
             </a:extLst>
           </p:cNvPr>
@@ -6413,7 +6413,7 @@
           <p:cNvPr id="4" name="">
             <a:extLst xmlns:a="http://schemas.openxmlformats.org/drawingml/2006/main">
               <a:ext uri="{FF2B5EF4-FFF2-40B4-BE49-F238E27FC236}">
-                <a16:creationId xmlns:a16="http://schemas.microsoft.com/office/drawing/2014/main" id="{7A66254C-D4E5-45AA-881A-6B006E86B43B}"/>
+                <a16:creationId xmlns:a16="http://schemas.microsoft.com/office/drawing/2014/main" id="{88EAC39C-9C21-4CF4-89FA-E4BB48748DE1}"/>
               </a:ext>
             </a:extLst>
           </p:cNvPr>
@@ -6463,7 +6463,7 @@
           <p:cNvPr id="5" name="">
             <a:extLst xmlns:a="http://schemas.openxmlformats.org/drawingml/2006/main">
               <a:ext uri="{FF2B5EF4-FFF2-40B4-BE49-F238E27FC236}">
-                <a16:creationId xmlns:a16="http://schemas.microsoft.com/office/drawing/2014/main" id="{E642A39D-C8EE-4BDB-9CE4-9D0478B4D7A1}"/>
+                <a16:creationId xmlns:a16="http://schemas.microsoft.com/office/drawing/2014/main" id="{28A64CE7-59FA-4195-A27E-C3CD3BB385A8}"/>
               </a:ext>
             </a:extLst>
           </p:cNvPr>
@@ -6513,7 +6513,7 @@
           <p:cNvPr id="6" name="">
             <a:extLst xmlns:a="http://schemas.openxmlformats.org/drawingml/2006/main">
               <a:ext uri="{FF2B5EF4-FFF2-40B4-BE49-F238E27FC236}">
-                <a16:creationId xmlns:a16="http://schemas.microsoft.com/office/drawing/2014/main" id="{9194AC01-61EB-4B25-B844-AF96296AA15F}"/>
+                <a16:creationId xmlns:a16="http://schemas.microsoft.com/office/drawing/2014/main" id="{24EE946D-A54A-49B2-99EE-E9C82819BB0D}"/>
               </a:ext>
             </a:extLst>
           </p:cNvPr>
@@ -6563,7 +6563,7 @@
           <p:cNvPr id="7" name="">
             <a:extLst xmlns:a="http://schemas.openxmlformats.org/drawingml/2006/main">
               <a:ext uri="{FF2B5EF4-FFF2-40B4-BE49-F238E27FC236}">
-                <a16:creationId xmlns:a16="http://schemas.microsoft.com/office/drawing/2014/main" id="{9EC39083-7BA0-42EB-A237-3BBBB40051D8}"/>
+                <a16:creationId xmlns:a16="http://schemas.microsoft.com/office/drawing/2014/main" id="{EA174AE1-19ED-4B20-94E6-8FB13024878E}"/>
               </a:ext>
             </a:extLst>
           </p:cNvPr>
@@ -6598,7 +6598,7 @@
           <p:cNvPr id="8" name="">
             <a:extLst xmlns:a="http://schemas.openxmlformats.org/drawingml/2006/main">
               <a:ext uri="{FF2B5EF4-FFF2-40B4-BE49-F238E27FC236}">
-                <a16:creationId xmlns:a16="http://schemas.microsoft.com/office/drawing/2014/main" id="{5034F0D2-C08A-4FB3-93DE-7D4471D4D201}"/>
+                <a16:creationId xmlns:a16="http://schemas.microsoft.com/office/drawing/2014/main" id="{53F330EE-F2B5-4962-B6DB-863914F71344}"/>
               </a:ext>
             </a:extLst>
           </p:cNvPr>
@@ -6648,7 +6648,7 @@
           <p:cNvPr id="9" name="">
             <a:extLst xmlns:a="http://schemas.openxmlformats.org/drawingml/2006/main">
               <a:ext uri="{FF2B5EF4-FFF2-40B4-BE49-F238E27FC236}">
-                <a16:creationId xmlns:a16="http://schemas.microsoft.com/office/drawing/2014/main" id="{33E18E07-DA05-4A4E-BCDA-A926DFEDD3D0}"/>
+                <a16:creationId xmlns:a16="http://schemas.microsoft.com/office/drawing/2014/main" id="{CB1B5429-E422-4632-AAC2-6E9D30B78093}"/>
               </a:ext>
             </a:extLst>
           </p:cNvPr>
@@ -6698,7 +6698,7 @@
           <p:cNvPr id="10" name="">
             <a:extLst xmlns:a="http://schemas.openxmlformats.org/drawingml/2006/main">
               <a:ext uri="{FF2B5EF4-FFF2-40B4-BE49-F238E27FC236}">
-                <a16:creationId xmlns:a16="http://schemas.microsoft.com/office/drawing/2014/main" id="{952CDD6F-9195-430D-8550-95B01D54DC18}"/>
+                <a16:creationId xmlns:a16="http://schemas.microsoft.com/office/drawing/2014/main" id="{941A10D4-83F2-4CAB-A2DD-D3A845D768B8}"/>
               </a:ext>
             </a:extLst>
           </p:cNvPr>
@@ -6748,7 +6748,7 @@
           <p:cNvPr id="11" name="">
             <a:extLst xmlns:a="http://schemas.openxmlformats.org/drawingml/2006/main">
               <a:ext uri="{FF2B5EF4-FFF2-40B4-BE49-F238E27FC236}">
-                <a16:creationId xmlns:a16="http://schemas.microsoft.com/office/drawing/2014/main" id="{4B61104D-A3F2-427B-BA58-00E72938078E}"/>
+                <a16:creationId xmlns:a16="http://schemas.microsoft.com/office/drawing/2014/main" id="{87729FC0-827E-4FCD-8D0D-75F0FF3C0736}"/>
               </a:ext>
             </a:extLst>
           </p:cNvPr>
@@ -6781,7 +6781,7 @@
           <p:cNvPr id="12" name="">
             <a:extLst xmlns:a="http://schemas.openxmlformats.org/drawingml/2006/main">
               <a:ext uri="{FF2B5EF4-FFF2-40B4-BE49-F238E27FC236}">
-                <a16:creationId xmlns:a16="http://schemas.microsoft.com/office/drawing/2014/main" id="{6403E7E1-D3F7-4FCD-A5AD-A476128AABB6}"/>
+                <a16:creationId xmlns:a16="http://schemas.microsoft.com/office/drawing/2014/main" id="{89D41B62-1C28-49B8-860F-3BAF37EE574F}"/>
               </a:ext>
             </a:extLst>
           </p:cNvPr>
@@ -6831,7 +6831,7 @@
           <p:cNvPr id="13" name="">
             <a:extLst xmlns:a="http://schemas.openxmlformats.org/drawingml/2006/main">
               <a:ext uri="{FF2B5EF4-FFF2-40B4-BE49-F238E27FC236}">
-                <a16:creationId xmlns:a16="http://schemas.microsoft.com/office/drawing/2014/main" id="{9CEB6C78-3F6B-4822-8C5C-F045067DC3FA}"/>
+                <a16:creationId xmlns:a16="http://schemas.microsoft.com/office/drawing/2014/main" id="{E3F71BD9-F5FA-4C7C-AC54-805AED341239}"/>
               </a:ext>
             </a:extLst>
           </p:cNvPr>
@@ -6866,7 +6866,7 @@
           <p:cNvPr id="14" name="">
             <a:extLst xmlns:a="http://schemas.openxmlformats.org/drawingml/2006/main">
               <a:ext uri="{FF2B5EF4-FFF2-40B4-BE49-F238E27FC236}">
-                <a16:creationId xmlns:a16="http://schemas.microsoft.com/office/drawing/2014/main" id="{923ABD1C-415A-4D29-BFF4-648C08DAC001}"/>
+                <a16:creationId xmlns:a16="http://schemas.microsoft.com/office/drawing/2014/main" id="{94BD26A1-D9C8-4BFC-9920-C0FFD0FD773E}"/>
               </a:ext>
             </a:extLst>
           </p:cNvPr>
@@ -6916,7 +6916,7 @@
           <p:cNvPr id="15" name="">
             <a:extLst xmlns:a="http://schemas.openxmlformats.org/drawingml/2006/main">
               <a:ext uri="{FF2B5EF4-FFF2-40B4-BE49-F238E27FC236}">
-                <a16:creationId xmlns:a16="http://schemas.microsoft.com/office/drawing/2014/main" id="{304C4108-6F4C-4704-97FF-BC83AB12C956}"/>
+                <a16:creationId xmlns:a16="http://schemas.microsoft.com/office/drawing/2014/main" id="{F485D25B-9A86-4962-B121-87EF63CCE60A}"/>
               </a:ext>
             </a:extLst>
           </p:cNvPr>
@@ -6966,7 +6966,7 @@
           <p:cNvPr id="16" name="">
             <a:extLst xmlns:a="http://schemas.openxmlformats.org/drawingml/2006/main">
               <a:ext uri="{FF2B5EF4-FFF2-40B4-BE49-F238E27FC236}">
-                <a16:creationId xmlns:a16="http://schemas.microsoft.com/office/drawing/2014/main" id="{2BBA6E23-1826-4964-95A3-40A03E1E7218}"/>
+                <a16:creationId xmlns:a16="http://schemas.microsoft.com/office/drawing/2014/main" id="{1E136CE0-AFAA-4BCB-9896-35BA4E325EA8}"/>
               </a:ext>
             </a:extLst>
           </p:cNvPr>
@@ -7016,7 +7016,7 @@
           <p:cNvPr id="17" name="">
             <a:extLst xmlns:a="http://schemas.openxmlformats.org/drawingml/2006/main">
               <a:ext uri="{FF2B5EF4-FFF2-40B4-BE49-F238E27FC236}">
-                <a16:creationId xmlns:a16="http://schemas.microsoft.com/office/drawing/2014/main" id="{0A6E57A1-A772-4D0E-AC7B-99F59B7AFC12}"/>
+                <a16:creationId xmlns:a16="http://schemas.microsoft.com/office/drawing/2014/main" id="{9D44201B-2C33-4DD4-A325-A768E38D171A}"/>
               </a:ext>
             </a:extLst>
           </p:cNvPr>
@@ -7049,7 +7049,7 @@
           <p:cNvPr id="18" name="">
             <a:extLst xmlns:a="http://schemas.openxmlformats.org/drawingml/2006/main">
               <a:ext uri="{FF2B5EF4-FFF2-40B4-BE49-F238E27FC236}">
-                <a16:creationId xmlns:a16="http://schemas.microsoft.com/office/drawing/2014/main" id="{2EFBABB9-70D4-4519-BED4-FCE6773B2B1E}"/>
+                <a16:creationId xmlns:a16="http://schemas.microsoft.com/office/drawing/2014/main" id="{B272F237-F925-421C-A503-8895AC72A36A}"/>
               </a:ext>
             </a:extLst>
           </p:cNvPr>
@@ -7099,7 +7099,7 @@
           <p:cNvPr id="19" name="">
             <a:extLst xmlns:a="http://schemas.openxmlformats.org/drawingml/2006/main">
               <a:ext uri="{FF2B5EF4-FFF2-40B4-BE49-F238E27FC236}">
-                <a16:creationId xmlns:a16="http://schemas.microsoft.com/office/drawing/2014/main" id="{8F4AE2F9-2027-40F1-AC34-0074326A39CB}"/>
+                <a16:creationId xmlns:a16="http://schemas.microsoft.com/office/drawing/2014/main" id="{05CB1D3A-10BA-4409-A794-8A41217D4F44}"/>
               </a:ext>
             </a:extLst>
           </p:cNvPr>
@@ -7134,7 +7134,7 @@
           <p:cNvPr id="20" name="">
             <a:extLst xmlns:a="http://schemas.openxmlformats.org/drawingml/2006/main">
               <a:ext uri="{FF2B5EF4-FFF2-40B4-BE49-F238E27FC236}">
-                <a16:creationId xmlns:a16="http://schemas.microsoft.com/office/drawing/2014/main" id="{3BDEA084-D312-481B-AC7A-55AB69829946}"/>
+                <a16:creationId xmlns:a16="http://schemas.microsoft.com/office/drawing/2014/main" id="{FF23255C-B609-4D6B-8133-57D918729722}"/>
               </a:ext>
             </a:extLst>
           </p:cNvPr>
@@ -7184,7 +7184,7 @@
           <p:cNvPr id="21" name="">
             <a:extLst xmlns:a="http://schemas.openxmlformats.org/drawingml/2006/main">
               <a:ext uri="{FF2B5EF4-FFF2-40B4-BE49-F238E27FC236}">
-                <a16:creationId xmlns:a16="http://schemas.microsoft.com/office/drawing/2014/main" id="{4B1ECBC7-3030-45F4-82EF-258DF7352F63}"/>
+                <a16:creationId xmlns:a16="http://schemas.microsoft.com/office/drawing/2014/main" id="{7DCDCDBD-E17B-49D6-BC4C-BDCF9F8CF7E4}"/>
               </a:ext>
             </a:extLst>
           </p:cNvPr>
@@ -7234,7 +7234,7 @@
           <p:cNvPr id="22" name="">
             <a:extLst xmlns:a="http://schemas.openxmlformats.org/drawingml/2006/main">
               <a:ext uri="{FF2B5EF4-FFF2-40B4-BE49-F238E27FC236}">
-                <a16:creationId xmlns:a16="http://schemas.microsoft.com/office/drawing/2014/main" id="{D9BEE681-A427-4610-AD99-4BAEBD5C9E5C}"/>
+                <a16:creationId xmlns:a16="http://schemas.microsoft.com/office/drawing/2014/main" id="{3E892795-EE92-4134-A2B4-55BB3B4A0F6D}"/>
               </a:ext>
             </a:extLst>
           </p:cNvPr>
@@ -7284,7 +7284,7 @@
           <p:cNvPr id="23" name="">
             <a:extLst xmlns:a="http://schemas.openxmlformats.org/drawingml/2006/main">
               <a:ext uri="{FF2B5EF4-FFF2-40B4-BE49-F238E27FC236}">
-                <a16:creationId xmlns:a16="http://schemas.microsoft.com/office/drawing/2014/main" id="{5C946CFC-CC65-4D9B-82E7-A8505ED40BBF}"/>
+                <a16:creationId xmlns:a16="http://schemas.microsoft.com/office/drawing/2014/main" id="{0D154109-2C29-4713-A7FF-CE048137ABD6}"/>
               </a:ext>
             </a:extLst>
           </p:cNvPr>
@@ -7317,7 +7317,7 @@
           <p:cNvPr id="24" name="">
             <a:extLst xmlns:a="http://schemas.openxmlformats.org/drawingml/2006/main">
               <a:ext uri="{FF2B5EF4-FFF2-40B4-BE49-F238E27FC236}">
-                <a16:creationId xmlns:a16="http://schemas.microsoft.com/office/drawing/2014/main" id="{5D900409-3F0F-4BB9-9F9D-461ACA154689}"/>
+                <a16:creationId xmlns:a16="http://schemas.microsoft.com/office/drawing/2014/main" id="{1328F2EC-F6F0-4B73-AF43-4546FD1A777A}"/>
               </a:ext>
             </a:extLst>
           </p:cNvPr>
@@ -7367,7 +7367,7 @@
           <p:cNvPr id="25" name="">
             <a:extLst xmlns:a="http://schemas.openxmlformats.org/drawingml/2006/main">
               <a:ext uri="{FF2B5EF4-FFF2-40B4-BE49-F238E27FC236}">
-                <a16:creationId xmlns:a16="http://schemas.microsoft.com/office/drawing/2014/main" id="{77E8D029-9E43-41C7-BDDB-A692762885BA}"/>
+                <a16:creationId xmlns:a16="http://schemas.microsoft.com/office/drawing/2014/main" id="{3AA840CB-9FC2-40CC-9E79-3FD6251D19D5}"/>
               </a:ext>
             </a:extLst>
           </p:cNvPr>
@@ -7417,7 +7417,7 @@
           <p:cNvPr id="26" name="">
             <a:extLst xmlns:a="http://schemas.openxmlformats.org/drawingml/2006/main">
               <a:ext uri="{FF2B5EF4-FFF2-40B4-BE49-F238E27FC236}">
-                <a16:creationId xmlns:a16="http://schemas.microsoft.com/office/drawing/2014/main" id="{60438763-D330-4612-9F78-AE94EDD45A54}"/>
+                <a16:creationId xmlns:a16="http://schemas.microsoft.com/office/drawing/2014/main" id="{006676E4-5CB5-4888-B9D9-5A691F572503}"/>
               </a:ext>
             </a:extLst>
           </p:cNvPr>
@@ -7465,7 +7465,7 @@
     </p:spTree>
     <p:extLst>
       <p:ext uri="{BB962C8B-B14F-4D97-AF65-F5344CB8AC3E}">
-        <p14:creationId xmlns:p14="http://schemas.microsoft.com/office/powerpoint/2010/main" val="1782868463"/>
+        <p14:creationId xmlns:p14="http://schemas.microsoft.com/office/powerpoint/2010/main" val="638462034"/>
       </p:ext>
     </p:extLst>
   </p:cSld>
@@ -7496,7 +7496,7 @@
           <p:cNvPr id="32" name="">
             <a:extLst xmlns:a="http://schemas.openxmlformats.org/drawingml/2006/main">
               <a:ext uri="{FF2B5EF4-FFF2-40B4-BE49-F238E27FC236}">
-                <a16:creationId xmlns:a16="http://schemas.microsoft.com/office/drawing/2014/main" id="{4FE69E1C-7E48-4078-BEA1-EA60D399E0DE}"/>
+                <a16:creationId xmlns:a16="http://schemas.microsoft.com/office/drawing/2014/main" id="{7E05BEBD-5387-40FA-8C41-D2C11B2780DF}"/>
               </a:ext>
             </a:extLst>
           </p:cNvPr>
@@ -7546,7 +7546,7 @@
           <p:cNvPr id="2" name="">
             <a:extLst xmlns:a="http://schemas.openxmlformats.org/drawingml/2006/main">
               <a:ext uri="{FF2B5EF4-FFF2-40B4-BE49-F238E27FC236}">
-                <a16:creationId xmlns:a16="http://schemas.microsoft.com/office/drawing/2014/main" id="{91A5376B-A75F-4039-BA69-9A077019FBB8}"/>
+                <a16:creationId xmlns:a16="http://schemas.microsoft.com/office/drawing/2014/main" id="{D364E0FD-C745-4EFB-A419-973BCFC893F3}"/>
               </a:ext>
             </a:extLst>
           </p:cNvPr>
@@ -7596,7 +7596,7 @@
           <p:cNvPr id="3" name="">
             <a:extLst xmlns:a="http://schemas.openxmlformats.org/drawingml/2006/main">
               <a:ext uri="{FF2B5EF4-FFF2-40B4-BE49-F238E27FC236}">
-                <a16:creationId xmlns:a16="http://schemas.microsoft.com/office/drawing/2014/main" id="{BE3A0FFF-35E5-4216-B1F5-2C618F7501EA}"/>
+                <a16:creationId xmlns:a16="http://schemas.microsoft.com/office/drawing/2014/main" id="{63B3A252-713D-423C-BF0E-8B98C64A2832}"/>
               </a:ext>
             </a:extLst>
           </p:cNvPr>
@@ -7629,7 +7629,7 @@
           <p:cNvPr id="4" name="">
             <a:extLst xmlns:a="http://schemas.openxmlformats.org/drawingml/2006/main">
               <a:ext uri="{FF2B5EF4-FFF2-40B4-BE49-F238E27FC236}">
-                <a16:creationId xmlns:a16="http://schemas.microsoft.com/office/drawing/2014/main" id="{59E04181-8408-483E-9DCE-32536B210FB1}"/>
+                <a16:creationId xmlns:a16="http://schemas.microsoft.com/office/drawing/2014/main" id="{4A2C007C-10D4-4E2F-B319-01B3C3E9123E}"/>
               </a:ext>
             </a:extLst>
           </p:cNvPr>
@@ -7679,7 +7679,7 @@
           <p:cNvPr id="5" name="">
             <a:extLst xmlns:a="http://schemas.openxmlformats.org/drawingml/2006/main">
               <a:ext uri="{FF2B5EF4-FFF2-40B4-BE49-F238E27FC236}">
-                <a16:creationId xmlns:a16="http://schemas.microsoft.com/office/drawing/2014/main" id="{B2A184E7-335B-4FBC-BB08-B924DB137B3A}"/>
+                <a16:creationId xmlns:a16="http://schemas.microsoft.com/office/drawing/2014/main" id="{1721AEA1-B872-4518-A68F-4148F67EAF8D}"/>
               </a:ext>
             </a:extLst>
           </p:cNvPr>
@@ -7729,7 +7729,7 @@
           <p:cNvPr id="6" name="">
             <a:extLst xmlns:a="http://schemas.openxmlformats.org/drawingml/2006/main">
               <a:ext uri="{FF2B5EF4-FFF2-40B4-BE49-F238E27FC236}">
-                <a16:creationId xmlns:a16="http://schemas.microsoft.com/office/drawing/2014/main" id="{76BDAB18-D97A-470C-A69A-BF39A039A67A}"/>
+                <a16:creationId xmlns:a16="http://schemas.microsoft.com/office/drawing/2014/main" id="{CF68D572-0F13-45F8-9D73-5BE7017DA614}"/>
               </a:ext>
             </a:extLst>
           </p:cNvPr>
@@ -7779,7 +7779,7 @@
           <p:cNvPr id="7" name="">
             <a:extLst xmlns:a="http://schemas.openxmlformats.org/drawingml/2006/main">
               <a:ext uri="{FF2B5EF4-FFF2-40B4-BE49-F238E27FC236}">
-                <a16:creationId xmlns:a16="http://schemas.microsoft.com/office/drawing/2014/main" id="{516E2324-2ABA-4DA9-8835-25C003A2CD96}"/>
+                <a16:creationId xmlns:a16="http://schemas.microsoft.com/office/drawing/2014/main" id="{4C8492CB-71F9-4755-9698-C9D475CB923A}"/>
               </a:ext>
             </a:extLst>
           </p:cNvPr>
@@ -7812,7 +7812,7 @@
           <p:cNvPr id="8" name="">
             <a:extLst xmlns:a="http://schemas.openxmlformats.org/drawingml/2006/main">
               <a:ext uri="{FF2B5EF4-FFF2-40B4-BE49-F238E27FC236}">
-                <a16:creationId xmlns:a16="http://schemas.microsoft.com/office/drawing/2014/main" id="{4B88D7BB-7CAB-4C69-A945-D40E83B08911}"/>
+                <a16:creationId xmlns:a16="http://schemas.microsoft.com/office/drawing/2014/main" id="{7EE35B83-5414-48BF-80D5-BD4EB5228F07}"/>
               </a:ext>
             </a:extLst>
           </p:cNvPr>
@@ -7845,7 +7845,7 @@
           <p:cNvPr id="9" name="">
             <a:extLst xmlns:a="http://schemas.openxmlformats.org/drawingml/2006/main">
               <a:ext uri="{FF2B5EF4-FFF2-40B4-BE49-F238E27FC236}">
-                <a16:creationId xmlns:a16="http://schemas.microsoft.com/office/drawing/2014/main" id="{2C924098-AD7D-419D-A399-2F0E1F73D173}"/>
+                <a16:creationId xmlns:a16="http://schemas.microsoft.com/office/drawing/2014/main" id="{B724A138-3D89-49DD-8AF8-CC69AD1ECC7A}"/>
               </a:ext>
             </a:extLst>
           </p:cNvPr>
@@ -7895,7 +7895,7 @@
           <p:cNvPr id="10" name="">
             <a:extLst xmlns:a="http://schemas.openxmlformats.org/drawingml/2006/main">
               <a:ext uri="{FF2B5EF4-FFF2-40B4-BE49-F238E27FC236}">
-                <a16:creationId xmlns:a16="http://schemas.microsoft.com/office/drawing/2014/main" id="{96535D55-B66E-4FE9-89A3-6F63B304624D}"/>
+                <a16:creationId xmlns:a16="http://schemas.microsoft.com/office/drawing/2014/main" id="{D322515D-2B2B-4215-858B-E5E0517EE367}"/>
               </a:ext>
             </a:extLst>
           </p:cNvPr>
@@ -7945,7 +7945,7 @@
           <p:cNvPr id="11" name="">
             <a:extLst xmlns:a="http://schemas.openxmlformats.org/drawingml/2006/main">
               <a:ext uri="{FF2B5EF4-FFF2-40B4-BE49-F238E27FC236}">
-                <a16:creationId xmlns:a16="http://schemas.microsoft.com/office/drawing/2014/main" id="{B1B122AF-3342-440D-9393-09AB6A1F5B04}"/>
+                <a16:creationId xmlns:a16="http://schemas.microsoft.com/office/drawing/2014/main" id="{401BA7AB-38B7-4D9A-BA11-271D2D6A212F}"/>
               </a:ext>
             </a:extLst>
           </p:cNvPr>
@@ -7995,7 +7995,7 @@
           <p:cNvPr id="12" name="">
             <a:extLst xmlns:a="http://schemas.openxmlformats.org/drawingml/2006/main">
               <a:ext uri="{FF2B5EF4-FFF2-40B4-BE49-F238E27FC236}">
-                <a16:creationId xmlns:a16="http://schemas.microsoft.com/office/drawing/2014/main" id="{2DB2CAF7-0413-48F0-A8C4-1808B262E976}"/>
+                <a16:creationId xmlns:a16="http://schemas.microsoft.com/office/drawing/2014/main" id="{AA31B8DD-C67B-4CCD-BE60-F001CA39FC6A}"/>
               </a:ext>
             </a:extLst>
           </p:cNvPr>
@@ -8028,7 +8028,7 @@
           <p:cNvPr id="13" name="">
             <a:extLst xmlns:a="http://schemas.openxmlformats.org/drawingml/2006/main">
               <a:ext uri="{FF2B5EF4-FFF2-40B4-BE49-F238E27FC236}">
-                <a16:creationId xmlns:a16="http://schemas.microsoft.com/office/drawing/2014/main" id="{7F0DD69D-9DC9-45DC-BCAC-588BEEB8A351}"/>
+                <a16:creationId xmlns:a16="http://schemas.microsoft.com/office/drawing/2014/main" id="{3A9EA3C4-42C6-41D7-BB5E-657B044CC53C}"/>
               </a:ext>
             </a:extLst>
           </p:cNvPr>
@@ -8078,7 +8078,7 @@
           <p:cNvPr id="14" name="">
             <a:extLst xmlns:a="http://schemas.openxmlformats.org/drawingml/2006/main">
               <a:ext uri="{FF2B5EF4-FFF2-40B4-BE49-F238E27FC236}">
-                <a16:creationId xmlns:a16="http://schemas.microsoft.com/office/drawing/2014/main" id="{6398775A-2A8F-4AC7-8488-873E82BDE6D9}"/>
+                <a16:creationId xmlns:a16="http://schemas.microsoft.com/office/drawing/2014/main" id="{518F615D-78C4-4634-ABB9-54C58DF78C38}"/>
               </a:ext>
             </a:extLst>
           </p:cNvPr>
@@ -8128,7 +8128,7 @@
           <p:cNvPr id="15" name="">
             <a:extLst xmlns:a="http://schemas.openxmlformats.org/drawingml/2006/main">
               <a:ext uri="{FF2B5EF4-FFF2-40B4-BE49-F238E27FC236}">
-                <a16:creationId xmlns:a16="http://schemas.microsoft.com/office/drawing/2014/main" id="{1C02B9F2-3198-410F-8A6D-F6060F32BC38}"/>
+                <a16:creationId xmlns:a16="http://schemas.microsoft.com/office/drawing/2014/main" id="{C298409F-F56D-43BB-B837-074ECC22519C}"/>
               </a:ext>
             </a:extLst>
           </p:cNvPr>
@@ -8178,7 +8178,7 @@
           <p:cNvPr id="16" name="">
             <a:extLst xmlns:a="http://schemas.openxmlformats.org/drawingml/2006/main">
               <a:ext uri="{FF2B5EF4-FFF2-40B4-BE49-F238E27FC236}">
-                <a16:creationId xmlns:a16="http://schemas.microsoft.com/office/drawing/2014/main" id="{4348EB67-2F98-41C6-9733-1B39BBEE8EEF}"/>
+                <a16:creationId xmlns:a16="http://schemas.microsoft.com/office/drawing/2014/main" id="{0F9DDE5F-C2C2-435E-BAC3-8BC61E829CCB}"/>
               </a:ext>
             </a:extLst>
           </p:cNvPr>
@@ -8211,7 +8211,7 @@
           <p:cNvPr id="17" name="">
             <a:extLst xmlns:a="http://schemas.openxmlformats.org/drawingml/2006/main">
               <a:ext uri="{FF2B5EF4-FFF2-40B4-BE49-F238E27FC236}">
-                <a16:creationId xmlns:a16="http://schemas.microsoft.com/office/drawing/2014/main" id="{120EC758-C42F-4271-BAA0-51A4404588C7}"/>
+                <a16:creationId xmlns:a16="http://schemas.microsoft.com/office/drawing/2014/main" id="{19CD60FF-4777-475B-9BB4-9462439C1362}"/>
               </a:ext>
             </a:extLst>
           </p:cNvPr>
@@ -8261,7 +8261,7 @@
           <p:cNvPr id="18" name="">
             <a:extLst xmlns:a="http://schemas.openxmlformats.org/drawingml/2006/main">
               <a:ext uri="{FF2B5EF4-FFF2-40B4-BE49-F238E27FC236}">
-                <a16:creationId xmlns:a16="http://schemas.microsoft.com/office/drawing/2014/main" id="{3CAEDBD0-99B2-46C9-866F-C248786497A6}"/>
+                <a16:creationId xmlns:a16="http://schemas.microsoft.com/office/drawing/2014/main" id="{E95A9129-2182-4D1B-AF11-B9743FDAD96E}"/>
               </a:ext>
             </a:extLst>
           </p:cNvPr>
@@ -8311,7 +8311,7 @@
           <p:cNvPr id="19" name="">
             <a:extLst xmlns:a="http://schemas.openxmlformats.org/drawingml/2006/main">
               <a:ext uri="{FF2B5EF4-FFF2-40B4-BE49-F238E27FC236}">
-                <a16:creationId xmlns:a16="http://schemas.microsoft.com/office/drawing/2014/main" id="{27D0AEC6-BDE9-4423-B44E-F577161AF4E5}"/>
+                <a16:creationId xmlns:a16="http://schemas.microsoft.com/office/drawing/2014/main" id="{4ED11E82-EB76-49E9-BDD2-FDE7E16C9163}"/>
               </a:ext>
             </a:extLst>
           </p:cNvPr>
@@ -8361,7 +8361,7 @@
           <p:cNvPr id="20" name="">
             <a:extLst xmlns:a="http://schemas.openxmlformats.org/drawingml/2006/main">
               <a:ext uri="{FF2B5EF4-FFF2-40B4-BE49-F238E27FC236}">
-                <a16:creationId xmlns:a16="http://schemas.microsoft.com/office/drawing/2014/main" id="{D4318247-67BC-47CD-BB11-DD1908A074F6}"/>
+                <a16:creationId xmlns:a16="http://schemas.microsoft.com/office/drawing/2014/main" id="{7FA8AABD-20D8-41EB-BB95-8C3CEA9E32D2}"/>
               </a:ext>
             </a:extLst>
           </p:cNvPr>
@@ -8394,7 +8394,7 @@
           <p:cNvPr id="21" name="">
             <a:extLst xmlns:a="http://schemas.openxmlformats.org/drawingml/2006/main">
               <a:ext uri="{FF2B5EF4-FFF2-40B4-BE49-F238E27FC236}">
-                <a16:creationId xmlns:a16="http://schemas.microsoft.com/office/drawing/2014/main" id="{7768FC1C-A00D-4F87-8E26-68F3101DE35D}"/>
+                <a16:creationId xmlns:a16="http://schemas.microsoft.com/office/drawing/2014/main" id="{E096EE9E-0B90-417A-897C-33E7E3ABCD1A}"/>
               </a:ext>
             </a:extLst>
           </p:cNvPr>
@@ -8444,7 +8444,7 @@
           <p:cNvPr id="22" name="">
             <a:extLst xmlns:a="http://schemas.openxmlformats.org/drawingml/2006/main">
               <a:ext uri="{FF2B5EF4-FFF2-40B4-BE49-F238E27FC236}">
-                <a16:creationId xmlns:a16="http://schemas.microsoft.com/office/drawing/2014/main" id="{F1ACB069-7184-4592-8DD2-0C1A995F3200}"/>
+                <a16:creationId xmlns:a16="http://schemas.microsoft.com/office/drawing/2014/main" id="{80EAC3AD-C922-4D93-B3AB-E9CB3C818350}"/>
               </a:ext>
             </a:extLst>
           </p:cNvPr>
@@ -8494,7 +8494,7 @@
           <p:cNvPr id="23" name="">
             <a:extLst xmlns:a="http://schemas.openxmlformats.org/drawingml/2006/main">
               <a:ext uri="{FF2B5EF4-FFF2-40B4-BE49-F238E27FC236}">
-                <a16:creationId xmlns:a16="http://schemas.microsoft.com/office/drawing/2014/main" id="{C1C07129-F7B5-4D13-9FAA-4F85C01F6F17}"/>
+                <a16:creationId xmlns:a16="http://schemas.microsoft.com/office/drawing/2014/main" id="{28E7D584-CC99-480A-B9FA-E7BB3802EF99}"/>
               </a:ext>
             </a:extLst>
           </p:cNvPr>
@@ -8544,7 +8544,7 @@
           <p:cNvPr id="24" name="">
             <a:extLst xmlns:a="http://schemas.openxmlformats.org/drawingml/2006/main">
               <a:ext uri="{FF2B5EF4-FFF2-40B4-BE49-F238E27FC236}">
-                <a16:creationId xmlns:a16="http://schemas.microsoft.com/office/drawing/2014/main" id="{1620C359-2AB3-4B5A-AB1E-02C11A75695D}"/>
+                <a16:creationId xmlns:a16="http://schemas.microsoft.com/office/drawing/2014/main" id="{504A8C70-A179-4CD8-9E95-4FE57C2D9D76}"/>
               </a:ext>
             </a:extLst>
           </p:cNvPr>
@@ -8577,7 +8577,7 @@
           <p:cNvPr id="25" name="">
             <a:extLst xmlns:a="http://schemas.openxmlformats.org/drawingml/2006/main">
               <a:ext uri="{FF2B5EF4-FFF2-40B4-BE49-F238E27FC236}">
-                <a16:creationId xmlns:a16="http://schemas.microsoft.com/office/drawing/2014/main" id="{7743797A-0DB3-4A7A-95F1-C8140AACEFC2}"/>
+                <a16:creationId xmlns:a16="http://schemas.microsoft.com/office/drawing/2014/main" id="{4D7FE873-BEF7-4691-A925-6139C3C0ED33}"/>
               </a:ext>
             </a:extLst>
           </p:cNvPr>
@@ -8627,7 +8627,7 @@
           <p:cNvPr id="26" name="">
             <a:extLst xmlns:a="http://schemas.openxmlformats.org/drawingml/2006/main">
               <a:ext uri="{FF2B5EF4-FFF2-40B4-BE49-F238E27FC236}">
-                <a16:creationId xmlns:a16="http://schemas.microsoft.com/office/drawing/2014/main" id="{9F441301-33BF-42E5-95A3-69425476277A}"/>
+                <a16:creationId xmlns:a16="http://schemas.microsoft.com/office/drawing/2014/main" id="{97226BA3-FCF4-47FD-98D8-4AA556584A15}"/>
               </a:ext>
             </a:extLst>
           </p:cNvPr>
@@ -8677,7 +8677,7 @@
           <p:cNvPr id="27" name="">
             <a:extLst xmlns:a="http://schemas.openxmlformats.org/drawingml/2006/main">
               <a:ext uri="{FF2B5EF4-FFF2-40B4-BE49-F238E27FC236}">
-                <a16:creationId xmlns:a16="http://schemas.microsoft.com/office/drawing/2014/main" id="{8059EACF-465D-49F5-9058-50CD65476BD6}"/>
+                <a16:creationId xmlns:a16="http://schemas.microsoft.com/office/drawing/2014/main" id="{2A10F9F0-76A4-49E9-9CCA-D87DBE0A5D1B}"/>
               </a:ext>
             </a:extLst>
           </p:cNvPr>
@@ -8727,7 +8727,7 @@
           <p:cNvPr id="28" name="">
             <a:extLst xmlns:a="http://schemas.openxmlformats.org/drawingml/2006/main">
               <a:ext uri="{FF2B5EF4-FFF2-40B4-BE49-F238E27FC236}">
-                <a16:creationId xmlns:a16="http://schemas.microsoft.com/office/drawing/2014/main" id="{7ECF5A3F-BBD2-410D-8A0F-7C320E3C5B95}"/>
+                <a16:creationId xmlns:a16="http://schemas.microsoft.com/office/drawing/2014/main" id="{2FE91D7D-4A7A-41A8-B389-FA9361761271}"/>
               </a:ext>
             </a:extLst>
           </p:cNvPr>
@@ -8777,7 +8777,7 @@
           <p:cNvPr id="29" name="">
             <a:extLst xmlns:a="http://schemas.openxmlformats.org/drawingml/2006/main">
               <a:ext uri="{FF2B5EF4-FFF2-40B4-BE49-F238E27FC236}">
-                <a16:creationId xmlns:a16="http://schemas.microsoft.com/office/drawing/2014/main" id="{98BAE4FE-43C8-4A38-BFAD-81069DFC2B4B}"/>
+                <a16:creationId xmlns:a16="http://schemas.microsoft.com/office/drawing/2014/main" id="{0779565B-5E28-4A16-BCC0-B4F33F623044}"/>
               </a:ext>
             </a:extLst>
           </p:cNvPr>
@@ -8827,7 +8827,7 @@
           <p:cNvPr id="30" name="">
             <a:extLst xmlns:a="http://schemas.openxmlformats.org/drawingml/2006/main">
               <a:ext uri="{FF2B5EF4-FFF2-40B4-BE49-F238E27FC236}">
-                <a16:creationId xmlns:a16="http://schemas.microsoft.com/office/drawing/2014/main" id="{7D424947-3F2C-43B2-9E26-6734235464FB}"/>
+                <a16:creationId xmlns:a16="http://schemas.microsoft.com/office/drawing/2014/main" id="{DA5279CE-ED9A-4D29-B0A0-8C5869702ADF}"/>
               </a:ext>
             </a:extLst>
           </p:cNvPr>
@@ -8877,7 +8877,7 @@
           <p:cNvPr id="31" name="">
             <a:extLst xmlns:a="http://schemas.openxmlformats.org/drawingml/2006/main">
               <a:ext uri="{FF2B5EF4-FFF2-40B4-BE49-F238E27FC236}">
-                <a16:creationId xmlns:a16="http://schemas.microsoft.com/office/drawing/2014/main" id="{D0591666-9BF7-48E0-90B3-3CC638FADBC0}"/>
+                <a16:creationId xmlns:a16="http://schemas.microsoft.com/office/drawing/2014/main" id="{4A566CB9-06F5-47E4-A24C-6FAD83F60068}"/>
               </a:ext>
             </a:extLst>
           </p:cNvPr>
@@ -8925,7 +8925,7 @@
     </p:spTree>
     <p:extLst>
       <p:ext uri="{BB962C8B-B14F-4D97-AF65-F5344CB8AC3E}">
-        <p14:creationId xmlns:p14="http://schemas.microsoft.com/office/powerpoint/2010/main" val="1391234860"/>
+        <p14:creationId xmlns:p14="http://schemas.microsoft.com/office/powerpoint/2010/main" val="293576918"/>
       </p:ext>
     </p:extLst>
   </p:cSld>
@@ -8956,7 +8956,7 @@
           <p:cNvPr id="27" name="">
             <a:extLst xmlns:a="http://schemas.openxmlformats.org/drawingml/2006/main">
               <a:ext uri="{FF2B5EF4-FFF2-40B4-BE49-F238E27FC236}">
-                <a16:creationId xmlns:a16="http://schemas.microsoft.com/office/drawing/2014/main" id="{00AD4C66-4435-4803-8767-962B03D20121}"/>
+                <a16:creationId xmlns:a16="http://schemas.microsoft.com/office/drawing/2014/main" id="{7C9B370B-5F67-49D3-9E11-DA20B88B8FF6}"/>
               </a:ext>
             </a:extLst>
           </p:cNvPr>
@@ -9006,7 +9006,7 @@
           <p:cNvPr id="2" name="">
             <a:extLst xmlns:a="http://schemas.openxmlformats.org/drawingml/2006/main">
               <a:ext uri="{FF2B5EF4-FFF2-40B4-BE49-F238E27FC236}">
-                <a16:creationId xmlns:a16="http://schemas.microsoft.com/office/drawing/2014/main" id="{A9ADC573-68E5-41AA-9F55-28B51D61DD3B}"/>
+                <a16:creationId xmlns:a16="http://schemas.microsoft.com/office/drawing/2014/main" id="{8D564363-F67F-46A9-90E8-62C83B56FB96}"/>
               </a:ext>
             </a:extLst>
           </p:cNvPr>
@@ -9056,7 +9056,7 @@
           <p:cNvPr id="3" name="">
             <a:extLst xmlns:a="http://schemas.openxmlformats.org/drawingml/2006/main">
               <a:ext uri="{FF2B5EF4-FFF2-40B4-BE49-F238E27FC236}">
-                <a16:creationId xmlns:a16="http://schemas.microsoft.com/office/drawing/2014/main" id="{29334070-12FA-4F89-8031-7AA09C43FA04}"/>
+                <a16:creationId xmlns:a16="http://schemas.microsoft.com/office/drawing/2014/main" id="{C7CF2939-AAE9-4489-872B-0F8562C1729E}"/>
               </a:ext>
             </a:extLst>
           </p:cNvPr>
@@ -9089,7 +9089,7 @@
           <p:cNvPr id="4" name="">
             <a:extLst xmlns:a="http://schemas.openxmlformats.org/drawingml/2006/main">
               <a:ext uri="{FF2B5EF4-FFF2-40B4-BE49-F238E27FC236}">
-                <a16:creationId xmlns:a16="http://schemas.microsoft.com/office/drawing/2014/main" id="{BA484D30-BE62-46FD-833F-5BC100CB30C8}"/>
+                <a16:creationId xmlns:a16="http://schemas.microsoft.com/office/drawing/2014/main" id="{542229B6-B958-4B22-8A3F-508DAF63B2BD}"/>
               </a:ext>
             </a:extLst>
           </p:cNvPr>
@@ -9139,7 +9139,7 @@
           <p:cNvPr id="5" name="">
             <a:extLst xmlns:a="http://schemas.openxmlformats.org/drawingml/2006/main">
               <a:ext uri="{FF2B5EF4-FFF2-40B4-BE49-F238E27FC236}">
-                <a16:creationId xmlns:a16="http://schemas.microsoft.com/office/drawing/2014/main" id="{8875905F-7A3F-48B0-8064-C9A1F454723E}"/>
+                <a16:creationId xmlns:a16="http://schemas.microsoft.com/office/drawing/2014/main" id="{E6262E13-A789-40DF-ABFD-544BEF244071}"/>
               </a:ext>
             </a:extLst>
           </p:cNvPr>
@@ -9189,7 +9189,7 @@
           <p:cNvPr id="6" name="">
             <a:extLst xmlns:a="http://schemas.openxmlformats.org/drawingml/2006/main">
               <a:ext uri="{FF2B5EF4-FFF2-40B4-BE49-F238E27FC236}">
-                <a16:creationId xmlns:a16="http://schemas.microsoft.com/office/drawing/2014/main" id="{AF878BE0-A2B3-4F16-9597-B903B5241864}"/>
+                <a16:creationId xmlns:a16="http://schemas.microsoft.com/office/drawing/2014/main" id="{890BD5EC-6465-40A6-9FAE-7A2051309DF6}"/>
               </a:ext>
             </a:extLst>
           </p:cNvPr>
@@ -9239,7 +9239,7 @@
           <p:cNvPr id="7" name="">
             <a:extLst xmlns:a="http://schemas.openxmlformats.org/drawingml/2006/main">
               <a:ext uri="{FF2B5EF4-FFF2-40B4-BE49-F238E27FC236}">
-                <a16:creationId xmlns:a16="http://schemas.microsoft.com/office/drawing/2014/main" id="{5C8667B3-3C48-4AB5-9167-83C3ECF34227}"/>
+                <a16:creationId xmlns:a16="http://schemas.microsoft.com/office/drawing/2014/main" id="{FF728095-510C-4C52-BA83-CA5CB12EA6F6}"/>
               </a:ext>
             </a:extLst>
           </p:cNvPr>
@@ -9274,7 +9274,7 @@
           <p:cNvPr id="8" name="">
             <a:extLst xmlns:a="http://schemas.openxmlformats.org/drawingml/2006/main">
               <a:ext uri="{FF2B5EF4-FFF2-40B4-BE49-F238E27FC236}">
-                <a16:creationId xmlns:a16="http://schemas.microsoft.com/office/drawing/2014/main" id="{18A227D4-F0E5-4B20-B57C-AC8947BB684F}"/>
+                <a16:creationId xmlns:a16="http://schemas.microsoft.com/office/drawing/2014/main" id="{A9485D4B-C925-4E7F-8B59-38CB98E1548F}"/>
               </a:ext>
             </a:extLst>
           </p:cNvPr>
@@ -9324,7 +9324,7 @@
           <p:cNvPr id="9" name="">
             <a:extLst xmlns:a="http://schemas.openxmlformats.org/drawingml/2006/main">
               <a:ext uri="{FF2B5EF4-FFF2-40B4-BE49-F238E27FC236}">
-                <a16:creationId xmlns:a16="http://schemas.microsoft.com/office/drawing/2014/main" id="{3DA1E55A-D5F7-444B-8648-06EB0BBF2F13}"/>
+                <a16:creationId xmlns:a16="http://schemas.microsoft.com/office/drawing/2014/main" id="{B1CFBC79-C1DA-4030-B846-784A1EF1606F}"/>
               </a:ext>
             </a:extLst>
           </p:cNvPr>
@@ -9374,7 +9374,7 @@
           <p:cNvPr id="10" name="">
             <a:extLst xmlns:a="http://schemas.openxmlformats.org/drawingml/2006/main">
               <a:ext uri="{FF2B5EF4-FFF2-40B4-BE49-F238E27FC236}">
-                <a16:creationId xmlns:a16="http://schemas.microsoft.com/office/drawing/2014/main" id="{A43ED044-5F10-4C1A-9CA1-30E1A3AB233C}"/>
+                <a16:creationId xmlns:a16="http://schemas.microsoft.com/office/drawing/2014/main" id="{19EE9D79-7651-4FB6-A65E-716074CA59FC}"/>
               </a:ext>
             </a:extLst>
           </p:cNvPr>
@@ -9409,7 +9409,7 @@
           <p:cNvPr id="11" name="">
             <a:extLst xmlns:a="http://schemas.openxmlformats.org/drawingml/2006/main">
               <a:ext uri="{FF2B5EF4-FFF2-40B4-BE49-F238E27FC236}">
-                <a16:creationId xmlns:a16="http://schemas.microsoft.com/office/drawing/2014/main" id="{EC39DF80-0431-45D2-81CC-5DDCB5FD9AEB}"/>
+                <a16:creationId xmlns:a16="http://schemas.microsoft.com/office/drawing/2014/main" id="{39920F6C-4D8B-4449-90DF-13CA6158ED53}"/>
               </a:ext>
             </a:extLst>
           </p:cNvPr>
@@ -9459,7 +9459,7 @@
           <p:cNvPr id="12" name="">
             <a:extLst xmlns:a="http://schemas.openxmlformats.org/drawingml/2006/main">
               <a:ext uri="{FF2B5EF4-FFF2-40B4-BE49-F238E27FC236}">
-                <a16:creationId xmlns:a16="http://schemas.microsoft.com/office/drawing/2014/main" id="{E6A7B381-2BD0-4451-9CB6-2306919DBC5A}"/>
+                <a16:creationId xmlns:a16="http://schemas.microsoft.com/office/drawing/2014/main" id="{9D1ADBB2-F8D1-4BC4-A63B-6463D7B5EFF0}"/>
               </a:ext>
             </a:extLst>
           </p:cNvPr>
@@ -9509,7 +9509,7 @@
           <p:cNvPr id="13" name="">
             <a:extLst xmlns:a="http://schemas.openxmlformats.org/drawingml/2006/main">
               <a:ext uri="{FF2B5EF4-FFF2-40B4-BE49-F238E27FC236}">
-                <a16:creationId xmlns:a16="http://schemas.microsoft.com/office/drawing/2014/main" id="{2F493AD3-DFD4-4D67-971A-449E5E6288B5}"/>
+                <a16:creationId xmlns:a16="http://schemas.microsoft.com/office/drawing/2014/main" id="{6A286A80-7D69-43E4-AE59-59F816B96929}"/>
               </a:ext>
             </a:extLst>
           </p:cNvPr>
@@ -9544,7 +9544,7 @@
           <p:cNvPr id="14" name="">
             <a:extLst xmlns:a="http://schemas.openxmlformats.org/drawingml/2006/main">
               <a:ext uri="{FF2B5EF4-FFF2-40B4-BE49-F238E27FC236}">
-                <a16:creationId xmlns:a16="http://schemas.microsoft.com/office/drawing/2014/main" id="{CA7D3936-43E6-4357-A16C-02E362CD9A45}"/>
+                <a16:creationId xmlns:a16="http://schemas.microsoft.com/office/drawing/2014/main" id="{CCA82A47-7BFE-4495-91FD-C0F94974119B}"/>
               </a:ext>
             </a:extLst>
           </p:cNvPr>
@@ -9594,7 +9594,7 @@
           <p:cNvPr id="15" name="">
             <a:extLst xmlns:a="http://schemas.openxmlformats.org/drawingml/2006/main">
               <a:ext uri="{FF2B5EF4-FFF2-40B4-BE49-F238E27FC236}">
-                <a16:creationId xmlns:a16="http://schemas.microsoft.com/office/drawing/2014/main" id="{35A242A7-BF48-45D8-8132-BA5146DC46A9}"/>
+                <a16:creationId xmlns:a16="http://schemas.microsoft.com/office/drawing/2014/main" id="{1E551DC6-6350-4FA1-9A06-7CAA96AC8287}"/>
               </a:ext>
             </a:extLst>
           </p:cNvPr>
@@ -9644,7 +9644,7 @@
           <p:cNvPr id="16" name="">
             <a:extLst xmlns:a="http://schemas.openxmlformats.org/drawingml/2006/main">
               <a:ext uri="{FF2B5EF4-FFF2-40B4-BE49-F238E27FC236}">
-                <a16:creationId xmlns:a16="http://schemas.microsoft.com/office/drawing/2014/main" id="{AC8C6FC3-55CF-4E11-8E56-01A9A6799216}"/>
+                <a16:creationId xmlns:a16="http://schemas.microsoft.com/office/drawing/2014/main" id="{DE585848-AFD1-4BD9-A4CE-21A6A678E9F5}"/>
               </a:ext>
             </a:extLst>
           </p:cNvPr>
@@ -9679,7 +9679,7 @@
           <p:cNvPr id="17" name="">
             <a:extLst xmlns:a="http://schemas.openxmlformats.org/drawingml/2006/main">
               <a:ext uri="{FF2B5EF4-FFF2-40B4-BE49-F238E27FC236}">
-                <a16:creationId xmlns:a16="http://schemas.microsoft.com/office/drawing/2014/main" id="{E49520BC-2161-4594-99A0-1EE18A22D846}"/>
+                <a16:creationId xmlns:a16="http://schemas.microsoft.com/office/drawing/2014/main" id="{6FB3417B-4657-4E38-AB12-E3AD1543BE44}"/>
               </a:ext>
             </a:extLst>
           </p:cNvPr>
@@ -9729,7 +9729,7 @@
           <p:cNvPr id="18" name="">
             <a:extLst xmlns:a="http://schemas.openxmlformats.org/drawingml/2006/main">
               <a:ext uri="{FF2B5EF4-FFF2-40B4-BE49-F238E27FC236}">
-                <a16:creationId xmlns:a16="http://schemas.microsoft.com/office/drawing/2014/main" id="{B1EEEFBD-E103-409A-9BD3-EDA69945C809}"/>
+                <a16:creationId xmlns:a16="http://schemas.microsoft.com/office/drawing/2014/main" id="{43DCC258-6C1A-4926-805A-91856FED3A99}"/>
               </a:ext>
             </a:extLst>
           </p:cNvPr>
@@ -9779,7 +9779,7 @@
           <p:cNvPr id="19" name="">
             <a:extLst xmlns:a="http://schemas.openxmlformats.org/drawingml/2006/main">
               <a:ext uri="{FF2B5EF4-FFF2-40B4-BE49-F238E27FC236}">
-                <a16:creationId xmlns:a16="http://schemas.microsoft.com/office/drawing/2014/main" id="{D9FAC6B7-EF17-4E6A-8B4F-BC0CDC054CC0}"/>
+                <a16:creationId xmlns:a16="http://schemas.microsoft.com/office/drawing/2014/main" id="{38DA86B9-41EC-4EC2-85E5-29186C2B5627}"/>
               </a:ext>
             </a:extLst>
           </p:cNvPr>
@@ -9814,7 +9814,7 @@
           <p:cNvPr id="20" name="">
             <a:extLst xmlns:a="http://schemas.openxmlformats.org/drawingml/2006/main">
               <a:ext uri="{FF2B5EF4-FFF2-40B4-BE49-F238E27FC236}">
-                <a16:creationId xmlns:a16="http://schemas.microsoft.com/office/drawing/2014/main" id="{155D8B1F-DAE0-444D-B61D-0D30D6F5BE00}"/>
+                <a16:creationId xmlns:a16="http://schemas.microsoft.com/office/drawing/2014/main" id="{1FD8EC48-215F-4FB4-8D51-03DD34446140}"/>
               </a:ext>
             </a:extLst>
           </p:cNvPr>
@@ -9864,7 +9864,7 @@
           <p:cNvPr id="21" name="">
             <a:extLst xmlns:a="http://schemas.openxmlformats.org/drawingml/2006/main">
               <a:ext uri="{FF2B5EF4-FFF2-40B4-BE49-F238E27FC236}">
-                <a16:creationId xmlns:a16="http://schemas.microsoft.com/office/drawing/2014/main" id="{FF161F1F-8845-49EA-90E6-9FAB90812A1D}"/>
+                <a16:creationId xmlns:a16="http://schemas.microsoft.com/office/drawing/2014/main" id="{0D693C12-38B4-4A16-8352-2A72F3D22065}"/>
               </a:ext>
             </a:extLst>
           </p:cNvPr>
@@ -9914,7 +9914,7 @@
           <p:cNvPr id="22" name="">
             <a:extLst xmlns:a="http://schemas.openxmlformats.org/drawingml/2006/main">
               <a:ext uri="{FF2B5EF4-FFF2-40B4-BE49-F238E27FC236}">
-                <a16:creationId xmlns:a16="http://schemas.microsoft.com/office/drawing/2014/main" id="{9C528E8D-4235-46ED-8877-513BDAF00B78}"/>
+                <a16:creationId xmlns:a16="http://schemas.microsoft.com/office/drawing/2014/main" id="{5A4836B3-8D0E-48BB-B67C-347950C4859F}"/>
               </a:ext>
             </a:extLst>
           </p:cNvPr>
@@ -9949,7 +9949,7 @@
           <p:cNvPr id="23" name="">
             <a:extLst xmlns:a="http://schemas.openxmlformats.org/drawingml/2006/main">
               <a:ext uri="{FF2B5EF4-FFF2-40B4-BE49-F238E27FC236}">
-                <a16:creationId xmlns:a16="http://schemas.microsoft.com/office/drawing/2014/main" id="{042203D4-CD7E-496D-8769-4980CD79A126}"/>
+                <a16:creationId xmlns:a16="http://schemas.microsoft.com/office/drawing/2014/main" id="{1DC6C5F9-2D1F-491F-A7F4-B58D55A24880}"/>
               </a:ext>
             </a:extLst>
           </p:cNvPr>
@@ -9999,7 +9999,7 @@
           <p:cNvPr id="24" name="">
             <a:extLst xmlns:a="http://schemas.openxmlformats.org/drawingml/2006/main">
               <a:ext uri="{FF2B5EF4-FFF2-40B4-BE49-F238E27FC236}">
-                <a16:creationId xmlns:a16="http://schemas.microsoft.com/office/drawing/2014/main" id="{F3D6AD1F-DA3E-462D-A2F7-9B6E5CD3C3C4}"/>
+                <a16:creationId xmlns:a16="http://schemas.microsoft.com/office/drawing/2014/main" id="{DA1BA2A2-44FE-4357-BDE3-9A81DAC63D65}"/>
               </a:ext>
             </a:extLst>
           </p:cNvPr>
@@ -10049,7 +10049,7 @@
           <p:cNvPr id="25" name="">
             <a:extLst xmlns:a="http://schemas.openxmlformats.org/drawingml/2006/main">
               <a:ext uri="{FF2B5EF4-FFF2-40B4-BE49-F238E27FC236}">
-                <a16:creationId xmlns:a16="http://schemas.microsoft.com/office/drawing/2014/main" id="{9707ACAA-1030-46E2-8888-B6DBFF163275}"/>
+                <a16:creationId xmlns:a16="http://schemas.microsoft.com/office/drawing/2014/main" id="{B0C03833-D73C-46A6-94C3-A8DB84852744}"/>
               </a:ext>
             </a:extLst>
           </p:cNvPr>
@@ -10099,7 +10099,7 @@
           <p:cNvPr id="26" name="">
             <a:extLst xmlns:a="http://schemas.openxmlformats.org/drawingml/2006/main">
               <a:ext uri="{FF2B5EF4-FFF2-40B4-BE49-F238E27FC236}">
-                <a16:creationId xmlns:a16="http://schemas.microsoft.com/office/drawing/2014/main" id="{0D43A7E0-FE15-47E8-A5AA-76C63AB86532}"/>
+                <a16:creationId xmlns:a16="http://schemas.microsoft.com/office/drawing/2014/main" id="{CEC7E95C-E035-4258-A9FA-1D26E16C1EDF}"/>
               </a:ext>
             </a:extLst>
           </p:cNvPr>
@@ -10147,7 +10147,7 @@
     </p:spTree>
     <p:extLst>
       <p:ext uri="{BB962C8B-B14F-4D97-AF65-F5344CB8AC3E}">
-        <p14:creationId xmlns:p14="http://schemas.microsoft.com/office/powerpoint/2010/main" val="245176172"/>
+        <p14:creationId xmlns:p14="http://schemas.microsoft.com/office/powerpoint/2010/main" val="1966869379"/>
       </p:ext>
     </p:extLst>
   </p:cSld>
@@ -10178,7 +10178,7 @@
           <p:cNvPr id="27" name="">
             <a:extLst xmlns:a="http://schemas.openxmlformats.org/drawingml/2006/main">
               <a:ext uri="{FF2B5EF4-FFF2-40B4-BE49-F238E27FC236}">
-                <a16:creationId xmlns:a16="http://schemas.microsoft.com/office/drawing/2014/main" id="{F6F5AFA5-7C70-43C5-8801-B8F16B7E5AC3}"/>
+                <a16:creationId xmlns:a16="http://schemas.microsoft.com/office/drawing/2014/main" id="{90AE5F52-8172-4DD7-BF11-4D7F4F8DF4D6}"/>
               </a:ext>
             </a:extLst>
           </p:cNvPr>
@@ -10228,7 +10228,7 @@
           <p:cNvPr id="2" name="">
             <a:extLst xmlns:a="http://schemas.openxmlformats.org/drawingml/2006/main">
               <a:ext uri="{FF2B5EF4-FFF2-40B4-BE49-F238E27FC236}">
-                <a16:creationId xmlns:a16="http://schemas.microsoft.com/office/drawing/2014/main" id="{37FAEE4E-7538-4DAE-845C-5AA2FF8D4978}"/>
+                <a16:creationId xmlns:a16="http://schemas.microsoft.com/office/drawing/2014/main" id="{96A8A719-8BF7-4A9C-8D73-630E1B64459E}"/>
               </a:ext>
             </a:extLst>
           </p:cNvPr>
@@ -10278,7 +10278,7 @@
           <p:cNvPr id="3" name="">
             <a:extLst xmlns:a="http://schemas.openxmlformats.org/drawingml/2006/main">
               <a:ext uri="{FF2B5EF4-FFF2-40B4-BE49-F238E27FC236}">
-                <a16:creationId xmlns:a16="http://schemas.microsoft.com/office/drawing/2014/main" id="{965FB854-E634-49CE-A9B9-137C9E73E55C}"/>
+                <a16:creationId xmlns:a16="http://schemas.microsoft.com/office/drawing/2014/main" id="{61666746-CECC-4CFB-A6A0-D48B96E639F5}"/>
               </a:ext>
             </a:extLst>
           </p:cNvPr>
@@ -10311,7 +10311,7 @@
           <p:cNvPr id="4" name="">
             <a:extLst xmlns:a="http://schemas.openxmlformats.org/drawingml/2006/main">
               <a:ext uri="{FF2B5EF4-FFF2-40B4-BE49-F238E27FC236}">
-                <a16:creationId xmlns:a16="http://schemas.microsoft.com/office/drawing/2014/main" id="{2A9DBA4A-9C62-4B3D-A308-0A47786E810B}"/>
+                <a16:creationId xmlns:a16="http://schemas.microsoft.com/office/drawing/2014/main" id="{FE5210F3-9684-4C20-8D45-DD32D2A3A133}"/>
               </a:ext>
             </a:extLst>
           </p:cNvPr>
@@ -10361,7 +10361,7 @@
           <p:cNvPr id="5" name="">
             <a:extLst xmlns:a="http://schemas.openxmlformats.org/drawingml/2006/main">
               <a:ext uri="{FF2B5EF4-FFF2-40B4-BE49-F238E27FC236}">
-                <a16:creationId xmlns:a16="http://schemas.microsoft.com/office/drawing/2014/main" id="{07D3DB98-DF5B-4F0F-A40E-53957C6D7E68}"/>
+                <a16:creationId xmlns:a16="http://schemas.microsoft.com/office/drawing/2014/main" id="{0915E3A5-7A82-4FF7-A57D-3BC756729670}"/>
               </a:ext>
             </a:extLst>
           </p:cNvPr>
@@ -10411,7 +10411,7 @@
           <p:cNvPr id="6" name="">
             <a:extLst xmlns:a="http://schemas.openxmlformats.org/drawingml/2006/main">
               <a:ext uri="{FF2B5EF4-FFF2-40B4-BE49-F238E27FC236}">
-                <a16:creationId xmlns:a16="http://schemas.microsoft.com/office/drawing/2014/main" id="{AFBA2AFF-7351-4B71-B68E-367505D8C132}"/>
+                <a16:creationId xmlns:a16="http://schemas.microsoft.com/office/drawing/2014/main" id="{FA7ECBA2-1C4B-450C-9CF4-AEC66533EF17}"/>
               </a:ext>
             </a:extLst>
           </p:cNvPr>
@@ -10461,7 +10461,7 @@
           <p:cNvPr id="7" name="">
             <a:extLst xmlns:a="http://schemas.openxmlformats.org/drawingml/2006/main">
               <a:ext uri="{FF2B5EF4-FFF2-40B4-BE49-F238E27FC236}">
-                <a16:creationId xmlns:a16="http://schemas.microsoft.com/office/drawing/2014/main" id="{9CE9A229-0FA2-4F64-91E4-5684C870FE1E}"/>
+                <a16:creationId xmlns:a16="http://schemas.microsoft.com/office/drawing/2014/main" id="{415D9F49-94BC-4124-A220-DE18A09099D6}"/>
               </a:ext>
             </a:extLst>
           </p:cNvPr>
@@ -10511,7 +10511,7 @@
           <p:cNvPr id="8" name="">
             <a:extLst xmlns:a="http://schemas.openxmlformats.org/drawingml/2006/main">
               <a:ext uri="{FF2B5EF4-FFF2-40B4-BE49-F238E27FC236}">
-                <a16:creationId xmlns:a16="http://schemas.microsoft.com/office/drawing/2014/main" id="{A5163EE2-BBD2-44FC-B5D1-51FF02CC81D4}"/>
+                <a16:creationId xmlns:a16="http://schemas.microsoft.com/office/drawing/2014/main" id="{FDA42091-9145-4D48-9EBA-0A4F9F350FD6}"/>
               </a:ext>
             </a:extLst>
           </p:cNvPr>
@@ -10561,7 +10561,7 @@
           <p:cNvPr id="9" name="">
             <a:extLst xmlns:a="http://schemas.openxmlformats.org/drawingml/2006/main">
               <a:ext uri="{FF2B5EF4-FFF2-40B4-BE49-F238E27FC236}">
-                <a16:creationId xmlns:a16="http://schemas.microsoft.com/office/drawing/2014/main" id="{A6B7CAFD-BAAA-4533-BB7E-60D1250AE47A}"/>
+                <a16:creationId xmlns:a16="http://schemas.microsoft.com/office/drawing/2014/main" id="{92C43BDC-9E20-4892-B611-104F06308C7F}"/>
               </a:ext>
             </a:extLst>
           </p:cNvPr>
@@ -10611,7 +10611,7 @@
           <p:cNvPr id="10" name="">
             <a:extLst xmlns:a="http://schemas.openxmlformats.org/drawingml/2006/main">
               <a:ext uri="{FF2B5EF4-FFF2-40B4-BE49-F238E27FC236}">
-                <a16:creationId xmlns:a16="http://schemas.microsoft.com/office/drawing/2014/main" id="{F5B8484F-5AE1-4159-8A0C-D14A64063686}"/>
+                <a16:creationId xmlns:a16="http://schemas.microsoft.com/office/drawing/2014/main" id="{A5550B32-8D57-48C3-8995-9FC1D0351E35}"/>
               </a:ext>
             </a:extLst>
           </p:cNvPr>
@@ -10661,7 +10661,7 @@
           <p:cNvPr id="11" name="">
             <a:extLst xmlns:a="http://schemas.openxmlformats.org/drawingml/2006/main">
               <a:ext uri="{FF2B5EF4-FFF2-40B4-BE49-F238E27FC236}">
-                <a16:creationId xmlns:a16="http://schemas.microsoft.com/office/drawing/2014/main" id="{CFB03AF1-3B4C-434F-BAEA-AE09D6D9CB32}"/>
+                <a16:creationId xmlns:a16="http://schemas.microsoft.com/office/drawing/2014/main" id="{E6399DB2-1A5B-495F-8A64-C8773102837C}"/>
               </a:ext>
             </a:extLst>
           </p:cNvPr>
@@ -10711,7 +10711,7 @@
           <p:cNvPr id="12" name="">
             <a:extLst xmlns:a="http://schemas.openxmlformats.org/drawingml/2006/main">
               <a:ext uri="{FF2B5EF4-FFF2-40B4-BE49-F238E27FC236}">
-                <a16:creationId xmlns:a16="http://schemas.microsoft.com/office/drawing/2014/main" id="{C7F54889-E1D6-4206-AD64-AFFB26F13458}"/>
+                <a16:creationId xmlns:a16="http://schemas.microsoft.com/office/drawing/2014/main" id="{D5588785-5CB9-4EB6-B656-E2F86E53FA84}"/>
               </a:ext>
             </a:extLst>
           </p:cNvPr>
@@ -10761,7 +10761,7 @@
           <p:cNvPr id="13" name="">
             <a:extLst xmlns:a="http://schemas.openxmlformats.org/drawingml/2006/main">
               <a:ext uri="{FF2B5EF4-FFF2-40B4-BE49-F238E27FC236}">
-                <a16:creationId xmlns:a16="http://schemas.microsoft.com/office/drawing/2014/main" id="{29DA6C93-38AE-47D2-B714-F0501828CAA2}"/>
+                <a16:creationId xmlns:a16="http://schemas.microsoft.com/office/drawing/2014/main" id="{0F3676F0-A509-4A86-A9BA-3D9616C5ED00}"/>
               </a:ext>
             </a:extLst>
           </p:cNvPr>
@@ -10811,7 +10811,7 @@
           <p:cNvPr id="14" name="">
             <a:extLst xmlns:a="http://schemas.openxmlformats.org/drawingml/2006/main">
               <a:ext uri="{FF2B5EF4-FFF2-40B4-BE49-F238E27FC236}">
-                <a16:creationId xmlns:a16="http://schemas.microsoft.com/office/drawing/2014/main" id="{C29930B8-F821-4F35-B22B-BF6963B3F12E}"/>
+                <a16:creationId xmlns:a16="http://schemas.microsoft.com/office/drawing/2014/main" id="{0EAFCA26-60D2-493F-A141-24AB567B803D}"/>
               </a:ext>
             </a:extLst>
           </p:cNvPr>
@@ -10861,7 +10861,7 @@
           <p:cNvPr id="15" name="">
             <a:extLst xmlns:a="http://schemas.openxmlformats.org/drawingml/2006/main">
               <a:ext uri="{FF2B5EF4-FFF2-40B4-BE49-F238E27FC236}">
-                <a16:creationId xmlns:a16="http://schemas.microsoft.com/office/drawing/2014/main" id="{A7A9A27A-4625-4A6F-928E-7C8DF0EB8FA9}"/>
+                <a16:creationId xmlns:a16="http://schemas.microsoft.com/office/drawing/2014/main" id="{284356B6-DAF9-4A9A-8BB8-1EBB263395AE}"/>
               </a:ext>
             </a:extLst>
           </p:cNvPr>
@@ -10911,7 +10911,7 @@
           <p:cNvPr id="16" name="">
             <a:extLst xmlns:a="http://schemas.openxmlformats.org/drawingml/2006/main">
               <a:ext uri="{FF2B5EF4-FFF2-40B4-BE49-F238E27FC236}">
-                <a16:creationId xmlns:a16="http://schemas.microsoft.com/office/drawing/2014/main" id="{B5FA143D-4C51-40AB-A4DF-CB2D3B7E6E50}"/>
+                <a16:creationId xmlns:a16="http://schemas.microsoft.com/office/drawing/2014/main" id="{A5499F68-420C-487F-AEFB-D290A1F108C8}"/>
               </a:ext>
             </a:extLst>
           </p:cNvPr>
@@ -10961,7 +10961,7 @@
           <p:cNvPr id="17" name="">
             <a:extLst xmlns:a="http://schemas.openxmlformats.org/drawingml/2006/main">
               <a:ext uri="{FF2B5EF4-FFF2-40B4-BE49-F238E27FC236}">
-                <a16:creationId xmlns:a16="http://schemas.microsoft.com/office/drawing/2014/main" id="{7CBDEE29-A148-44A9-971F-4F9C9478C01C}"/>
+                <a16:creationId xmlns:a16="http://schemas.microsoft.com/office/drawing/2014/main" id="{85C6A46A-A57D-43D8-8A88-13666D5E3711}"/>
               </a:ext>
             </a:extLst>
           </p:cNvPr>
@@ -11011,7 +11011,7 @@
           <p:cNvPr id="18" name="">
             <a:extLst xmlns:a="http://schemas.openxmlformats.org/drawingml/2006/main">
               <a:ext uri="{FF2B5EF4-FFF2-40B4-BE49-F238E27FC236}">
-                <a16:creationId xmlns:a16="http://schemas.microsoft.com/office/drawing/2014/main" id="{11021D47-4682-4BD8-B9F8-759F834C086A}"/>
+                <a16:creationId xmlns:a16="http://schemas.microsoft.com/office/drawing/2014/main" id="{A3C92FC7-8638-433C-B173-31CEF7708026}"/>
               </a:ext>
             </a:extLst>
           </p:cNvPr>
@@ -11061,7 +11061,7 @@
           <p:cNvPr id="19" name="">
             <a:extLst xmlns:a="http://schemas.openxmlformats.org/drawingml/2006/main">
               <a:ext uri="{FF2B5EF4-FFF2-40B4-BE49-F238E27FC236}">
-                <a16:creationId xmlns:a16="http://schemas.microsoft.com/office/drawing/2014/main" id="{8551A08F-D1AA-4796-A1E1-9DE60B13290F}"/>
+                <a16:creationId xmlns:a16="http://schemas.microsoft.com/office/drawing/2014/main" id="{07358AA8-5C54-4366-86CC-8DA45A73AB27}"/>
               </a:ext>
             </a:extLst>
           </p:cNvPr>
@@ -11111,7 +11111,7 @@
           <p:cNvPr id="20" name="">
             <a:extLst xmlns:a="http://schemas.openxmlformats.org/drawingml/2006/main">
               <a:ext uri="{FF2B5EF4-FFF2-40B4-BE49-F238E27FC236}">
-                <a16:creationId xmlns:a16="http://schemas.microsoft.com/office/drawing/2014/main" id="{64ADE7D8-E78D-4771-BA32-9ABB3D20664B}"/>
+                <a16:creationId xmlns:a16="http://schemas.microsoft.com/office/drawing/2014/main" id="{47D30C82-FDDB-46BF-872A-057A8FB5C3EB}"/>
               </a:ext>
             </a:extLst>
           </p:cNvPr>
@@ -11161,7 +11161,7 @@
           <p:cNvPr id="21" name="">
             <a:extLst xmlns:a="http://schemas.openxmlformats.org/drawingml/2006/main">
               <a:ext uri="{FF2B5EF4-FFF2-40B4-BE49-F238E27FC236}">
-                <a16:creationId xmlns:a16="http://schemas.microsoft.com/office/drawing/2014/main" id="{8A21EC88-7836-4A74-BC0A-C942205A8AAD}"/>
+                <a16:creationId xmlns:a16="http://schemas.microsoft.com/office/drawing/2014/main" id="{13FBA3FD-851A-48EA-B6DA-8F3140E4100E}"/>
               </a:ext>
             </a:extLst>
           </p:cNvPr>
@@ -11211,7 +11211,7 @@
           <p:cNvPr id="22" name="">
             <a:extLst xmlns:a="http://schemas.openxmlformats.org/drawingml/2006/main">
               <a:ext uri="{FF2B5EF4-FFF2-40B4-BE49-F238E27FC236}">
-                <a16:creationId xmlns:a16="http://schemas.microsoft.com/office/drawing/2014/main" id="{B6867113-F48B-47AC-8B2E-A9DFB1639984}"/>
+                <a16:creationId xmlns:a16="http://schemas.microsoft.com/office/drawing/2014/main" id="{60B3FF17-5C67-4FDE-B716-E01BDC13036C}"/>
               </a:ext>
             </a:extLst>
           </p:cNvPr>
@@ -11261,7 +11261,7 @@
           <p:cNvPr id="23" name="">
             <a:extLst xmlns:a="http://schemas.openxmlformats.org/drawingml/2006/main">
               <a:ext uri="{FF2B5EF4-FFF2-40B4-BE49-F238E27FC236}">
-                <a16:creationId xmlns:a16="http://schemas.microsoft.com/office/drawing/2014/main" id="{9B84A003-384E-4F7F-947A-65A1F199FBC8}"/>
+                <a16:creationId xmlns:a16="http://schemas.microsoft.com/office/drawing/2014/main" id="{3792BA88-42C7-4C6A-B82C-43D453A28497}"/>
               </a:ext>
             </a:extLst>
           </p:cNvPr>
@@ -11311,7 +11311,7 @@
           <p:cNvPr id="24" name="">
             <a:extLst xmlns:a="http://schemas.openxmlformats.org/drawingml/2006/main">
               <a:ext uri="{FF2B5EF4-FFF2-40B4-BE49-F238E27FC236}">
-                <a16:creationId xmlns:a16="http://schemas.microsoft.com/office/drawing/2014/main" id="{7A15A4E5-9E15-4B3E-82BB-E48C5811C1B9}"/>
+                <a16:creationId xmlns:a16="http://schemas.microsoft.com/office/drawing/2014/main" id="{C149C0C8-6939-494F-A1A0-3EDA1EABE241}"/>
               </a:ext>
             </a:extLst>
           </p:cNvPr>
@@ -11361,7 +11361,7 @@
           <p:cNvPr id="25" name="">
             <a:extLst xmlns:a="http://schemas.openxmlformats.org/drawingml/2006/main">
               <a:ext uri="{FF2B5EF4-FFF2-40B4-BE49-F238E27FC236}">
-                <a16:creationId xmlns:a16="http://schemas.microsoft.com/office/drawing/2014/main" id="{EE4534D3-CEAB-4E88-BD47-6B40C3DB6FAE}"/>
+                <a16:creationId xmlns:a16="http://schemas.microsoft.com/office/drawing/2014/main" id="{294841BB-4DCC-4098-A075-8C621C776AC4}"/>
               </a:ext>
             </a:extLst>
           </p:cNvPr>
@@ -11411,7 +11411,7 @@
           <p:cNvPr id="26" name="">
             <a:extLst xmlns:a="http://schemas.openxmlformats.org/drawingml/2006/main">
               <a:ext uri="{FF2B5EF4-FFF2-40B4-BE49-F238E27FC236}">
-                <a16:creationId xmlns:a16="http://schemas.microsoft.com/office/drawing/2014/main" id="{9603AE5C-1EE5-4446-874B-5C131A4A2A6C}"/>
+                <a16:creationId xmlns:a16="http://schemas.microsoft.com/office/drawing/2014/main" id="{A1740DC2-F054-4E3D-8B7C-60675D95F856}"/>
               </a:ext>
             </a:extLst>
           </p:cNvPr>
@@ -11459,7 +11459,7 @@
     </p:spTree>
     <p:extLst>
       <p:ext uri="{BB962C8B-B14F-4D97-AF65-F5344CB8AC3E}">
-        <p14:creationId xmlns:p14="http://schemas.microsoft.com/office/powerpoint/2010/main" val="632105971"/>
+        <p14:creationId xmlns:p14="http://schemas.microsoft.com/office/powerpoint/2010/main" val="758335378"/>
       </p:ext>
     </p:extLst>
   </p:cSld>
@@ -11490,7 +11490,7 @@
           <p:cNvPr id="27" name="">
             <a:extLst xmlns:a="http://schemas.openxmlformats.org/drawingml/2006/main">
               <a:ext uri="{FF2B5EF4-FFF2-40B4-BE49-F238E27FC236}">
-                <a16:creationId xmlns:a16="http://schemas.microsoft.com/office/drawing/2014/main" id="{3C3797B3-3A49-438A-9AFD-43E271F75D47}"/>
+                <a16:creationId xmlns:a16="http://schemas.microsoft.com/office/drawing/2014/main" id="{0D7BF778-E8EA-4796-883B-3A46EA6FD203}"/>
               </a:ext>
             </a:extLst>
           </p:cNvPr>
@@ -11540,7 +11540,7 @@
           <p:cNvPr id="2" name="">
             <a:extLst xmlns:a="http://schemas.openxmlformats.org/drawingml/2006/main">
               <a:ext uri="{FF2B5EF4-FFF2-40B4-BE49-F238E27FC236}">
-                <a16:creationId xmlns:a16="http://schemas.microsoft.com/office/drawing/2014/main" id="{462BE2E7-6EEA-4873-A65E-4DA594451645}"/>
+                <a16:creationId xmlns:a16="http://schemas.microsoft.com/office/drawing/2014/main" id="{16FE5CDC-F3FA-4DD4-8BB1-672DB6495AB0}"/>
               </a:ext>
             </a:extLst>
           </p:cNvPr>
@@ -11590,7 +11590,7 @@
           <p:cNvPr id="3" name="">
             <a:extLst xmlns:a="http://schemas.openxmlformats.org/drawingml/2006/main">
               <a:ext uri="{FF2B5EF4-FFF2-40B4-BE49-F238E27FC236}">
-                <a16:creationId xmlns:a16="http://schemas.microsoft.com/office/drawing/2014/main" id="{BE0462C2-82EF-46AB-A64A-BB2304FA016D}"/>
+                <a16:creationId xmlns:a16="http://schemas.microsoft.com/office/drawing/2014/main" id="{CE451DAA-F5CA-4B90-ABB1-4464EB6E2486}"/>
               </a:ext>
             </a:extLst>
           </p:cNvPr>
@@ -11623,7 +11623,7 @@
           <p:cNvPr id="4" name="">
             <a:extLst xmlns:a="http://schemas.openxmlformats.org/drawingml/2006/main">
               <a:ext uri="{FF2B5EF4-FFF2-40B4-BE49-F238E27FC236}">
-                <a16:creationId xmlns:a16="http://schemas.microsoft.com/office/drawing/2014/main" id="{A46EB3A8-61A4-4D73-A69A-D9F6A72063D6}"/>
+                <a16:creationId xmlns:a16="http://schemas.microsoft.com/office/drawing/2014/main" id="{02776FE5-B6BB-4A13-BB1B-25FB93D5D603}"/>
               </a:ext>
             </a:extLst>
           </p:cNvPr>
@@ -11673,7 +11673,7 @@
           <p:cNvPr id="5" name="">
             <a:extLst xmlns:a="http://schemas.openxmlformats.org/drawingml/2006/main">
               <a:ext uri="{FF2B5EF4-FFF2-40B4-BE49-F238E27FC236}">
-                <a16:creationId xmlns:a16="http://schemas.microsoft.com/office/drawing/2014/main" id="{0DF38A6B-A035-4376-B11B-083B0F0A335E}"/>
+                <a16:creationId xmlns:a16="http://schemas.microsoft.com/office/drawing/2014/main" id="{71CD73E2-6C7D-468B-B934-6C2BBF5B8A88}"/>
               </a:ext>
             </a:extLst>
           </p:cNvPr>
@@ -11723,7 +11723,7 @@
           <p:cNvPr id="6" name="">
             <a:extLst xmlns:a="http://schemas.openxmlformats.org/drawingml/2006/main">
               <a:ext uri="{FF2B5EF4-FFF2-40B4-BE49-F238E27FC236}">
-                <a16:creationId xmlns:a16="http://schemas.microsoft.com/office/drawing/2014/main" id="{F1D7AEA2-B495-40E7-90C9-FA4C622B16AA}"/>
+                <a16:creationId xmlns:a16="http://schemas.microsoft.com/office/drawing/2014/main" id="{5E515F7C-633A-4FBF-AD3E-95BB3C2BD03A}"/>
               </a:ext>
             </a:extLst>
           </p:cNvPr>
@@ -11773,7 +11773,7 @@
           <p:cNvPr id="7" name="">
             <a:extLst xmlns:a="http://schemas.openxmlformats.org/drawingml/2006/main">
               <a:ext uri="{FF2B5EF4-FFF2-40B4-BE49-F238E27FC236}">
-                <a16:creationId xmlns:a16="http://schemas.microsoft.com/office/drawing/2014/main" id="{D3CF9C12-B68D-49A4-A69E-2C13ED33D0D2}"/>
+                <a16:creationId xmlns:a16="http://schemas.microsoft.com/office/drawing/2014/main" id="{F8EE4BDE-5F27-4227-A864-7D12EAC9E679}"/>
               </a:ext>
             </a:extLst>
           </p:cNvPr>
@@ -11808,7 +11808,7 @@
           <p:cNvPr id="8" name="">
             <a:extLst xmlns:a="http://schemas.openxmlformats.org/drawingml/2006/main">
               <a:ext uri="{FF2B5EF4-FFF2-40B4-BE49-F238E27FC236}">
-                <a16:creationId xmlns:a16="http://schemas.microsoft.com/office/drawing/2014/main" id="{D7408621-1BA8-4CD0-9EE4-15E338533D2E}"/>
+                <a16:creationId xmlns:a16="http://schemas.microsoft.com/office/drawing/2014/main" id="{05AE6630-7B2D-4673-B154-15154950E076}"/>
               </a:ext>
             </a:extLst>
           </p:cNvPr>
@@ -11858,7 +11858,7 @@
           <p:cNvPr id="9" name="">
             <a:extLst xmlns:a="http://schemas.openxmlformats.org/drawingml/2006/main">
               <a:ext uri="{FF2B5EF4-FFF2-40B4-BE49-F238E27FC236}">
-                <a16:creationId xmlns:a16="http://schemas.microsoft.com/office/drawing/2014/main" id="{883BDB81-089B-4CFD-8C99-9FF7557F67F3}"/>
+                <a16:creationId xmlns:a16="http://schemas.microsoft.com/office/drawing/2014/main" id="{A8A173F2-747F-4350-8FC6-ADCAF6294398}"/>
               </a:ext>
             </a:extLst>
           </p:cNvPr>
@@ -11908,7 +11908,7 @@
           <p:cNvPr id="10" name="">
             <a:extLst xmlns:a="http://schemas.openxmlformats.org/drawingml/2006/main">
               <a:ext uri="{FF2B5EF4-FFF2-40B4-BE49-F238E27FC236}">
-                <a16:creationId xmlns:a16="http://schemas.microsoft.com/office/drawing/2014/main" id="{15126A6D-9857-4E20-9B0C-DA5737AD9D90}"/>
+                <a16:creationId xmlns:a16="http://schemas.microsoft.com/office/drawing/2014/main" id="{F90043F3-6410-48B5-9479-CE949EE0DC80}"/>
               </a:ext>
             </a:extLst>
           </p:cNvPr>
@@ -11943,7 +11943,7 @@
           <p:cNvPr id="11" name="">
             <a:extLst xmlns:a="http://schemas.openxmlformats.org/drawingml/2006/main">
               <a:ext uri="{FF2B5EF4-FFF2-40B4-BE49-F238E27FC236}">
-                <a16:creationId xmlns:a16="http://schemas.microsoft.com/office/drawing/2014/main" id="{D1F5B477-06A9-46FE-8772-61ABAC491791}"/>
+                <a16:creationId xmlns:a16="http://schemas.microsoft.com/office/drawing/2014/main" id="{31582E98-ACE0-44AF-8688-83E0E0A42AC7}"/>
               </a:ext>
             </a:extLst>
           </p:cNvPr>
@@ -11993,7 +11993,7 @@
           <p:cNvPr id="12" name="">
             <a:extLst xmlns:a="http://schemas.openxmlformats.org/drawingml/2006/main">
               <a:ext uri="{FF2B5EF4-FFF2-40B4-BE49-F238E27FC236}">
-                <a16:creationId xmlns:a16="http://schemas.microsoft.com/office/drawing/2014/main" id="{5D01AC8A-8841-480A-916F-AE94C7E7A7E6}"/>
+                <a16:creationId xmlns:a16="http://schemas.microsoft.com/office/drawing/2014/main" id="{2C6C7F2C-467A-42FA-9FA4-4A98204BB0C3}"/>
               </a:ext>
             </a:extLst>
           </p:cNvPr>
@@ -12043,7 +12043,7 @@
           <p:cNvPr id="13" name="">
             <a:extLst xmlns:a="http://schemas.openxmlformats.org/drawingml/2006/main">
               <a:ext uri="{FF2B5EF4-FFF2-40B4-BE49-F238E27FC236}">
-                <a16:creationId xmlns:a16="http://schemas.microsoft.com/office/drawing/2014/main" id="{A933CC87-B55E-471C-B916-09CD5FB04668}"/>
+                <a16:creationId xmlns:a16="http://schemas.microsoft.com/office/drawing/2014/main" id="{E56E2184-C847-4074-BE2B-7D08FB42AFC1}"/>
               </a:ext>
             </a:extLst>
           </p:cNvPr>
@@ -12078,7 +12078,7 @@
           <p:cNvPr id="14" name="">
             <a:extLst xmlns:a="http://schemas.openxmlformats.org/drawingml/2006/main">
               <a:ext uri="{FF2B5EF4-FFF2-40B4-BE49-F238E27FC236}">
-                <a16:creationId xmlns:a16="http://schemas.microsoft.com/office/drawing/2014/main" id="{E94DE55B-1423-4CF8-B924-BBF70CA4DEEA}"/>
+                <a16:creationId xmlns:a16="http://schemas.microsoft.com/office/drawing/2014/main" id="{369D835A-CC3C-4566-91EB-5B32482788B3}"/>
               </a:ext>
             </a:extLst>
           </p:cNvPr>
@@ -12128,7 +12128,7 @@
           <p:cNvPr id="15" name="">
             <a:extLst xmlns:a="http://schemas.openxmlformats.org/drawingml/2006/main">
               <a:ext uri="{FF2B5EF4-FFF2-40B4-BE49-F238E27FC236}">
-                <a16:creationId xmlns:a16="http://schemas.microsoft.com/office/drawing/2014/main" id="{804AB2A0-994F-415B-A8C9-98780FF8AB50}"/>
+                <a16:creationId xmlns:a16="http://schemas.microsoft.com/office/drawing/2014/main" id="{D51EA596-0BC2-4B22-BC09-B089E33DEF79}"/>
               </a:ext>
             </a:extLst>
           </p:cNvPr>
@@ -12178,7 +12178,7 @@
           <p:cNvPr id="16" name="">
             <a:extLst xmlns:a="http://schemas.openxmlformats.org/drawingml/2006/main">
               <a:ext uri="{FF2B5EF4-FFF2-40B4-BE49-F238E27FC236}">
-                <a16:creationId xmlns:a16="http://schemas.microsoft.com/office/drawing/2014/main" id="{CC725227-6CA3-4F2C-ABC5-5FD447F2305A}"/>
+                <a16:creationId xmlns:a16="http://schemas.microsoft.com/office/drawing/2014/main" id="{C9561533-376D-4905-891B-D4C7BA7BB3FE}"/>
               </a:ext>
             </a:extLst>
           </p:cNvPr>
@@ -12213,7 +12213,7 @@
           <p:cNvPr id="17" name="">
             <a:extLst xmlns:a="http://schemas.openxmlformats.org/drawingml/2006/main">
               <a:ext uri="{FF2B5EF4-FFF2-40B4-BE49-F238E27FC236}">
-                <a16:creationId xmlns:a16="http://schemas.microsoft.com/office/drawing/2014/main" id="{C3AC2A2A-B8B4-4C5E-81D0-58FBE602A9D7}"/>
+                <a16:creationId xmlns:a16="http://schemas.microsoft.com/office/drawing/2014/main" id="{3F2E2371-3B2A-4579-A079-FC641A8A340A}"/>
               </a:ext>
             </a:extLst>
           </p:cNvPr>
@@ -12263,7 +12263,7 @@
           <p:cNvPr id="18" name="">
             <a:extLst xmlns:a="http://schemas.openxmlformats.org/drawingml/2006/main">
               <a:ext uri="{FF2B5EF4-FFF2-40B4-BE49-F238E27FC236}">
-                <a16:creationId xmlns:a16="http://schemas.microsoft.com/office/drawing/2014/main" id="{937F5CB7-541D-46F3-A330-88057C7463A4}"/>
+                <a16:creationId xmlns:a16="http://schemas.microsoft.com/office/drawing/2014/main" id="{0B111292-F7E2-4EB3-AFB2-2630B0208509}"/>
               </a:ext>
             </a:extLst>
           </p:cNvPr>
@@ -12313,7 +12313,7 @@
           <p:cNvPr id="19" name="">
             <a:extLst xmlns:a="http://schemas.openxmlformats.org/drawingml/2006/main">
               <a:ext uri="{FF2B5EF4-FFF2-40B4-BE49-F238E27FC236}">
-                <a16:creationId xmlns:a16="http://schemas.microsoft.com/office/drawing/2014/main" id="{D12D42CA-37B3-4549-8DCC-F6834CA63082}"/>
+                <a16:creationId xmlns:a16="http://schemas.microsoft.com/office/drawing/2014/main" id="{4D063D19-BE84-423D-B3AE-AF11DEEC557C}"/>
               </a:ext>
             </a:extLst>
           </p:cNvPr>
@@ -12363,7 +12363,7 @@
           <p:cNvPr id="20" name="">
             <a:extLst xmlns:a="http://schemas.openxmlformats.org/drawingml/2006/main">
               <a:ext uri="{FF2B5EF4-FFF2-40B4-BE49-F238E27FC236}">
-                <a16:creationId xmlns:a16="http://schemas.microsoft.com/office/drawing/2014/main" id="{E5C921C1-2729-49A0-B9ED-4EED6B745404}"/>
+                <a16:creationId xmlns:a16="http://schemas.microsoft.com/office/drawing/2014/main" id="{73141EB4-C71C-451C-9976-4DA5F1284E11}"/>
               </a:ext>
             </a:extLst>
           </p:cNvPr>
@@ -12413,7 +12413,7 @@
           <p:cNvPr id="21" name="">
             <a:extLst xmlns:a="http://schemas.openxmlformats.org/drawingml/2006/main">
               <a:ext uri="{FF2B5EF4-FFF2-40B4-BE49-F238E27FC236}">
-                <a16:creationId xmlns:a16="http://schemas.microsoft.com/office/drawing/2014/main" id="{487A06AC-E3E2-4569-92FA-7BB73F8CA22F}"/>
+                <a16:creationId xmlns:a16="http://schemas.microsoft.com/office/drawing/2014/main" id="{A57E9E37-3533-4BBC-8D72-601F773986F4}"/>
               </a:ext>
             </a:extLst>
           </p:cNvPr>
@@ -12463,7 +12463,7 @@
           <p:cNvPr id="22" name="">
             <a:extLst xmlns:a="http://schemas.openxmlformats.org/drawingml/2006/main">
               <a:ext uri="{FF2B5EF4-FFF2-40B4-BE49-F238E27FC236}">
-                <a16:creationId xmlns:a16="http://schemas.microsoft.com/office/drawing/2014/main" id="{EC2BCF44-B45B-4F57-9DC9-54C44E2DC140}"/>
+                <a16:creationId xmlns:a16="http://schemas.microsoft.com/office/drawing/2014/main" id="{91950D3D-FE9C-4F9D-A764-E9A7BAFD037A}"/>
               </a:ext>
             </a:extLst>
           </p:cNvPr>
@@ -12513,7 +12513,7 @@
           <p:cNvPr id="23" name="">
             <a:extLst xmlns:a="http://schemas.openxmlformats.org/drawingml/2006/main">
               <a:ext uri="{FF2B5EF4-FFF2-40B4-BE49-F238E27FC236}">
-                <a16:creationId xmlns:a16="http://schemas.microsoft.com/office/drawing/2014/main" id="{ECA90CED-6BE6-455D-9CFC-F2F9B56854FD}"/>
+                <a16:creationId xmlns:a16="http://schemas.microsoft.com/office/drawing/2014/main" id="{C0676C94-CCF5-4778-9C58-BD4B884203FD}"/>
               </a:ext>
             </a:extLst>
           </p:cNvPr>
@@ -12563,7 +12563,7 @@
           <p:cNvPr id="24" name="">
             <a:extLst xmlns:a="http://schemas.openxmlformats.org/drawingml/2006/main">
               <a:ext uri="{FF2B5EF4-FFF2-40B4-BE49-F238E27FC236}">
-                <a16:creationId xmlns:a16="http://schemas.microsoft.com/office/drawing/2014/main" id="{241117B4-B706-495B-85E1-7A0821DD69B8}"/>
+                <a16:creationId xmlns:a16="http://schemas.microsoft.com/office/drawing/2014/main" id="{130FF19D-D9C7-4FEB-B768-767F101DBBD9}"/>
               </a:ext>
             </a:extLst>
           </p:cNvPr>
@@ -12613,7 +12613,7 @@
           <p:cNvPr id="25" name="">
             <a:extLst xmlns:a="http://schemas.openxmlformats.org/drawingml/2006/main">
               <a:ext uri="{FF2B5EF4-FFF2-40B4-BE49-F238E27FC236}">
-                <a16:creationId xmlns:a16="http://schemas.microsoft.com/office/drawing/2014/main" id="{9D2AA9C4-6091-4974-9788-8A53F9E837D1}"/>
+                <a16:creationId xmlns:a16="http://schemas.microsoft.com/office/drawing/2014/main" id="{E9EA2EC2-3707-4EA4-8081-4D721DFD847F}"/>
               </a:ext>
             </a:extLst>
           </p:cNvPr>
@@ -12663,7 +12663,7 @@
           <p:cNvPr id="26" name="">
             <a:extLst xmlns:a="http://schemas.openxmlformats.org/drawingml/2006/main">
               <a:ext uri="{FF2B5EF4-FFF2-40B4-BE49-F238E27FC236}">
-                <a16:creationId xmlns:a16="http://schemas.microsoft.com/office/drawing/2014/main" id="{B25E064E-05FA-4772-A8EA-93D0FC8EBBE0}"/>
+                <a16:creationId xmlns:a16="http://schemas.microsoft.com/office/drawing/2014/main" id="{0132BBF0-0AC9-4383-BBE4-392C11643A08}"/>
               </a:ext>
             </a:extLst>
           </p:cNvPr>
@@ -12711,7 +12711,7 @@
     </p:spTree>
     <p:extLst>
       <p:ext uri="{BB962C8B-B14F-4D97-AF65-F5344CB8AC3E}">
-        <p14:creationId xmlns:p14="http://schemas.microsoft.com/office/powerpoint/2010/main" val="2059108258"/>
+        <p14:creationId xmlns:p14="http://schemas.microsoft.com/office/powerpoint/2010/main" val="1555990536"/>
       </p:ext>
     </p:extLst>
   </p:cSld>
@@ -12742,7 +12742,7 @@
           <p:cNvPr id="21" name="">
             <a:extLst xmlns:a="http://schemas.openxmlformats.org/drawingml/2006/main">
               <a:ext uri="{FF2B5EF4-FFF2-40B4-BE49-F238E27FC236}">
-                <a16:creationId xmlns:a16="http://schemas.microsoft.com/office/drawing/2014/main" id="{B17A95D0-6444-41EC-9F3D-27B8C3F75387}"/>
+                <a16:creationId xmlns:a16="http://schemas.microsoft.com/office/drawing/2014/main" id="{EBD42A3B-76BA-43AA-A3F8-B24EF78D0A34}"/>
               </a:ext>
             </a:extLst>
           </p:cNvPr>
@@ -12792,7 +12792,7 @@
           <p:cNvPr id="2" name="">
             <a:extLst xmlns:a="http://schemas.openxmlformats.org/drawingml/2006/main">
               <a:ext uri="{FF2B5EF4-FFF2-40B4-BE49-F238E27FC236}">
-                <a16:creationId xmlns:a16="http://schemas.microsoft.com/office/drawing/2014/main" id="{4C14717C-405D-4AAA-86FD-3D831D2936DB}"/>
+                <a16:creationId xmlns:a16="http://schemas.microsoft.com/office/drawing/2014/main" id="{DA54765D-4121-4314-9055-1C87678AAF68}"/>
               </a:ext>
             </a:extLst>
           </p:cNvPr>
@@ -12842,7 +12842,7 @@
           <p:cNvPr id="3" name="">
             <a:extLst xmlns:a="http://schemas.openxmlformats.org/drawingml/2006/main">
               <a:ext uri="{FF2B5EF4-FFF2-40B4-BE49-F238E27FC236}">
-                <a16:creationId xmlns:a16="http://schemas.microsoft.com/office/drawing/2014/main" id="{D37FD7CB-EADF-4804-878E-EC7DE735979C}"/>
+                <a16:creationId xmlns:a16="http://schemas.microsoft.com/office/drawing/2014/main" id="{C5357C84-D2A5-4DE3-829B-8C8F2F0A93D8}"/>
               </a:ext>
             </a:extLst>
           </p:cNvPr>
@@ -12875,7 +12875,7 @@
           <p:cNvPr id="4" name="">
             <a:extLst xmlns:a="http://schemas.openxmlformats.org/drawingml/2006/main">
               <a:ext uri="{FF2B5EF4-FFF2-40B4-BE49-F238E27FC236}">
-                <a16:creationId xmlns:a16="http://schemas.microsoft.com/office/drawing/2014/main" id="{FC8F8CCE-C7C3-4A8B-86EC-DFA1DC9E5302}"/>
+                <a16:creationId xmlns:a16="http://schemas.microsoft.com/office/drawing/2014/main" id="{94812D08-AB61-44F4-8F33-BB2AA5CA625E}"/>
               </a:ext>
             </a:extLst>
           </p:cNvPr>
@@ -12925,7 +12925,7 @@
           <p:cNvPr id="5" name="">
             <a:extLst xmlns:a="http://schemas.openxmlformats.org/drawingml/2006/main">
               <a:ext uri="{FF2B5EF4-FFF2-40B4-BE49-F238E27FC236}">
-                <a16:creationId xmlns:a16="http://schemas.microsoft.com/office/drawing/2014/main" id="{1E8C0D87-55AE-472A-A4C5-9AA26DC6BFC0}"/>
+                <a16:creationId xmlns:a16="http://schemas.microsoft.com/office/drawing/2014/main" id="{BC3EE8D7-E539-48FA-AC5F-DB956F048266}"/>
               </a:ext>
             </a:extLst>
           </p:cNvPr>
@@ -12975,7 +12975,7 @@
           <p:cNvPr id="6" name="">
             <a:extLst xmlns:a="http://schemas.openxmlformats.org/drawingml/2006/main">
               <a:ext uri="{FF2B5EF4-FFF2-40B4-BE49-F238E27FC236}">
-                <a16:creationId xmlns:a16="http://schemas.microsoft.com/office/drawing/2014/main" id="{759504CA-1BA4-41B1-9BC7-4284BEF57D43}"/>
+                <a16:creationId xmlns:a16="http://schemas.microsoft.com/office/drawing/2014/main" id="{754269E5-B85D-447E-87A2-062F46657C17}"/>
               </a:ext>
             </a:extLst>
           </p:cNvPr>
@@ -13029,8 +13029,8 @@
           <p:nvPr/>
         </p:nvPicPr>
         <p:blipFill>
-          <a:blip xmlns:r="http://schemas.openxmlformats.org/officeDocument/2006/relationships" xmlns:a="http://schemas.openxmlformats.org/drawingml/2006/main" r:embed="R2ef9fc0714554dde"/>
-          <a:srcRect xmlns:a="http://schemas.openxmlformats.org/drawingml/2006/main" l="0" t="19315" r="0" b="19315"/>
+          <a:blip xmlns:r="http://schemas.openxmlformats.org/officeDocument/2006/relationships" xmlns:a="http://schemas.openxmlformats.org/drawingml/2006/main" r:embed="Rbba93b1c7f7d4b49"/>
+          <a:srcRect xmlns:a="http://schemas.openxmlformats.org/drawingml/2006/main" l="2508" t="0" r="2508" b="0"/>
           <a:stretch xmlns:a="http://schemas.openxmlformats.org/drawingml/2006/main">
             <a:fillRect l="0" t="0" r="0" b="0"/>
           </a:stretch>
@@ -13052,7 +13052,7 @@
           <p:cNvPr id="8" name="">
             <a:extLst xmlns:a="http://schemas.openxmlformats.org/drawingml/2006/main">
               <a:ext uri="{FF2B5EF4-FFF2-40B4-BE49-F238E27FC236}">
-                <a16:creationId xmlns:a16="http://schemas.microsoft.com/office/drawing/2014/main" id="{8C4CCA41-36A9-470B-B002-A86505C287B3}"/>
+                <a16:creationId xmlns:a16="http://schemas.microsoft.com/office/drawing/2014/main" id="{63E677C3-DDB3-4E0B-AA4B-36BAF9BF3DD3}"/>
               </a:ext>
             </a:extLst>
           </p:cNvPr>
@@ -13102,7 +13102,7 @@
           <p:cNvPr id="9" name="">
             <a:extLst xmlns:a="http://schemas.openxmlformats.org/drawingml/2006/main">
               <a:ext uri="{FF2B5EF4-FFF2-40B4-BE49-F238E27FC236}">
-                <a16:creationId xmlns:a16="http://schemas.microsoft.com/office/drawing/2014/main" id="{A4709FEA-5FCE-4619-95AC-3B383C5F303B}"/>
+                <a16:creationId xmlns:a16="http://schemas.microsoft.com/office/drawing/2014/main" id="{7459D80F-A80E-48AD-9406-3B350BC20D3D}"/>
               </a:ext>
             </a:extLst>
           </p:cNvPr>
@@ -13152,7 +13152,7 @@
           <p:cNvPr id="10" name="">
             <a:extLst xmlns:a="http://schemas.openxmlformats.org/drawingml/2006/main">
               <a:ext uri="{FF2B5EF4-FFF2-40B4-BE49-F238E27FC236}">
-                <a16:creationId xmlns:a16="http://schemas.microsoft.com/office/drawing/2014/main" id="{46F53C29-6033-4957-A700-4934D116AD44}"/>
+                <a16:creationId xmlns:a16="http://schemas.microsoft.com/office/drawing/2014/main" id="{D10B5BD4-A8C1-447D-AE84-B868BFDA9646}"/>
               </a:ext>
             </a:extLst>
           </p:cNvPr>
@@ -13202,7 +13202,7 @@
           <p:cNvPr id="11" name="">
             <a:extLst xmlns:a="http://schemas.openxmlformats.org/drawingml/2006/main">
               <a:ext uri="{FF2B5EF4-FFF2-40B4-BE49-F238E27FC236}">
-                <a16:creationId xmlns:a16="http://schemas.microsoft.com/office/drawing/2014/main" id="{B70798EC-609B-463A-8E02-4C123F4B813E}"/>
+                <a16:creationId xmlns:a16="http://schemas.microsoft.com/office/drawing/2014/main" id="{6666A191-9A39-43A4-B6C0-64A9B58D2E7A}"/>
               </a:ext>
             </a:extLst>
           </p:cNvPr>
@@ -13252,7 +13252,7 @@
           <p:cNvPr id="12" name="">
             <a:extLst xmlns:a="http://schemas.openxmlformats.org/drawingml/2006/main">
               <a:ext uri="{FF2B5EF4-FFF2-40B4-BE49-F238E27FC236}">
-                <a16:creationId xmlns:a16="http://schemas.microsoft.com/office/drawing/2014/main" id="{61B76A51-56AE-46C0-A7AA-CD4343A89106}"/>
+                <a16:creationId xmlns:a16="http://schemas.microsoft.com/office/drawing/2014/main" id="{7C182029-19C0-4B7F-89CA-3DEC5E5D02F9}"/>
               </a:ext>
             </a:extLst>
           </p:cNvPr>
@@ -13302,7 +13302,7 @@
           <p:cNvPr id="13" name="">
             <a:extLst xmlns:a="http://schemas.openxmlformats.org/drawingml/2006/main">
               <a:ext uri="{FF2B5EF4-FFF2-40B4-BE49-F238E27FC236}">
-                <a16:creationId xmlns:a16="http://schemas.microsoft.com/office/drawing/2014/main" id="{C4A6DD94-31E4-4E12-B076-BAFF3827F1D2}"/>
+                <a16:creationId xmlns:a16="http://schemas.microsoft.com/office/drawing/2014/main" id="{E697D2DC-B2F0-4E8A-809B-274023001D89}"/>
               </a:ext>
             </a:extLst>
           </p:cNvPr>
@@ -13352,7 +13352,7 @@
           <p:cNvPr id="14" name="">
             <a:extLst xmlns:a="http://schemas.openxmlformats.org/drawingml/2006/main">
               <a:ext uri="{FF2B5EF4-FFF2-40B4-BE49-F238E27FC236}">
-                <a16:creationId xmlns:a16="http://schemas.microsoft.com/office/drawing/2014/main" id="{AD67DEE7-4E64-4359-AD6D-E93D2F922A22}"/>
+                <a16:creationId xmlns:a16="http://schemas.microsoft.com/office/drawing/2014/main" id="{E0A4F46E-99B2-4D04-B9BE-F6CDD9CACFF1}"/>
               </a:ext>
             </a:extLst>
           </p:cNvPr>
@@ -13402,7 +13402,7 @@
           <p:cNvPr id="15" name="">
             <a:extLst xmlns:a="http://schemas.openxmlformats.org/drawingml/2006/main">
               <a:ext uri="{FF2B5EF4-FFF2-40B4-BE49-F238E27FC236}">
-                <a16:creationId xmlns:a16="http://schemas.microsoft.com/office/drawing/2014/main" id="{8258FEFD-6487-4AE4-8CE1-C94D4B617577}"/>
+                <a16:creationId xmlns:a16="http://schemas.microsoft.com/office/drawing/2014/main" id="{3CDDE066-7CF1-42B6-B0BC-9586BF32D173}"/>
               </a:ext>
             </a:extLst>
           </p:cNvPr>
@@ -13452,7 +13452,7 @@
           <p:cNvPr id="16" name="">
             <a:extLst xmlns:a="http://schemas.openxmlformats.org/drawingml/2006/main">
               <a:ext uri="{FF2B5EF4-FFF2-40B4-BE49-F238E27FC236}">
-                <a16:creationId xmlns:a16="http://schemas.microsoft.com/office/drawing/2014/main" id="{4B7EE0B0-FBEF-4D38-9C7E-DE34C851B0DF}"/>
+                <a16:creationId xmlns:a16="http://schemas.microsoft.com/office/drawing/2014/main" id="{7A7BF210-2CA0-4BAD-B4D1-15D06D1CE190}"/>
               </a:ext>
             </a:extLst>
           </p:cNvPr>
@@ -13502,7 +13502,7 @@
           <p:cNvPr id="17" name="">
             <a:extLst xmlns:a="http://schemas.openxmlformats.org/drawingml/2006/main">
               <a:ext uri="{FF2B5EF4-FFF2-40B4-BE49-F238E27FC236}">
-                <a16:creationId xmlns:a16="http://schemas.microsoft.com/office/drawing/2014/main" id="{9FFDE48C-67F6-4574-BE61-4B07BB0DBCFD}"/>
+                <a16:creationId xmlns:a16="http://schemas.microsoft.com/office/drawing/2014/main" id="{23B0E238-B447-4DDA-BD33-9637118FFDFB}"/>
               </a:ext>
             </a:extLst>
           </p:cNvPr>
@@ -13552,7 +13552,7 @@
           <p:cNvPr id="18" name="">
             <a:extLst xmlns:a="http://schemas.openxmlformats.org/drawingml/2006/main">
               <a:ext uri="{FF2B5EF4-FFF2-40B4-BE49-F238E27FC236}">
-                <a16:creationId xmlns:a16="http://schemas.microsoft.com/office/drawing/2014/main" id="{B81F698A-BF6D-4AFB-9A40-23C6ED3167AA}"/>
+                <a16:creationId xmlns:a16="http://schemas.microsoft.com/office/drawing/2014/main" id="{729EC8EA-C618-4CC5-A7AB-87BC6D446CFF}"/>
               </a:ext>
             </a:extLst>
           </p:cNvPr>
@@ -13602,7 +13602,7 @@
           <p:cNvPr id="19" name="">
             <a:extLst xmlns:a="http://schemas.openxmlformats.org/drawingml/2006/main">
               <a:ext uri="{FF2B5EF4-FFF2-40B4-BE49-F238E27FC236}">
-                <a16:creationId xmlns:a16="http://schemas.microsoft.com/office/drawing/2014/main" id="{77E7853F-FDE1-4779-96E1-82FB7B54A33C}"/>
+                <a16:creationId xmlns:a16="http://schemas.microsoft.com/office/drawing/2014/main" id="{164BE61D-B943-4C0F-9BFF-A038D50D780A}"/>
               </a:ext>
             </a:extLst>
           </p:cNvPr>
@@ -13652,7 +13652,7 @@
           <p:cNvPr id="20" name="">
             <a:extLst xmlns:a="http://schemas.openxmlformats.org/drawingml/2006/main">
               <a:ext uri="{FF2B5EF4-FFF2-40B4-BE49-F238E27FC236}">
-                <a16:creationId xmlns:a16="http://schemas.microsoft.com/office/drawing/2014/main" id="{82E0AF6C-260A-4863-A458-E4A214E5A4A5}"/>
+                <a16:creationId xmlns:a16="http://schemas.microsoft.com/office/drawing/2014/main" id="{14A49715-106C-46F7-A66E-45AB4A147439}"/>
               </a:ext>
             </a:extLst>
           </p:cNvPr>
@@ -13700,7 +13700,7 @@
     </p:spTree>
     <p:extLst>
       <p:ext uri="{BB962C8B-B14F-4D97-AF65-F5344CB8AC3E}">
-        <p14:creationId xmlns:p14="http://schemas.microsoft.com/office/powerpoint/2010/main" val="1925623386"/>
+        <p14:creationId xmlns:p14="http://schemas.microsoft.com/office/powerpoint/2010/main" val="1776476720"/>
       </p:ext>
     </p:extLst>
   </p:cSld>
@@ -13731,7 +13731,7 @@
           <p:cNvPr id="23" name="">
             <a:extLst xmlns:a="http://schemas.openxmlformats.org/drawingml/2006/main">
               <a:ext uri="{FF2B5EF4-FFF2-40B4-BE49-F238E27FC236}">
-                <a16:creationId xmlns:a16="http://schemas.microsoft.com/office/drawing/2014/main" id="{5B0DB1DA-9A20-4AE0-9D17-5C43C70B2BCC}"/>
+                <a16:creationId xmlns:a16="http://schemas.microsoft.com/office/drawing/2014/main" id="{91D3E266-4C3B-44BE-A431-45647DA60F12}"/>
               </a:ext>
             </a:extLst>
           </p:cNvPr>
@@ -13781,7 +13781,7 @@
           <p:cNvPr id="2" name="">
             <a:extLst xmlns:a="http://schemas.openxmlformats.org/drawingml/2006/main">
               <a:ext uri="{FF2B5EF4-FFF2-40B4-BE49-F238E27FC236}">
-                <a16:creationId xmlns:a16="http://schemas.microsoft.com/office/drawing/2014/main" id="{444F9606-D8E8-4774-907B-DAF196EB7FA5}"/>
+                <a16:creationId xmlns:a16="http://schemas.microsoft.com/office/drawing/2014/main" id="{AE1D11DA-8267-469E-9FDB-8B3038C54CE5}"/>
               </a:ext>
             </a:extLst>
           </p:cNvPr>
@@ -13831,7 +13831,7 @@
           <p:cNvPr id="3" name="">
             <a:extLst xmlns:a="http://schemas.openxmlformats.org/drawingml/2006/main">
               <a:ext uri="{FF2B5EF4-FFF2-40B4-BE49-F238E27FC236}">
-                <a16:creationId xmlns:a16="http://schemas.microsoft.com/office/drawing/2014/main" id="{BDA06444-0BA8-4E1D-9132-67270BD607FC}"/>
+                <a16:creationId xmlns:a16="http://schemas.microsoft.com/office/drawing/2014/main" id="{674F7A26-4C2B-4688-A110-A7FDEDC52FC9}"/>
               </a:ext>
             </a:extLst>
           </p:cNvPr>
@@ -13864,7 +13864,7 @@
           <p:cNvPr id="4" name="">
             <a:extLst xmlns:a="http://schemas.openxmlformats.org/drawingml/2006/main">
               <a:ext uri="{FF2B5EF4-FFF2-40B4-BE49-F238E27FC236}">
-                <a16:creationId xmlns:a16="http://schemas.microsoft.com/office/drawing/2014/main" id="{726C40D7-C265-49FC-B140-C79FD128E386}"/>
+                <a16:creationId xmlns:a16="http://schemas.microsoft.com/office/drawing/2014/main" id="{A7C2C5E7-AB7F-4846-801E-19B2D750E1B1}"/>
               </a:ext>
             </a:extLst>
           </p:cNvPr>
@@ -13914,7 +13914,7 @@
           <p:cNvPr id="5" name="">
             <a:extLst xmlns:a="http://schemas.openxmlformats.org/drawingml/2006/main">
               <a:ext uri="{FF2B5EF4-FFF2-40B4-BE49-F238E27FC236}">
-                <a16:creationId xmlns:a16="http://schemas.microsoft.com/office/drawing/2014/main" id="{C4967B72-4E43-4C9C-BEB3-6BD05B053D96}"/>
+                <a16:creationId xmlns:a16="http://schemas.microsoft.com/office/drawing/2014/main" id="{9A0FD56B-C0D9-4257-AC37-32032673DBD8}"/>
               </a:ext>
             </a:extLst>
           </p:cNvPr>
@@ -13964,7 +13964,7 @@
           <p:cNvPr id="6" name="">
             <a:extLst xmlns:a="http://schemas.openxmlformats.org/drawingml/2006/main">
               <a:ext uri="{FF2B5EF4-FFF2-40B4-BE49-F238E27FC236}">
-                <a16:creationId xmlns:a16="http://schemas.microsoft.com/office/drawing/2014/main" id="{FE8093C2-29D7-4FCE-A495-51A3A4C62DEC}"/>
+                <a16:creationId xmlns:a16="http://schemas.microsoft.com/office/drawing/2014/main" id="{256BB591-7351-410F-916E-8E1705F4A4CE}"/>
               </a:ext>
             </a:extLst>
           </p:cNvPr>
@@ -14014,7 +14014,7 @@
           <p:cNvPr id="7" name="">
             <a:extLst xmlns:a="http://schemas.openxmlformats.org/drawingml/2006/main">
               <a:ext uri="{FF2B5EF4-FFF2-40B4-BE49-F238E27FC236}">
-                <a16:creationId xmlns:a16="http://schemas.microsoft.com/office/drawing/2014/main" id="{C09C8A86-AA2A-43CF-975F-3D22DE37FA2D}"/>
+                <a16:creationId xmlns:a16="http://schemas.microsoft.com/office/drawing/2014/main" id="{F851D72E-D605-4CAE-A2B0-D8DC00647AB5}"/>
               </a:ext>
             </a:extLst>
           </p:cNvPr>
@@ -14049,7 +14049,7 @@
           <p:cNvPr id="8" name="">
             <a:extLst xmlns:a="http://schemas.openxmlformats.org/drawingml/2006/main">
               <a:ext uri="{FF2B5EF4-FFF2-40B4-BE49-F238E27FC236}">
-                <a16:creationId xmlns:a16="http://schemas.microsoft.com/office/drawing/2014/main" id="{945C032A-1334-4A7A-95F3-774B05CAEB9D}"/>
+                <a16:creationId xmlns:a16="http://schemas.microsoft.com/office/drawing/2014/main" id="{27A83D16-3D7F-4239-8737-B3450731D2A3}"/>
               </a:ext>
             </a:extLst>
           </p:cNvPr>
@@ -14099,7 +14099,7 @@
           <p:cNvPr id="9" name="">
             <a:extLst xmlns:a="http://schemas.openxmlformats.org/drawingml/2006/main">
               <a:ext uri="{FF2B5EF4-FFF2-40B4-BE49-F238E27FC236}">
-                <a16:creationId xmlns:a16="http://schemas.microsoft.com/office/drawing/2014/main" id="{93F1658A-E3D5-48BD-8AD4-69C3E9245240}"/>
+                <a16:creationId xmlns:a16="http://schemas.microsoft.com/office/drawing/2014/main" id="{BDEFA8B3-18DC-4701-8C2E-D17BEC0B7D71}"/>
               </a:ext>
             </a:extLst>
           </p:cNvPr>
@@ -14149,7 +14149,7 @@
           <p:cNvPr id="10" name="">
             <a:extLst xmlns:a="http://schemas.openxmlformats.org/drawingml/2006/main">
               <a:ext uri="{FF2B5EF4-FFF2-40B4-BE49-F238E27FC236}">
-                <a16:creationId xmlns:a16="http://schemas.microsoft.com/office/drawing/2014/main" id="{3C7B5C7A-DE1E-4063-882C-9B1E46D0011D}"/>
+                <a16:creationId xmlns:a16="http://schemas.microsoft.com/office/drawing/2014/main" id="{B9CB6C27-0BB9-4F72-A88A-95E3819F8002}"/>
               </a:ext>
             </a:extLst>
           </p:cNvPr>
@@ -14184,7 +14184,7 @@
           <p:cNvPr id="11" name="">
             <a:extLst xmlns:a="http://schemas.openxmlformats.org/drawingml/2006/main">
               <a:ext uri="{FF2B5EF4-FFF2-40B4-BE49-F238E27FC236}">
-                <a16:creationId xmlns:a16="http://schemas.microsoft.com/office/drawing/2014/main" id="{55E393B3-3076-4B2A-BD29-9963B6BC21C4}"/>
+                <a16:creationId xmlns:a16="http://schemas.microsoft.com/office/drawing/2014/main" id="{8D853351-1176-4030-9DC5-2D3FDE767BF0}"/>
               </a:ext>
             </a:extLst>
           </p:cNvPr>
@@ -14234,7 +14234,7 @@
           <p:cNvPr id="12" name="">
             <a:extLst xmlns:a="http://schemas.openxmlformats.org/drawingml/2006/main">
               <a:ext uri="{FF2B5EF4-FFF2-40B4-BE49-F238E27FC236}">
-                <a16:creationId xmlns:a16="http://schemas.microsoft.com/office/drawing/2014/main" id="{97BF5C62-BBC9-42C8-B631-5BDC52513EC8}"/>
+                <a16:creationId xmlns:a16="http://schemas.microsoft.com/office/drawing/2014/main" id="{45A910A9-9F4F-4A6F-B385-FFF6879EF1CE}"/>
               </a:ext>
             </a:extLst>
           </p:cNvPr>
@@ -14284,7 +14284,7 @@
           <p:cNvPr id="13" name="">
             <a:extLst xmlns:a="http://schemas.openxmlformats.org/drawingml/2006/main">
               <a:ext uri="{FF2B5EF4-FFF2-40B4-BE49-F238E27FC236}">
-                <a16:creationId xmlns:a16="http://schemas.microsoft.com/office/drawing/2014/main" id="{A2609563-4CA9-44AC-859D-3DDA7522E379}"/>
+                <a16:creationId xmlns:a16="http://schemas.microsoft.com/office/drawing/2014/main" id="{2B24BC62-2591-42F8-B54E-77DDDCC0EF8C}"/>
               </a:ext>
             </a:extLst>
           </p:cNvPr>
@@ -14319,7 +14319,7 @@
           <p:cNvPr id="14" name="">
             <a:extLst xmlns:a="http://schemas.openxmlformats.org/drawingml/2006/main">
               <a:ext uri="{FF2B5EF4-FFF2-40B4-BE49-F238E27FC236}">
-                <a16:creationId xmlns:a16="http://schemas.microsoft.com/office/drawing/2014/main" id="{7C358AFF-6856-4618-B40E-BF8151F01E75}"/>
+                <a16:creationId xmlns:a16="http://schemas.microsoft.com/office/drawing/2014/main" id="{F3E40C23-1557-43B2-AAE5-AD7B5151D6C1}"/>
               </a:ext>
             </a:extLst>
           </p:cNvPr>
@@ -14369,7 +14369,7 @@
           <p:cNvPr id="15" name="">
             <a:extLst xmlns:a="http://schemas.openxmlformats.org/drawingml/2006/main">
               <a:ext uri="{FF2B5EF4-FFF2-40B4-BE49-F238E27FC236}">
-                <a16:creationId xmlns:a16="http://schemas.microsoft.com/office/drawing/2014/main" id="{A0CC302A-03BD-405E-8F38-F09C723E5639}"/>
+                <a16:creationId xmlns:a16="http://schemas.microsoft.com/office/drawing/2014/main" id="{3B8083A8-9C1B-4A1B-8F69-ECCA8003D0E4}"/>
               </a:ext>
             </a:extLst>
           </p:cNvPr>
@@ -14419,7 +14419,7 @@
           <p:cNvPr id="16" name="">
             <a:extLst xmlns:a="http://schemas.openxmlformats.org/drawingml/2006/main">
               <a:ext uri="{FF2B5EF4-FFF2-40B4-BE49-F238E27FC236}">
-                <a16:creationId xmlns:a16="http://schemas.microsoft.com/office/drawing/2014/main" id="{B14D4970-9A7F-45A1-AA9E-B77EFD175290}"/>
+                <a16:creationId xmlns:a16="http://schemas.microsoft.com/office/drawing/2014/main" id="{9DAF324F-88FF-40AA-83F1-3DFB02CE9368}"/>
               </a:ext>
             </a:extLst>
           </p:cNvPr>
@@ -14454,7 +14454,7 @@
           <p:cNvPr id="17" name="">
             <a:extLst xmlns:a="http://schemas.openxmlformats.org/drawingml/2006/main">
               <a:ext uri="{FF2B5EF4-FFF2-40B4-BE49-F238E27FC236}">
-                <a16:creationId xmlns:a16="http://schemas.microsoft.com/office/drawing/2014/main" id="{E868B9A8-28B2-4887-B4D0-7F85BA214AC1}"/>
+                <a16:creationId xmlns:a16="http://schemas.microsoft.com/office/drawing/2014/main" id="{EC112BED-12E2-482F-AAF0-EB027E01B78A}"/>
               </a:ext>
             </a:extLst>
           </p:cNvPr>
@@ -14504,7 +14504,7 @@
           <p:cNvPr id="18" name="">
             <a:extLst xmlns:a="http://schemas.openxmlformats.org/drawingml/2006/main">
               <a:ext uri="{FF2B5EF4-FFF2-40B4-BE49-F238E27FC236}">
-                <a16:creationId xmlns:a16="http://schemas.microsoft.com/office/drawing/2014/main" id="{6EDF328A-18DD-44FB-850E-9677FC4C2D48}"/>
+                <a16:creationId xmlns:a16="http://schemas.microsoft.com/office/drawing/2014/main" id="{A0AE1DD0-EE78-457D-85EE-7193FBE6E8F8}"/>
               </a:ext>
             </a:extLst>
           </p:cNvPr>
@@ -14554,7 +14554,7 @@
           <p:cNvPr id="19" name="">
             <a:extLst xmlns:a="http://schemas.openxmlformats.org/drawingml/2006/main">
               <a:ext uri="{FF2B5EF4-FFF2-40B4-BE49-F238E27FC236}">
-                <a16:creationId xmlns:a16="http://schemas.microsoft.com/office/drawing/2014/main" id="{B259E85E-CB55-497D-8BDC-B07CED4D00D0}"/>
+                <a16:creationId xmlns:a16="http://schemas.microsoft.com/office/drawing/2014/main" id="{04CFBD1F-33CE-426C-A4F8-9CF703CC872C}"/>
               </a:ext>
             </a:extLst>
           </p:cNvPr>
@@ -14604,7 +14604,7 @@
           <p:cNvPr id="20" name="">
             <a:extLst xmlns:a="http://schemas.openxmlformats.org/drawingml/2006/main">
               <a:ext uri="{FF2B5EF4-FFF2-40B4-BE49-F238E27FC236}">
-                <a16:creationId xmlns:a16="http://schemas.microsoft.com/office/drawing/2014/main" id="{D00F5B8C-C128-4FEB-BC27-34BD7209639F}"/>
+                <a16:creationId xmlns:a16="http://schemas.microsoft.com/office/drawing/2014/main" id="{A29A1179-1B19-4BEA-935A-D8BE17C2270A}"/>
               </a:ext>
             </a:extLst>
           </p:cNvPr>
@@ -14654,7 +14654,7 @@
           <p:cNvPr id="21" name="">
             <a:extLst xmlns:a="http://schemas.openxmlformats.org/drawingml/2006/main">
               <a:ext uri="{FF2B5EF4-FFF2-40B4-BE49-F238E27FC236}">
-                <a16:creationId xmlns:a16="http://schemas.microsoft.com/office/drawing/2014/main" id="{B9FDCC00-E4E1-4B96-8EB8-C8243ACB64F6}"/>
+                <a16:creationId xmlns:a16="http://schemas.microsoft.com/office/drawing/2014/main" id="{561D11C4-9A15-4630-8C9E-49CA38F8907B}"/>
               </a:ext>
             </a:extLst>
           </p:cNvPr>
@@ -14704,7 +14704,7 @@
           <p:cNvPr id="22" name="">
             <a:extLst xmlns:a="http://schemas.openxmlformats.org/drawingml/2006/main">
               <a:ext uri="{FF2B5EF4-FFF2-40B4-BE49-F238E27FC236}">
-                <a16:creationId xmlns:a16="http://schemas.microsoft.com/office/drawing/2014/main" id="{E65AD1BF-151E-43EB-9602-3FEADF1D2A09}"/>
+                <a16:creationId xmlns:a16="http://schemas.microsoft.com/office/drawing/2014/main" id="{7DDAA2DA-561D-43E0-9887-5F65D1344EBC}"/>
               </a:ext>
             </a:extLst>
           </p:cNvPr>
@@ -14752,7 +14752,7 @@
     </p:spTree>
     <p:extLst>
       <p:ext uri="{BB962C8B-B14F-4D97-AF65-F5344CB8AC3E}">
-        <p14:creationId xmlns:p14="http://schemas.microsoft.com/office/powerpoint/2010/main" val="1152038297"/>
+        <p14:creationId xmlns:p14="http://schemas.microsoft.com/office/powerpoint/2010/main" val="1538880221"/>
       </p:ext>
     </p:extLst>
   </p:cSld>

</xml_diff>